<commit_message>
Update A/B deck with IG insights and Dcard comment stats
Co-Authored-By: Claude Sonnet 5.5 <noreply@anthropic.com>
Claude-Session: https://claude.ai/code/session_01YWYmCoF2kfC3GxD29xN2Db
</commit_message>
<xml_diff>
--- a/deliverables/CMC_10月_AB任務簡報.pptx
+++ b/deliverables/CMC_10月_AB任務簡報.pptx
@@ -142,7 +142,7 @@
                 </a:solidFill>
                 <a:latin typeface="Arial"/>
               </a:rPr>
-              <a:t>求職時在意因素(%)</a:t>
+              <a:t>案例 1 留言提及的福利(則,n=17)</a:t>
             </a:r>
           </a:p>
         </c:rich>
@@ -166,7 +166,7 @@
               <c:strCache>
                 <c:ptCount val="1"/>
                 <c:pt idx="0">
-                  <c:v>比例</c:v>
+                  <c:v>提及則數</c:v>
                 </c:pt>
               </c:strCache>
             </c:strRef>
@@ -179,7 +179,7 @@
           </c:spPr>
           <c:invertIfNegative val="0"/>
           <c:dLbls>
-            <c:numFmt formatCode="0&quot;%&quot;" sourceLinked="0"/>
+            <c:numFmt formatCode="#,##0" sourceLinked="0"/>
             <c:txPr>
               <a:bodyPr/>
               <a:lstStyle/>
@@ -204,12 +204,30 @@
           </c:dLbls>
           <c:cat>
             <c:multiLvlStrRef>
-              <c:f>Sheet1!$A$2:$A$2</c:f>
+              <c:f>Sheet1!$A$2:$A$8</c:f>
               <c:multiLvlStrCache>
-                <c:ptCount val="1"/>
+                <c:ptCount val="7"/>
                 <c:lvl>
                   <c:pt idx="0">
-                    <c:v>薪資條件符合期待</c:v>
+                    <c:v>體檢</c:v>
+                  </c:pt>
+                  <c:pt idx="1">
+                    <c:v>停車位</c:v>
+                  </c:pt>
+                  <c:pt idx="2">
+                    <c:v>加班費/準時下班</c:v>
+                  </c:pt>
+                  <c:pt idx="3">
+                    <c:v>休假</c:v>
+                  </c:pt>
+                  <c:pt idx="4">
+                    <c:v>彈性/遠端</c:v>
+                  </c:pt>
+                  <c:pt idx="5">
+                    <c:v>餐飲/零食/設備</c:v>
+                  </c:pt>
+                  <c:pt idx="6">
+                    <c:v>薪資/獎金/年終</c:v>
                   </c:pt>
                 </c:lvl>
               </c:multiLvlStrCache>
@@ -217,19 +235,37 @@
           </c:cat>
           <c:val>
             <c:numRef>
-              <c:f>Sheet1!$B$2:$B$2</c:f>
+              <c:f>Sheet1!$B$2:$B$8</c:f>
               <c:numCache>
                 <c:formatCode>General</c:formatCode>
-                <c:ptCount val="1"/>
+                <c:ptCount val="7"/>
                 <c:pt idx="0">
-                  <c:v>64</c:v>
+                  <c:v>1</c:v>
+                </c:pt>
+                <c:pt idx="1">
+                  <c:v>2</c:v>
+                </c:pt>
+                <c:pt idx="2">
+                  <c:v>3</c:v>
+                </c:pt>
+                <c:pt idx="3">
+                  <c:v>3</c:v>
+                </c:pt>
+                <c:pt idx="4">
+                  <c:v>3</c:v>
+                </c:pt>
+                <c:pt idx="5">
+                  <c:v>5</c:v>
+                </c:pt>
+                <c:pt idx="6">
+                  <c:v>14</c:v>
                 </c:pt>
               </c:numCache>
             </c:numRef>
           </c:val>
         </c:ser>
         <c:dLbls>
-          <c:numFmt formatCode="0&quot;%&quot;" sourceLinked="0"/>
+          <c:numFmt formatCode="#,##0" sourceLinked="0"/>
           <c:txPr>
             <a:bodyPr/>
             <a:lstStyle/>
@@ -303,7 +339,7 @@
         <c:axId val="2094734552"/>
         <c:scaling>
           <c:orientation val="minMax"/>
-          <c:max val="100"/>
+          <c:max val="16"/>
           <c:min val="0"/>
         </c:scaling>
         <c:delete val="0"/>
@@ -2804,7 +2840,7 @@
                 <a:ea typeface="Calibri" pitchFamily="34" charset="-122"/>
                 <a:cs typeface="Calibri" pitchFamily="34" charset="-120"/>
               </a:rPr>
-              <a:t>平台:Dcard / Threads</a:t>
+              <a:t>平台:Dcard 工作版(2 篇貼文)</a:t>
             </a:r>
             <a:endParaRPr lang="en-US" sz="1400" dirty="0"/>
           </a:p>
@@ -4312,12 +4348,12 @@
         </p:nvSpPr>
         <p:spPr>
           <a:xfrm>
-            <a:off x="457200" y="1188720"/>
-            <a:ext cx="1920240" cy="1737360"/>
+            <a:off x="457200" y="1051560"/>
+            <a:ext cx="1783080" cy="1417320"/>
           </a:xfrm>
           <a:prstGeom prst="roundRect">
             <a:avLst>
-              <a:gd name="adj" fmla="val 4211"/>
+              <a:gd name="adj" fmla="val 5161"/>
             </a:avLst>
           </a:prstGeom>
           <a:solidFill>
@@ -4339,8 +4375,8 @@
         </p:nvSpPr>
         <p:spPr>
           <a:xfrm>
-            <a:off x="457200" y="1371600"/>
-            <a:ext cx="1920240" cy="822960"/>
+            <a:off x="457200" y="1188720"/>
+            <a:ext cx="1783080" cy="731520"/>
           </a:xfrm>
           <a:prstGeom prst="rect">
             <a:avLst/>
@@ -4356,7 +4392,7 @@
               <a:buNone/>
             </a:pPr>
             <a:r>
-              <a:rPr lang="en-US" sz="2800" b="1" dirty="0">
+              <a:rPr lang="en-US" sz="3400" b="1" dirty="0">
                 <a:solidFill>
                   <a:srgbClr val="C8102E"/>
                 </a:solidFill>
@@ -4364,9 +4400,9 @@
                 <a:ea typeface="Calibri" pitchFamily="34" charset="-122"/>
                 <a:cs typeface="Calibri" pitchFamily="34" charset="-120"/>
               </a:rPr>
-              <a:t>【待補】</a:t>
-            </a:r>
-            <a:endParaRPr lang="en-US" sz="2800" dirty="0"/>
+              <a:t>1,176</a:t>
+            </a:r>
+            <a:endParaRPr lang="en-US" sz="3400" dirty="0"/>
           </a:p>
         </p:txBody>
       </p:sp>
@@ -4378,8 +4414,8 @@
         </p:nvSpPr>
         <p:spPr>
           <a:xfrm>
-            <a:off x="457200" y="2286000"/>
-            <a:ext cx="1920240" cy="457200"/>
+            <a:off x="457200" y="1920240"/>
+            <a:ext cx="1783080" cy="365760"/>
           </a:xfrm>
           <a:prstGeom prst="rect">
             <a:avLst/>
@@ -4395,7 +4431,7 @@
               <a:buNone/>
             </a:pPr>
             <a:r>
-              <a:rPr lang="en-US" sz="1600" b="1" dirty="0">
+              <a:rPr lang="en-US" sz="1500" b="1" dirty="0">
                 <a:solidFill>
                   <a:srgbClr val="1B2A41"/>
                 </a:solidFill>
@@ -4403,9 +4439,9 @@
                 <a:ea typeface="Calibri" pitchFamily="34" charset="-122"/>
                 <a:cs typeface="Calibri" pitchFamily="34" charset="-120"/>
               </a:rPr>
-              <a:t>觸及數</a:t>
-            </a:r>
-            <a:endParaRPr lang="en-US" sz="1600" dirty="0"/>
+              <a:t>觀看次數</a:t>
+            </a:r>
+            <a:endParaRPr lang="en-US" sz="1500" dirty="0"/>
           </a:p>
         </p:txBody>
       </p:sp>
@@ -4417,12 +4453,12 @@
         </p:nvSpPr>
         <p:spPr>
           <a:xfrm>
-            <a:off x="2542032" y="1188720"/>
-            <a:ext cx="1920240" cy="1737360"/>
+            <a:off x="2377440" y="1051560"/>
+            <a:ext cx="1783080" cy="1417320"/>
           </a:xfrm>
           <a:prstGeom prst="roundRect">
             <a:avLst>
-              <a:gd name="adj" fmla="val 4211"/>
+              <a:gd name="adj" fmla="val 5161"/>
             </a:avLst>
           </a:prstGeom>
           <a:solidFill>
@@ -4444,8 +4480,8 @@
         </p:nvSpPr>
         <p:spPr>
           <a:xfrm>
-            <a:off x="2542032" y="1371600"/>
-            <a:ext cx="1920240" cy="822960"/>
+            <a:off x="2377440" y="1188720"/>
+            <a:ext cx="1783080" cy="731520"/>
           </a:xfrm>
           <a:prstGeom prst="rect">
             <a:avLst/>
@@ -4461,7 +4497,7 @@
               <a:buNone/>
             </a:pPr>
             <a:r>
-              <a:rPr lang="en-US" sz="2800" b="1" dirty="0">
+              <a:rPr lang="en-US" sz="3400" b="1" dirty="0">
                 <a:solidFill>
                   <a:srgbClr val="C8102E"/>
                 </a:solidFill>
@@ -4469,9 +4505,9 @@
                 <a:ea typeface="Calibri" pitchFamily="34" charset="-122"/>
                 <a:cs typeface="Calibri" pitchFamily="34" charset="-120"/>
               </a:rPr>
-              <a:t>【待補】</a:t>
-            </a:r>
-            <a:endParaRPr lang="en-US" sz="2800" dirty="0"/>
+              <a:t>551</a:t>
+            </a:r>
+            <a:endParaRPr lang="en-US" sz="3400" dirty="0"/>
           </a:p>
         </p:txBody>
       </p:sp>
@@ -4483,8 +4519,8 @@
         </p:nvSpPr>
         <p:spPr>
           <a:xfrm>
-            <a:off x="2542032" y="2286000"/>
-            <a:ext cx="1920240" cy="457200"/>
+            <a:off x="2377440" y="1920240"/>
+            <a:ext cx="1783080" cy="365760"/>
           </a:xfrm>
           <a:prstGeom prst="rect">
             <a:avLst/>
@@ -4500,7 +4536,7 @@
               <a:buNone/>
             </a:pPr>
             <a:r>
-              <a:rPr lang="en-US" sz="1600" b="1" dirty="0">
+              <a:rPr lang="en-US" sz="1500" b="1" dirty="0">
                 <a:solidFill>
                   <a:srgbClr val="1B2A41"/>
                 </a:solidFill>
@@ -4508,9 +4544,9 @@
                 <a:ea typeface="Calibri" pitchFamily="34" charset="-122"/>
                 <a:cs typeface="Calibri" pitchFamily="34" charset="-120"/>
               </a:rPr>
-              <a:t>互動數</a:t>
-            </a:r>
-            <a:endParaRPr lang="en-US" sz="1600" dirty="0"/>
+              <a:t>觸及人數</a:t>
+            </a:r>
+            <a:endParaRPr lang="en-US" sz="1500" dirty="0"/>
           </a:p>
         </p:txBody>
       </p:sp>
@@ -4522,12 +4558,12 @@
         </p:nvSpPr>
         <p:spPr>
           <a:xfrm>
-            <a:off x="4626864" y="1188720"/>
-            <a:ext cx="1920240" cy="1737360"/>
+            <a:off x="4297680" y="1051560"/>
+            <a:ext cx="1783080" cy="1417320"/>
           </a:xfrm>
           <a:prstGeom prst="roundRect">
             <a:avLst>
-              <a:gd name="adj" fmla="val 4211"/>
+              <a:gd name="adj" fmla="val 5161"/>
             </a:avLst>
           </a:prstGeom>
           <a:solidFill>
@@ -4549,8 +4585,8 @@
         </p:nvSpPr>
         <p:spPr>
           <a:xfrm>
-            <a:off x="4626864" y="1371600"/>
-            <a:ext cx="1920240" cy="822960"/>
+            <a:off x="4297680" y="1188720"/>
+            <a:ext cx="1783080" cy="731520"/>
           </a:xfrm>
           <a:prstGeom prst="rect">
             <a:avLst/>
@@ -4566,7 +4602,7 @@
               <a:buNone/>
             </a:pPr>
             <a:r>
-              <a:rPr lang="en-US" sz="2800" b="1" dirty="0">
+              <a:rPr lang="en-US" sz="3400" b="1" dirty="0">
                 <a:solidFill>
                   <a:srgbClr val="C8102E"/>
                 </a:solidFill>
@@ -4574,9 +4610,9 @@
                 <a:ea typeface="Calibri" pitchFamily="34" charset="-122"/>
                 <a:cs typeface="Calibri" pitchFamily="34" charset="-120"/>
               </a:rPr>
-              <a:t>【待補】</a:t>
-            </a:r>
-            <a:endParaRPr lang="en-US" sz="2800" dirty="0"/>
+              <a:t>36</a:t>
+            </a:r>
+            <a:endParaRPr lang="en-US" sz="3400" dirty="0"/>
           </a:p>
         </p:txBody>
       </p:sp>
@@ -4588,8 +4624,8 @@
         </p:nvSpPr>
         <p:spPr>
           <a:xfrm>
-            <a:off x="4626864" y="2286000"/>
-            <a:ext cx="1920240" cy="457200"/>
+            <a:off x="4297680" y="1920240"/>
+            <a:ext cx="1783080" cy="365760"/>
           </a:xfrm>
           <a:prstGeom prst="rect">
             <a:avLst/>
@@ -4605,7 +4641,7 @@
               <a:buNone/>
             </a:pPr>
             <a:r>
-              <a:rPr lang="en-US" sz="1600" b="1" dirty="0">
+              <a:rPr lang="en-US" sz="1500" b="1" dirty="0">
                 <a:solidFill>
                   <a:srgbClr val="1B2A41"/>
                 </a:solidFill>
@@ -4613,9 +4649,9 @@
                 <a:ea typeface="Calibri" pitchFamily="34" charset="-122"/>
                 <a:cs typeface="Calibri" pitchFamily="34" charset="-120"/>
               </a:rPr>
-              <a:t>留言數</a:t>
-            </a:r>
-            <a:endParaRPr lang="en-US" sz="1600" dirty="0"/>
+              <a:t>互動數</a:t>
+            </a:r>
+            <a:endParaRPr lang="en-US" sz="1500" dirty="0"/>
           </a:p>
         </p:txBody>
       </p:sp>
@@ -4627,12 +4663,12 @@
         </p:nvSpPr>
         <p:spPr>
           <a:xfrm>
-            <a:off x="6711696" y="1188720"/>
-            <a:ext cx="1920240" cy="1737360"/>
+            <a:off x="457200" y="2651760"/>
+            <a:ext cx="1783080" cy="1417320"/>
           </a:xfrm>
           <a:prstGeom prst="roundRect">
             <a:avLst>
-              <a:gd name="adj" fmla="val 4211"/>
+              <a:gd name="adj" fmla="val 5161"/>
             </a:avLst>
           </a:prstGeom>
           <a:solidFill>
@@ -4654,8 +4690,8 @@
         </p:nvSpPr>
         <p:spPr>
           <a:xfrm>
-            <a:off x="6711696" y="1371600"/>
-            <a:ext cx="1920240" cy="822960"/>
+            <a:off x="457200" y="2788920"/>
+            <a:ext cx="1783080" cy="731520"/>
           </a:xfrm>
           <a:prstGeom prst="rect">
             <a:avLst/>
@@ -4671,7 +4707,7 @@
               <a:buNone/>
             </a:pPr>
             <a:r>
-              <a:rPr lang="en-US" sz="2800" b="1" dirty="0">
+              <a:rPr lang="en-US" sz="3400" b="1" dirty="0">
                 <a:solidFill>
                   <a:srgbClr val="C8102E"/>
                 </a:solidFill>
@@ -4679,9 +4715,9 @@
                 <a:ea typeface="Calibri" pitchFamily="34" charset="-122"/>
                 <a:cs typeface="Calibri" pitchFamily="34" charset="-120"/>
               </a:rPr>
-              <a:t>【待補】</a:t>
-            </a:r>
-            <a:endParaRPr lang="en-US" sz="2800" dirty="0"/>
+              <a:t>34</a:t>
+            </a:r>
+            <a:endParaRPr lang="en-US" sz="3400" dirty="0"/>
           </a:p>
         </p:txBody>
       </p:sp>
@@ -4693,8 +4729,8 @@
         </p:nvSpPr>
         <p:spPr>
           <a:xfrm>
-            <a:off x="6711696" y="2286000"/>
-            <a:ext cx="1920240" cy="457200"/>
+            <a:off x="457200" y="3520440"/>
+            <a:ext cx="1783080" cy="365760"/>
           </a:xfrm>
           <a:prstGeom prst="rect">
             <a:avLst/>
@@ -4710,7 +4746,7 @@
               <a:buNone/>
             </a:pPr>
             <a:r>
-              <a:rPr lang="en-US" sz="1600" b="1" dirty="0">
+              <a:rPr lang="en-US" sz="1500" b="1" dirty="0">
                 <a:solidFill>
                   <a:srgbClr val="1B2A41"/>
                 </a:solidFill>
@@ -4720,7 +4756,7 @@
               </a:rPr>
               <a:t>按讚數</a:t>
             </a:r>
-            <a:endParaRPr lang="en-US" sz="1600" dirty="0"/>
+            <a:endParaRPr lang="en-US" sz="1500" dirty="0"/>
           </a:p>
         </p:txBody>
       </p:sp>
@@ -4732,20 +4768,22 @@
         </p:nvSpPr>
         <p:spPr>
           <a:xfrm>
-            <a:off x="457200" y="3154680"/>
-            <a:ext cx="8229600" cy="1463040"/>
-          </a:xfrm>
-          <a:prstGeom prst="rect">
-            <a:avLst/>
+            <a:off x="2377440" y="2651760"/>
+            <a:ext cx="1783080" cy="1417320"/>
+          </a:xfrm>
+          <a:prstGeom prst="roundRect">
+            <a:avLst>
+              <a:gd name="adj" fmla="val 5161"/>
+            </a:avLst>
           </a:prstGeom>
           <a:solidFill>
-            <a:srgbClr val="FFFFFF"/>
+            <a:srgbClr val="F3F5F8"/>
           </a:solidFill>
-          <a:ln w="15875">
+          <a:ln w="12700">
             <a:solidFill>
-              <a:srgbClr val="9AA3B2"/>
+              <a:srgbClr val="F3F5F8"/>
             </a:solidFill>
-            <a:prstDash val="dash"/>
+            <a:prstDash val="solid"/>
           </a:ln>
         </p:spPr>
       </p:sp>
@@ -4757,24 +4795,207 @@
         </p:nvSpPr>
         <p:spPr>
           <a:xfrm>
-            <a:off x="457200" y="3154680"/>
-            <a:ext cx="8229600" cy="1463040"/>
-          </a:xfrm>
-          <a:prstGeom prst="rect">
-            <a:avLst/>
-          </a:prstGeom>
-          <a:noFill/>
-          <a:ln/>
-        </p:spPr>
-        <p:txBody>
-          <a:bodyPr wrap="square" rtlCol="0" anchor="ctr"/>
+            <a:off x="2377440" y="2788920"/>
+            <a:ext cx="1783080" cy="731520"/>
+          </a:xfrm>
+          <a:prstGeom prst="rect">
+            <a:avLst/>
+          </a:prstGeom>
+          <a:noFill/>
+          <a:ln/>
+        </p:spPr>
+        <p:txBody>
+          <a:bodyPr wrap="square" lIns="0" tIns="0" rIns="0" bIns="0" rtlCol="0" anchor="ctr"/>
           <a:lstStyle/>
           <a:p>
             <a:pPr algn="ctr" indent="0" marL="0">
               <a:buNone/>
             </a:pPr>
             <a:r>
-              <a:rPr lang="en-US" sz="1400" dirty="0">
+              <a:rPr lang="en-US" sz="3400" b="1" dirty="0">
+                <a:solidFill>
+                  <a:srgbClr val="C8102E"/>
+                </a:solidFill>
+                <a:latin typeface="Calibri" pitchFamily="34" charset="0"/>
+                <a:ea typeface="Calibri" pitchFamily="34" charset="-122"/>
+                <a:cs typeface="Calibri" pitchFamily="34" charset="-120"/>
+              </a:rPr>
+              <a:t>1</a:t>
+            </a:r>
+            <a:endParaRPr lang="en-US" sz="3400" dirty="0"/>
+          </a:p>
+        </p:txBody>
+      </p:sp>
+      <p:sp>
+        <p:nvSpPr>
+          <p:cNvPr id="19" name="Text 17"/>
+          <p:cNvSpPr txBox="1"/>
+          <p:nvPr/>
+        </p:nvSpPr>
+        <p:spPr>
+          <a:xfrm>
+            <a:off x="2377440" y="3520440"/>
+            <a:ext cx="1783080" cy="365760"/>
+          </a:xfrm>
+          <a:prstGeom prst="rect">
+            <a:avLst/>
+          </a:prstGeom>
+          <a:noFill/>
+          <a:ln/>
+        </p:spPr>
+        <p:txBody>
+          <a:bodyPr wrap="square" lIns="0" tIns="0" rIns="0" bIns="0" rtlCol="0" anchor="ctr"/>
+          <a:lstStyle/>
+          <a:p>
+            <a:pPr algn="ctr" indent="0" marL="0">
+              <a:buNone/>
+            </a:pPr>
+            <a:r>
+              <a:rPr lang="en-US" sz="1500" b="1" dirty="0">
+                <a:solidFill>
+                  <a:srgbClr val="1B2A41"/>
+                </a:solidFill>
+                <a:latin typeface="Calibri" pitchFamily="34" charset="0"/>
+                <a:ea typeface="Calibri" pitchFamily="34" charset="-122"/>
+                <a:cs typeface="Calibri" pitchFamily="34" charset="-120"/>
+              </a:rPr>
+              <a:t>留言數</a:t>
+            </a:r>
+            <a:endParaRPr lang="en-US" sz="1500" dirty="0"/>
+          </a:p>
+        </p:txBody>
+      </p:sp>
+      <p:sp>
+        <p:nvSpPr>
+          <p:cNvPr id="20" name="Shape 18"/>
+          <p:cNvSpPr/>
+          <p:nvPr/>
+        </p:nvSpPr>
+        <p:spPr>
+          <a:xfrm>
+            <a:off x="4297680" y="2651760"/>
+            <a:ext cx="1783080" cy="1417320"/>
+          </a:xfrm>
+          <a:prstGeom prst="roundRect">
+            <a:avLst>
+              <a:gd name="adj" fmla="val 5161"/>
+            </a:avLst>
+          </a:prstGeom>
+          <a:solidFill>
+            <a:srgbClr val="F3F5F8"/>
+          </a:solidFill>
+          <a:ln w="12700">
+            <a:solidFill>
+              <a:srgbClr val="F3F5F8"/>
+            </a:solidFill>
+            <a:prstDash val="solid"/>
+          </a:ln>
+        </p:spPr>
+      </p:sp>
+      <p:sp>
+        <p:nvSpPr>
+          <p:cNvPr id="21" name="Text 19"/>
+          <p:cNvSpPr txBox="1"/>
+          <p:nvPr/>
+        </p:nvSpPr>
+        <p:spPr>
+          <a:xfrm>
+            <a:off x="4297680" y="2788920"/>
+            <a:ext cx="1783080" cy="731520"/>
+          </a:xfrm>
+          <a:prstGeom prst="rect">
+            <a:avLst/>
+          </a:prstGeom>
+          <a:noFill/>
+          <a:ln/>
+        </p:spPr>
+        <p:txBody>
+          <a:bodyPr wrap="square" lIns="0" tIns="0" rIns="0" bIns="0" rtlCol="0" anchor="ctr"/>
+          <a:lstStyle/>
+          <a:p>
+            <a:pPr algn="ctr" indent="0" marL="0">
+              <a:buNone/>
+            </a:pPr>
+            <a:r>
+              <a:rPr lang="en-US" sz="3400" b="1" dirty="0">
+                <a:solidFill>
+                  <a:srgbClr val="C8102E"/>
+                </a:solidFill>
+                <a:latin typeface="Calibri" pitchFamily="34" charset="0"/>
+                <a:ea typeface="Calibri" pitchFamily="34" charset="-122"/>
+                <a:cs typeface="Calibri" pitchFamily="34" charset="-120"/>
+              </a:rPr>
+              <a:t>1</a:t>
+            </a:r>
+            <a:endParaRPr lang="en-US" sz="3400" dirty="0"/>
+          </a:p>
+        </p:txBody>
+      </p:sp>
+      <p:sp>
+        <p:nvSpPr>
+          <p:cNvPr id="22" name="Text 20"/>
+          <p:cNvSpPr txBox="1"/>
+          <p:nvPr/>
+        </p:nvSpPr>
+        <p:spPr>
+          <a:xfrm>
+            <a:off x="4297680" y="3520440"/>
+            <a:ext cx="1783080" cy="365760"/>
+          </a:xfrm>
+          <a:prstGeom prst="rect">
+            <a:avLst/>
+          </a:prstGeom>
+          <a:noFill/>
+          <a:ln/>
+        </p:spPr>
+        <p:txBody>
+          <a:bodyPr wrap="square" lIns="0" tIns="0" rIns="0" bIns="0" rtlCol="0" anchor="ctr"/>
+          <a:lstStyle/>
+          <a:p>
+            <a:pPr algn="ctr" indent="0" marL="0">
+              <a:buNone/>
+            </a:pPr>
+            <a:r>
+              <a:rPr lang="en-US" sz="1500" b="1" dirty="0">
+                <a:solidFill>
+                  <a:srgbClr val="1B2A41"/>
+                </a:solidFill>
+                <a:latin typeface="Calibri" pitchFamily="34" charset="0"/>
+                <a:ea typeface="Calibri" pitchFamily="34" charset="-122"/>
+                <a:cs typeface="Calibri" pitchFamily="34" charset="-120"/>
+              </a:rPr>
+              <a:t>分享數</a:t>
+            </a:r>
+            <a:endParaRPr lang="en-US" sz="1500" dirty="0"/>
+          </a:p>
+        </p:txBody>
+      </p:sp>
+      <p:sp>
+        <p:nvSpPr>
+          <p:cNvPr id="23" name="Text 21"/>
+          <p:cNvSpPr txBox="1"/>
+          <p:nvPr/>
+        </p:nvSpPr>
+        <p:spPr>
+          <a:xfrm>
+            <a:off x="457200" y="4297680"/>
+            <a:ext cx="5669280" cy="548640"/>
+          </a:xfrm>
+          <a:prstGeom prst="rect">
+            <a:avLst/>
+          </a:prstGeom>
+          <a:noFill/>
+          <a:ln/>
+        </p:spPr>
+        <p:txBody>
+          <a:bodyPr wrap="square" lIns="0" tIns="0" rIns="0" bIns="0" rtlCol="0" anchor="ctr"/>
+          <a:lstStyle/>
+          <a:p>
+            <a:pPr indent="0" marL="0">
+              <a:buNone/>
+            </a:pPr>
+            <a:r>
+              <a:rPr lang="en-US" sz="1200" dirty="0">
                 <a:solidFill>
                   <a:srgbClr val="5B6575"/>
                 </a:solidFill>
@@ -4782,12 +5003,35 @@
                 <a:ea typeface="Calibri" pitchFamily="34" charset="-122"/>
                 <a:cs typeface="Calibri" pitchFamily="34" charset="-120"/>
               </a:rPr>
-              <a:t>【貼上 IG 後台洞察截圖(觸及 / 互動 / 留言 / 按讚)】</a:t>
-            </a:r>
-            <a:endParaRPr lang="en-US" sz="1400" dirty="0"/>
-          </a:p>
-        </p:txBody>
-      </p:sp>
+              <a:t>互動數 = 按讚 34 + 留言 1 + 分享 1(轉發、儲存皆 0)。平均觀看時間 3 秒,新增追蹤 0。資料來源:IG Reel 後台洞察。</a:t>
+            </a:r>
+            <a:endParaRPr lang="en-US" sz="1200" dirty="0"/>
+          </a:p>
+        </p:txBody>
+      </p:sp>
+      <p:pic>
+        <p:nvPicPr>
+          <p:cNvPr id="24" name="Image 0" descr="img/3028a033.jpg">    </p:cNvPr>
+          <p:cNvPicPr>
+            <a:picLocks noChangeAspect="1"/>
+          </p:cNvPicPr>
+          <p:nvPr/>
+        </p:nvPicPr>
+        <p:blipFill>
+          <a:blip r:embed="rId1"/>
+          <a:srcRect l="0" r="0" t="0" b="0"/>
+          <a:stretch/>
+        </p:blipFill>
+        <p:spPr>
+          <a:xfrm>
+            <a:off x="6583680" y="868680"/>
+            <a:ext cx="1783080" cy="3877056"/>
+          </a:xfrm>
+          <a:prstGeom prst="rect">
+            <a:avLst/>
+          </a:prstGeom>
+        </p:spPr>
+      </p:pic>
     </p:spTree>
   </p:cSld>
   <p:clrMapOvr>
@@ -5149,7 +5393,7 @@
                 <a:ea typeface="Calibri" pitchFamily="34" charset="-122"/>
                 <a:cs typeface="Calibri" pitchFamily="34" charset="-120"/>
               </a:rPr>
-              <a:t>Dcard:職場 / 實習 / 求職相關看板</a:t>
+              <a:t>Dcard 工作版</a:t>
             </a:r>
             <a:endParaRPr lang="en-US" sz="1400" dirty="0"/>
           </a:p>
@@ -5170,7 +5414,28 @@
                 <a:ea typeface="Calibri" pitchFamily="34" charset="-122"/>
                 <a:cs typeface="Calibri" pitchFamily="34" charset="-120"/>
               </a:rPr>
-              <a:t>Threads:求職、新鮮人相關貼文</a:t>
+              <a:t>2 篇貼文,共 50 則留言</a:t>
+            </a:r>
+            <a:endParaRPr lang="en-US" sz="1400" dirty="0"/>
+          </a:p>
+          <a:p>
+            <a:pPr marL="342900" indent="-342900">
+              <a:spcAft>
+                <a:spcPts val="400"/>
+              </a:spcAft>
+              <a:buSzPct val="100000"/>
+              <a:buChar char="•"/>
+            </a:pPr>
+            <a:r>
+              <a:rPr lang="en-US" sz="1400" dirty="0">
+                <a:solidFill>
+                  <a:srgbClr val="222222"/>
+                </a:solidFill>
+                <a:latin typeface="Calibri" pitchFamily="34" charset="0"/>
+                <a:ea typeface="Calibri" pitchFamily="34" charset="-122"/>
+                <a:cs typeface="Calibri" pitchFamily="34" charset="-120"/>
+              </a:rPr>
+              <a:t>(實際統計 31 則可見留言)</a:t>
             </a:r>
             <a:endParaRPr lang="en-US" sz="1400" dirty="0"/>
           </a:p>
@@ -5279,7 +5544,7 @@
                 <a:ea typeface="Calibri" pitchFamily="34" charset="-122"/>
                 <a:cs typeface="Calibri" pitchFamily="34" charset="-120"/>
               </a:rPr>
-              <a:t>關鍵字:福利、年終、彈性工時、遠端、員工旅遊、津貼、進修補助</a:t>
+              <a:t>選擇與福利、新鮮人職場生活最相關的兩篇貼文,記錄發文日期、愛心、留言、收藏、分享數</a:t>
             </a:r>
             <a:endParaRPr lang="en-US" sz="1400" dirty="0"/>
           </a:p>
@@ -5300,7 +5565,7 @@
                 <a:ea typeface="Calibri" pitchFamily="34" charset="-122"/>
                 <a:cs typeface="Calibri" pitchFamily="34" charset="-120"/>
               </a:rPr>
-              <a:t>記錄:貼文截圖、發文日期、按讚 / 留言數,整理出被提及最多的福利類型</a:t>
+              <a:t>逐則閱讀可見留言,依福利類別統計被提及的次數(一則留言可提及多項)</a:t>
             </a:r>
             <a:endParaRPr lang="en-US" sz="1400" dirty="0"/>
           </a:p>
@@ -5321,7 +5586,7 @@
                 <a:ea typeface="Calibri" pitchFamily="34" charset="-122"/>
                 <a:cs typeface="Calibri" pitchFamily="34" charset="-120"/>
               </a:rPr>
-              <a:t>交叉比對:公開人力銀行調查數據,避免僅憑單一貼文下結論</a:t>
+              <a:t>再與公開人力銀行調查交叉比對,避免僅憑單一貼文下結論</a:t>
             </a:r>
             <a:endParaRPr lang="en-US" sz="1400" dirty="0"/>
           </a:p>
@@ -5451,63 +5716,84 @@
                 <a:ea typeface="Calibri" pitchFamily="34" charset="-122"/>
                 <a:cs typeface="Calibri" pitchFamily="34" charset="-120"/>
               </a:rPr>
-              <a:t>B 第一線觀察:平台案例</a:t>
+              <a:t>B 第一線觀察:Dcard 案例</a:t>
             </a:r>
             <a:endParaRPr lang="en-US" sz="2600" dirty="0"/>
           </a:p>
         </p:txBody>
       </p:sp>
-      <p:sp>
-        <p:nvSpPr>
-          <p:cNvPr id="5" name="Shape 3"/>
-          <p:cNvSpPr/>
-          <p:nvPr/>
-        </p:nvSpPr>
-        <p:spPr>
-          <a:xfrm>
-            <a:off x="457200" y="1051560"/>
-            <a:ext cx="2606040" cy="2651760"/>
-          </a:xfrm>
-          <a:prstGeom prst="rect">
-            <a:avLst/>
-          </a:prstGeom>
-          <a:solidFill>
-            <a:srgbClr val="FFFFFF"/>
-          </a:solidFill>
-          <a:ln w="15875">
-            <a:solidFill>
-              <a:srgbClr val="9AA3B2"/>
-            </a:solidFill>
-            <a:prstDash val="dash"/>
-          </a:ln>
-        </p:spPr>
-      </p:sp>
-      <p:sp>
-        <p:nvSpPr>
-          <p:cNvPr id="6" name="Text 4"/>
-          <p:cNvSpPr txBox="1"/>
-          <p:nvPr/>
-        </p:nvSpPr>
-        <p:spPr>
-          <a:xfrm>
-            <a:off x="457200" y="1051560"/>
-            <a:ext cx="2606040" cy="2651760"/>
-          </a:xfrm>
-          <a:prstGeom prst="rect">
-            <a:avLst/>
-          </a:prstGeom>
-          <a:noFill/>
-          <a:ln/>
-        </p:spPr>
-        <p:txBody>
-          <a:bodyPr wrap="square" rtlCol="0" anchor="ctr"/>
-          <a:lstStyle/>
-          <a:p>
-            <a:pPr algn="ctr" indent="0" marL="0">
-              <a:buNone/>
-            </a:pPr>
-            <a:r>
-              <a:rPr lang="en-US" sz="1400" dirty="0">
+      <p:pic>
+        <p:nvPicPr>
+          <p:cNvPr id="5" name="Image 0" descr="img/6ff4206d.jpg">    </p:cNvPr>
+          <p:cNvPicPr>
+            <a:picLocks noChangeAspect="1"/>
+          </p:cNvPicPr>
+          <p:nvPr/>
+        </p:nvPicPr>
+        <p:blipFill>
+          <a:blip r:embed="rId1"/>
+          <a:srcRect l="0" r="0" t="0" b="0"/>
+          <a:stretch/>
+        </p:blipFill>
+        <p:spPr>
+          <a:xfrm>
+            <a:off x="457200" y="960120"/>
+            <a:ext cx="1554480" cy="3383280"/>
+          </a:xfrm>
+          <a:prstGeom prst="rect">
+            <a:avLst/>
+          </a:prstGeom>
+        </p:spPr>
+      </p:pic>
+      <p:sp>
+        <p:nvSpPr>
+          <p:cNvPr id="6" name="Text 3"/>
+          <p:cNvSpPr txBox="1"/>
+          <p:nvPr/>
+        </p:nvSpPr>
+        <p:spPr>
+          <a:xfrm>
+            <a:off x="2194560" y="960120"/>
+            <a:ext cx="2240280" cy="3566160"/>
+          </a:xfrm>
+          <a:prstGeom prst="rect">
+            <a:avLst/>
+          </a:prstGeom>
+          <a:noFill/>
+          <a:ln/>
+        </p:spPr>
+        <p:txBody>
+          <a:bodyPr wrap="square" lIns="0" tIns="0" rIns="0" bIns="0" rtlCol="0" anchor="t"/>
+          <a:lstStyle/>
+          <a:p>
+            <a:pPr indent="0" marL="0">
+              <a:spcAft>
+                <a:spcPts val="500"/>
+              </a:spcAft>
+              <a:buNone/>
+            </a:pPr>
+            <a:r>
+              <a:rPr lang="en-US" sz="1300" b="1" dirty="0">
+                <a:solidFill>
+                  <a:srgbClr val="1B2A41"/>
+                </a:solidFill>
+                <a:latin typeface="Calibri" pitchFamily="34" charset="0"/>
+                <a:ea typeface="Calibri" pitchFamily="34" charset="-122"/>
+                <a:cs typeface="Calibri" pitchFamily="34" charset="-120"/>
+              </a:rPr>
+              <a:t>案例 1|#請益 大家都在乎什麼公司福利?</a:t>
+            </a:r>
+            <a:endParaRPr lang="en-US" sz="1300" dirty="0"/>
+          </a:p>
+          <a:p>
+            <a:pPr indent="0" marL="0">
+              <a:spcAft>
+                <a:spcPts val="500"/>
+              </a:spcAft>
+              <a:buNone/>
+            </a:pPr>
+            <a:r>
+              <a:rPr lang="en-US" sz="1200" dirty="0">
                 <a:solidFill>
                   <a:srgbClr val="5B6575"/>
                 </a:solidFill>
@@ -5515,16 +5801,147 @@
                 <a:ea typeface="Calibri" pitchFamily="34" charset="-122"/>
                 <a:cs typeface="Calibri" pitchFamily="34" charset="-120"/>
               </a:rPr>
-              <a:t>【貼上截圖】</a:t>
-            </a:r>
-            <a:endParaRPr lang="en-US" sz="1400" dirty="0"/>
-          </a:p>
-          <a:p>
-            <a:pPr algn="ctr" indent="0" marL="0">
-              <a:buNone/>
-            </a:pPr>
-            <a:r>
-              <a:rPr lang="en-US" sz="1400" dirty="0">
+              <a:t>發文:2025/2/15 ・ 愛心 142 ・ 留言 35 ・ 收藏 832 ・ 分享 50</a:t>
+            </a:r>
+            <a:endParaRPr lang="en-US" sz="1300" dirty="0"/>
+          </a:p>
+          <a:p>
+            <a:pPr marL="342900" indent="-342900">
+              <a:spcAft>
+                <a:spcPts val="500"/>
+              </a:spcAft>
+              <a:buSzPct val="100000"/>
+              <a:buChar char="•"/>
+            </a:pPr>
+            <a:r>
+              <a:rPr lang="en-US" sz="1300" dirty="0">
+                <a:solidFill>
+                  <a:srgbClr val="222222"/>
+                </a:solidFill>
+                <a:latin typeface="Calibri" pitchFamily="34" charset="0"/>
+                <a:ea typeface="Calibri" pitchFamily="34" charset="-122"/>
+                <a:cs typeface="Calibri" pitchFamily="34" charset="-120"/>
+              </a:rPr>
+              <a:t>新鮮人拿到錄取通知,請教哪些福利是必問、必備</a:t>
+            </a:r>
+            <a:endParaRPr lang="en-US" sz="1300" dirty="0"/>
+          </a:p>
+          <a:p>
+            <a:pPr marL="342900" indent="-342900">
+              <a:spcAft>
+                <a:spcPts val="500"/>
+              </a:spcAft>
+              <a:buSzPct val="100000"/>
+              <a:buChar char="•"/>
+            </a:pPr>
+            <a:r>
+              <a:rPr lang="en-US" sz="1300" dirty="0">
+                <a:solidFill>
+                  <a:srgbClr val="222222"/>
+                </a:solidFill>
+                <a:latin typeface="Calibri" pitchFamily="34" charset="0"/>
+                <a:ea typeface="Calibri" pitchFamily="34" charset="-122"/>
+                <a:cs typeface="Calibri" pitchFamily="34" charset="-120"/>
+              </a:rPr>
+              <a:t>最高讚留言(246 讚):入職前要確認試用期、薪資結構、休假、三節/年終、加班費、勞健保級距</a:t>
+            </a:r>
+            <a:endParaRPr lang="en-US" sz="1300" dirty="0"/>
+          </a:p>
+          <a:p>
+            <a:pPr marL="342900" indent="-342900">
+              <a:spcAft>
+                <a:spcPts val="500"/>
+              </a:spcAft>
+              <a:buSzPct val="100000"/>
+              <a:buChar char="•"/>
+            </a:pPr>
+            <a:r>
+              <a:rPr lang="en-US" sz="1300" dirty="0">
+                <a:solidFill>
+                  <a:srgbClr val="222222"/>
+                </a:solidFill>
+                <a:latin typeface="Calibri" pitchFamily="34" charset="0"/>
+                <a:ea typeface="Calibri" pitchFamily="34" charset="-122"/>
+                <a:cs typeface="Calibri" pitchFamily="34" charset="-120"/>
+              </a:rPr>
+              <a:t>「錢才是重點,優於勞基法的才叫福利」(72 讚)</a:t>
+            </a:r>
+            <a:endParaRPr lang="en-US" sz="1300" dirty="0"/>
+          </a:p>
+        </p:txBody>
+      </p:sp>
+      <p:pic>
+        <p:nvPicPr>
+          <p:cNvPr id="7" name="Image 1" descr="img/3928ddfb.jpg">    </p:cNvPr>
+          <p:cNvPicPr>
+            <a:picLocks noChangeAspect="1"/>
+          </p:cNvPicPr>
+          <p:nvPr/>
+        </p:nvPicPr>
+        <p:blipFill>
+          <a:blip r:embed="rId2"/>
+          <a:srcRect l="0" r="0" t="0" b="0"/>
+          <a:stretch/>
+        </p:blipFill>
+        <p:spPr>
+          <a:xfrm>
+            <a:off x="4663440" y="960120"/>
+            <a:ext cx="1554480" cy="3383280"/>
+          </a:xfrm>
+          <a:prstGeom prst="rect">
+            <a:avLst/>
+          </a:prstGeom>
+        </p:spPr>
+      </p:pic>
+      <p:sp>
+        <p:nvSpPr>
+          <p:cNvPr id="8" name="Text 4"/>
+          <p:cNvSpPr txBox="1"/>
+          <p:nvPr/>
+        </p:nvSpPr>
+        <p:spPr>
+          <a:xfrm>
+            <a:off x="6400800" y="960120"/>
+            <a:ext cx="2286000" cy="3566160"/>
+          </a:xfrm>
+          <a:prstGeom prst="rect">
+            <a:avLst/>
+          </a:prstGeom>
+          <a:noFill/>
+          <a:ln/>
+        </p:spPr>
+        <p:txBody>
+          <a:bodyPr wrap="square" lIns="0" tIns="0" rIns="0" bIns="0" rtlCol="0" anchor="t"/>
+          <a:lstStyle/>
+          <a:p>
+            <a:pPr indent="0" marL="0">
+              <a:spcAft>
+                <a:spcPts val="500"/>
+              </a:spcAft>
+              <a:buNone/>
+            </a:pPr>
+            <a:r>
+              <a:rPr lang="en-US" sz="1300" b="1" dirty="0">
+                <a:solidFill>
+                  <a:srgbClr val="1B2A41"/>
+                </a:solidFill>
+                <a:latin typeface="Calibri" pitchFamily="34" charset="0"/>
+                <a:ea typeface="Calibri" pitchFamily="34" charset="-122"/>
+                <a:cs typeface="Calibri" pitchFamily="34" charset="-120"/>
+              </a:rPr>
+              <a:t>案例 2|#閒聊 社會新鮮人的小確幸公司</a:t>
+            </a:r>
+            <a:endParaRPr lang="en-US" sz="1300" dirty="0"/>
+          </a:p>
+          <a:p>
+            <a:pPr indent="0" marL="0">
+              <a:spcAft>
+                <a:spcPts val="500"/>
+              </a:spcAft>
+              <a:buNone/>
+            </a:pPr>
+            <a:r>
+              <a:rPr lang="en-US" sz="1200" dirty="0">
                 <a:solidFill>
                   <a:srgbClr val="5B6575"/>
                 </a:solidFill>
@@ -5532,38 +5949,20 @@
                 <a:ea typeface="Calibri" pitchFamily="34" charset="-122"/>
                 <a:cs typeface="Calibri" pitchFamily="34" charset="-120"/>
               </a:rPr>
-              <a:t>Dcard 案例 1</a:t>
-            </a:r>
-            <a:endParaRPr lang="en-US" sz="1400" dirty="0"/>
-          </a:p>
-        </p:txBody>
-      </p:sp>
-      <p:sp>
-        <p:nvSpPr>
-          <p:cNvPr id="7" name="Text 5"/>
-          <p:cNvSpPr txBox="1"/>
-          <p:nvPr/>
-        </p:nvSpPr>
-        <p:spPr>
-          <a:xfrm>
-            <a:off x="457200" y="3794760"/>
-            <a:ext cx="2606040" cy="411480"/>
-          </a:xfrm>
-          <a:prstGeom prst="rect">
-            <a:avLst/>
-          </a:prstGeom>
-          <a:noFill/>
-          <a:ln/>
-        </p:spPr>
-        <p:txBody>
-          <a:bodyPr wrap="square" lIns="0" tIns="0" rIns="0" bIns="0" rtlCol="0" anchor="ctr"/>
-          <a:lstStyle/>
-          <a:p>
-            <a:pPr indent="0" marL="0">
-              <a:buNone/>
-            </a:pPr>
-            <a:r>
-              <a:rPr lang="en-US" sz="1200" dirty="0">
+              <a:t>發文:2025/12/18 ・ 愛心 82 ・ 留言 15 ・ 收藏 10 ・ 分享 2</a:t>
+            </a:r>
+            <a:endParaRPr lang="en-US" sz="1300" dirty="0"/>
+          </a:p>
+          <a:p>
+            <a:pPr marL="342900" indent="-342900">
+              <a:spcAft>
+                <a:spcPts val="500"/>
+              </a:spcAft>
+              <a:buSzPct val="100000"/>
+              <a:buChar char="•"/>
+            </a:pPr>
+            <a:r>
+              <a:rPr lang="en-US" sz="1300" dirty="0">
                 <a:solidFill>
                   <a:srgbClr val="222222"/>
                 </a:solidFill>
@@ -5571,52 +5970,20 @@
                 <a:ea typeface="Calibri" pitchFamily="34" charset="-122"/>
                 <a:cs typeface="Calibri" pitchFamily="34" charset="-120"/>
               </a:rPr>
-              <a:t>貼文重點:</a:t>
-            </a:r>
-            <a:pPr indent="0" marL="0">
-              <a:buNone/>
-            </a:pPr>
-            <a:r>
-              <a:rPr lang="en-US" sz="1200" b="1" dirty="0">
-                <a:solidFill>
-                  <a:srgbClr val="C8102E"/>
-                </a:solidFill>
-                <a:latin typeface="Calibri" pitchFamily="34" charset="0"/>
-                <a:ea typeface="Calibri" pitchFamily="34" charset="-122"/>
-                <a:cs typeface="Calibri" pitchFamily="34" charset="-120"/>
-              </a:rPr>
-              <a:t>【待補】</a:t>
-            </a:r>
-            <a:endParaRPr lang="en-US" sz="1200" dirty="0"/>
-          </a:p>
-        </p:txBody>
-      </p:sp>
-      <p:sp>
-        <p:nvSpPr>
-          <p:cNvPr id="8" name="Text 6"/>
-          <p:cNvSpPr txBox="1"/>
-          <p:nvPr/>
-        </p:nvSpPr>
-        <p:spPr>
-          <a:xfrm>
-            <a:off x="457200" y="4206240"/>
-            <a:ext cx="2606040" cy="365760"/>
-          </a:xfrm>
-          <a:prstGeom prst="rect">
-            <a:avLst/>
-          </a:prstGeom>
-          <a:noFill/>
-          <a:ln/>
-        </p:spPr>
-        <p:txBody>
-          <a:bodyPr wrap="square" lIns="0" tIns="0" rIns="0" bIns="0" rtlCol="0" anchor="ctr"/>
-          <a:lstStyle/>
-          <a:p>
-            <a:pPr indent="0" marL="0">
-              <a:buNone/>
-            </a:pPr>
-            <a:r>
-              <a:rPr lang="en-US" sz="1200" dirty="0">
+              <a:t>原 PO 喜歡:月底放風日、Work From Anywhere、午休 1.5 小時、病假 10 天不扣薪、生日月福利</a:t>
+            </a:r>
+            <a:endParaRPr lang="en-US" sz="1300" dirty="0"/>
+          </a:p>
+          <a:p>
+            <a:pPr marL="342900" indent="-342900">
+              <a:spcAft>
+                <a:spcPts val="500"/>
+              </a:spcAft>
+              <a:buSzPct val="100000"/>
+              <a:buChar char="•"/>
+            </a:pPr>
+            <a:r>
+              <a:rPr lang="en-US" sz="1300" dirty="0">
                 <a:solidFill>
                   <a:srgbClr val="222222"/>
                 </a:solidFill>
@@ -5624,397 +5991,9 @@
                 <a:ea typeface="Calibri" pitchFamily="34" charset="-122"/>
                 <a:cs typeface="Calibri" pitchFamily="34" charset="-120"/>
               </a:rPr>
-              <a:t>讚 / 留言數:</a:t>
-            </a:r>
-            <a:pPr indent="0" marL="0">
-              <a:buNone/>
-            </a:pPr>
-            <a:r>
-              <a:rPr lang="en-US" sz="1200" b="1" dirty="0">
-                <a:solidFill>
-                  <a:srgbClr val="C8102E"/>
-                </a:solidFill>
-                <a:latin typeface="Calibri" pitchFamily="34" charset="0"/>
-                <a:ea typeface="Calibri" pitchFamily="34" charset="-122"/>
-                <a:cs typeface="Calibri" pitchFamily="34" charset="-120"/>
-              </a:rPr>
-              <a:t>【待補】</a:t>
-            </a:r>
-            <a:endParaRPr lang="en-US" sz="1200" dirty="0"/>
-          </a:p>
-        </p:txBody>
-      </p:sp>
-      <p:sp>
-        <p:nvSpPr>
-          <p:cNvPr id="9" name="Shape 7"/>
-          <p:cNvSpPr/>
-          <p:nvPr/>
-        </p:nvSpPr>
-        <p:spPr>
-          <a:xfrm>
-            <a:off x="3264408" y="1051560"/>
-            <a:ext cx="2606040" cy="2651760"/>
-          </a:xfrm>
-          <a:prstGeom prst="rect">
-            <a:avLst/>
-          </a:prstGeom>
-          <a:solidFill>
-            <a:srgbClr val="FFFFFF"/>
-          </a:solidFill>
-          <a:ln w="15875">
-            <a:solidFill>
-              <a:srgbClr val="9AA3B2"/>
-            </a:solidFill>
-            <a:prstDash val="dash"/>
-          </a:ln>
-        </p:spPr>
-      </p:sp>
-      <p:sp>
-        <p:nvSpPr>
-          <p:cNvPr id="10" name="Text 8"/>
-          <p:cNvSpPr txBox="1"/>
-          <p:nvPr/>
-        </p:nvSpPr>
-        <p:spPr>
-          <a:xfrm>
-            <a:off x="3264408" y="1051560"/>
-            <a:ext cx="2606040" cy="2651760"/>
-          </a:xfrm>
-          <a:prstGeom prst="rect">
-            <a:avLst/>
-          </a:prstGeom>
-          <a:noFill/>
-          <a:ln/>
-        </p:spPr>
-        <p:txBody>
-          <a:bodyPr wrap="square" rtlCol="0" anchor="ctr"/>
-          <a:lstStyle/>
-          <a:p>
-            <a:pPr algn="ctr" indent="0" marL="0">
-              <a:buNone/>
-            </a:pPr>
-            <a:r>
-              <a:rPr lang="en-US" sz="1400" dirty="0">
-                <a:solidFill>
-                  <a:srgbClr val="5B6575"/>
-                </a:solidFill>
-                <a:latin typeface="Calibri" pitchFamily="34" charset="0"/>
-                <a:ea typeface="Calibri" pitchFamily="34" charset="-122"/>
-                <a:cs typeface="Calibri" pitchFamily="34" charset="-120"/>
-              </a:rPr>
-              <a:t>【貼上截圖】</a:t>
-            </a:r>
-            <a:endParaRPr lang="en-US" sz="1400" dirty="0"/>
-          </a:p>
-          <a:p>
-            <a:pPr algn="ctr" indent="0" marL="0">
-              <a:buNone/>
-            </a:pPr>
-            <a:r>
-              <a:rPr lang="en-US" sz="1400" dirty="0">
-                <a:solidFill>
-                  <a:srgbClr val="5B6575"/>
-                </a:solidFill>
-                <a:latin typeface="Calibri" pitchFamily="34" charset="0"/>
-                <a:ea typeface="Calibri" pitchFamily="34" charset="-122"/>
-                <a:cs typeface="Calibri" pitchFamily="34" charset="-120"/>
-              </a:rPr>
-              <a:t>Dcard 案例 2</a:t>
-            </a:r>
-            <a:endParaRPr lang="en-US" sz="1400" dirty="0"/>
-          </a:p>
-        </p:txBody>
-      </p:sp>
-      <p:sp>
-        <p:nvSpPr>
-          <p:cNvPr id="11" name="Text 9"/>
-          <p:cNvSpPr txBox="1"/>
-          <p:nvPr/>
-        </p:nvSpPr>
-        <p:spPr>
-          <a:xfrm>
-            <a:off x="3264408" y="3794760"/>
-            <a:ext cx="2606040" cy="411480"/>
-          </a:xfrm>
-          <a:prstGeom prst="rect">
-            <a:avLst/>
-          </a:prstGeom>
-          <a:noFill/>
-          <a:ln/>
-        </p:spPr>
-        <p:txBody>
-          <a:bodyPr wrap="square" lIns="0" tIns="0" rIns="0" bIns="0" rtlCol="0" anchor="ctr"/>
-          <a:lstStyle/>
-          <a:p>
-            <a:pPr indent="0" marL="0">
-              <a:buNone/>
-            </a:pPr>
-            <a:r>
-              <a:rPr lang="en-US" sz="1200" dirty="0">
-                <a:solidFill>
-                  <a:srgbClr val="222222"/>
-                </a:solidFill>
-                <a:latin typeface="Calibri" pitchFamily="34" charset="0"/>
-                <a:ea typeface="Calibri" pitchFamily="34" charset="-122"/>
-                <a:cs typeface="Calibri" pitchFamily="34" charset="-120"/>
-              </a:rPr>
-              <a:t>貼文重點:</a:t>
-            </a:r>
-            <a:pPr indent="0" marL="0">
-              <a:buNone/>
-            </a:pPr>
-            <a:r>
-              <a:rPr lang="en-US" sz="1200" b="1" dirty="0">
-                <a:solidFill>
-                  <a:srgbClr val="C8102E"/>
-                </a:solidFill>
-                <a:latin typeface="Calibri" pitchFamily="34" charset="0"/>
-                <a:ea typeface="Calibri" pitchFamily="34" charset="-122"/>
-                <a:cs typeface="Calibri" pitchFamily="34" charset="-120"/>
-              </a:rPr>
-              <a:t>【待補】</a:t>
-            </a:r>
-            <a:endParaRPr lang="en-US" sz="1200" dirty="0"/>
-          </a:p>
-        </p:txBody>
-      </p:sp>
-      <p:sp>
-        <p:nvSpPr>
-          <p:cNvPr id="12" name="Text 10"/>
-          <p:cNvSpPr txBox="1"/>
-          <p:nvPr/>
-        </p:nvSpPr>
-        <p:spPr>
-          <a:xfrm>
-            <a:off x="3264408" y="4206240"/>
-            <a:ext cx="2606040" cy="365760"/>
-          </a:xfrm>
-          <a:prstGeom prst="rect">
-            <a:avLst/>
-          </a:prstGeom>
-          <a:noFill/>
-          <a:ln/>
-        </p:spPr>
-        <p:txBody>
-          <a:bodyPr wrap="square" lIns="0" tIns="0" rIns="0" bIns="0" rtlCol="0" anchor="ctr"/>
-          <a:lstStyle/>
-          <a:p>
-            <a:pPr indent="0" marL="0">
-              <a:buNone/>
-            </a:pPr>
-            <a:r>
-              <a:rPr lang="en-US" sz="1200" dirty="0">
-                <a:solidFill>
-                  <a:srgbClr val="222222"/>
-                </a:solidFill>
-                <a:latin typeface="Calibri" pitchFamily="34" charset="0"/>
-                <a:ea typeface="Calibri" pitchFamily="34" charset="-122"/>
-                <a:cs typeface="Calibri" pitchFamily="34" charset="-120"/>
-              </a:rPr>
-              <a:t>讚 / 留言數:</a:t>
-            </a:r>
-            <a:pPr indent="0" marL="0">
-              <a:buNone/>
-            </a:pPr>
-            <a:r>
-              <a:rPr lang="en-US" sz="1200" b="1" dirty="0">
-                <a:solidFill>
-                  <a:srgbClr val="C8102E"/>
-                </a:solidFill>
-                <a:latin typeface="Calibri" pitchFamily="34" charset="0"/>
-                <a:ea typeface="Calibri" pitchFamily="34" charset="-122"/>
-                <a:cs typeface="Calibri" pitchFamily="34" charset="-120"/>
-              </a:rPr>
-              <a:t>【待補】</a:t>
-            </a:r>
-            <a:endParaRPr lang="en-US" sz="1200" dirty="0"/>
-          </a:p>
-        </p:txBody>
-      </p:sp>
-      <p:sp>
-        <p:nvSpPr>
-          <p:cNvPr id="13" name="Shape 11"/>
-          <p:cNvSpPr/>
-          <p:nvPr/>
-        </p:nvSpPr>
-        <p:spPr>
-          <a:xfrm>
-            <a:off x="6071616" y="1051560"/>
-            <a:ext cx="2606040" cy="2651760"/>
-          </a:xfrm>
-          <a:prstGeom prst="rect">
-            <a:avLst/>
-          </a:prstGeom>
-          <a:solidFill>
-            <a:srgbClr val="FFFFFF"/>
-          </a:solidFill>
-          <a:ln w="15875">
-            <a:solidFill>
-              <a:srgbClr val="9AA3B2"/>
-            </a:solidFill>
-            <a:prstDash val="dash"/>
-          </a:ln>
-        </p:spPr>
-      </p:sp>
-      <p:sp>
-        <p:nvSpPr>
-          <p:cNvPr id="14" name="Text 12"/>
-          <p:cNvSpPr txBox="1"/>
-          <p:nvPr/>
-        </p:nvSpPr>
-        <p:spPr>
-          <a:xfrm>
-            <a:off x="6071616" y="1051560"/>
-            <a:ext cx="2606040" cy="2651760"/>
-          </a:xfrm>
-          <a:prstGeom prst="rect">
-            <a:avLst/>
-          </a:prstGeom>
-          <a:noFill/>
-          <a:ln/>
-        </p:spPr>
-        <p:txBody>
-          <a:bodyPr wrap="square" rtlCol="0" anchor="ctr"/>
-          <a:lstStyle/>
-          <a:p>
-            <a:pPr algn="ctr" indent="0" marL="0">
-              <a:buNone/>
-            </a:pPr>
-            <a:r>
-              <a:rPr lang="en-US" sz="1400" dirty="0">
-                <a:solidFill>
-                  <a:srgbClr val="5B6575"/>
-                </a:solidFill>
-                <a:latin typeface="Calibri" pitchFamily="34" charset="0"/>
-                <a:ea typeface="Calibri" pitchFamily="34" charset="-122"/>
-                <a:cs typeface="Calibri" pitchFamily="34" charset="-120"/>
-              </a:rPr>
-              <a:t>【貼上截圖】</a:t>
-            </a:r>
-            <a:endParaRPr lang="en-US" sz="1400" dirty="0"/>
-          </a:p>
-          <a:p>
-            <a:pPr algn="ctr" indent="0" marL="0">
-              <a:buNone/>
-            </a:pPr>
-            <a:r>
-              <a:rPr lang="en-US" sz="1400" dirty="0">
-                <a:solidFill>
-                  <a:srgbClr val="5B6575"/>
-                </a:solidFill>
-                <a:latin typeface="Calibri" pitchFamily="34" charset="0"/>
-                <a:ea typeface="Calibri" pitchFamily="34" charset="-122"/>
-                <a:cs typeface="Calibri" pitchFamily="34" charset="-120"/>
-              </a:rPr>
-              <a:t>Threads 案例 1</a:t>
-            </a:r>
-            <a:endParaRPr lang="en-US" sz="1400" dirty="0"/>
-          </a:p>
-        </p:txBody>
-      </p:sp>
-      <p:sp>
-        <p:nvSpPr>
-          <p:cNvPr id="15" name="Text 13"/>
-          <p:cNvSpPr txBox="1"/>
-          <p:nvPr/>
-        </p:nvSpPr>
-        <p:spPr>
-          <a:xfrm>
-            <a:off x="6071616" y="3794760"/>
-            <a:ext cx="2606040" cy="411480"/>
-          </a:xfrm>
-          <a:prstGeom prst="rect">
-            <a:avLst/>
-          </a:prstGeom>
-          <a:noFill/>
-          <a:ln/>
-        </p:spPr>
-        <p:txBody>
-          <a:bodyPr wrap="square" lIns="0" tIns="0" rIns="0" bIns="0" rtlCol="0" anchor="ctr"/>
-          <a:lstStyle/>
-          <a:p>
-            <a:pPr indent="0" marL="0">
-              <a:buNone/>
-            </a:pPr>
-            <a:r>
-              <a:rPr lang="en-US" sz="1200" dirty="0">
-                <a:solidFill>
-                  <a:srgbClr val="222222"/>
-                </a:solidFill>
-                <a:latin typeface="Calibri" pitchFamily="34" charset="0"/>
-                <a:ea typeface="Calibri" pitchFamily="34" charset="-122"/>
-                <a:cs typeface="Calibri" pitchFamily="34" charset="-120"/>
-              </a:rPr>
-              <a:t>貼文重點:</a:t>
-            </a:r>
-            <a:pPr indent="0" marL="0">
-              <a:buNone/>
-            </a:pPr>
-            <a:r>
-              <a:rPr lang="en-US" sz="1200" b="1" dirty="0">
-                <a:solidFill>
-                  <a:srgbClr val="C8102E"/>
-                </a:solidFill>
-                <a:latin typeface="Calibri" pitchFamily="34" charset="0"/>
-                <a:ea typeface="Calibri" pitchFamily="34" charset="-122"/>
-                <a:cs typeface="Calibri" pitchFamily="34" charset="-120"/>
-              </a:rPr>
-              <a:t>【待補】</a:t>
-            </a:r>
-            <a:endParaRPr lang="en-US" sz="1200" dirty="0"/>
-          </a:p>
-        </p:txBody>
-      </p:sp>
-      <p:sp>
-        <p:nvSpPr>
-          <p:cNvPr id="16" name="Text 14"/>
-          <p:cNvSpPr txBox="1"/>
-          <p:nvPr/>
-        </p:nvSpPr>
-        <p:spPr>
-          <a:xfrm>
-            <a:off x="6071616" y="4206240"/>
-            <a:ext cx="2606040" cy="365760"/>
-          </a:xfrm>
-          <a:prstGeom prst="rect">
-            <a:avLst/>
-          </a:prstGeom>
-          <a:noFill/>
-          <a:ln/>
-        </p:spPr>
-        <p:txBody>
-          <a:bodyPr wrap="square" lIns="0" tIns="0" rIns="0" bIns="0" rtlCol="0" anchor="ctr"/>
-          <a:lstStyle/>
-          <a:p>
-            <a:pPr indent="0" marL="0">
-              <a:buNone/>
-            </a:pPr>
-            <a:r>
-              <a:rPr lang="en-US" sz="1200" dirty="0">
-                <a:solidFill>
-                  <a:srgbClr val="222222"/>
-                </a:solidFill>
-                <a:latin typeface="Calibri" pitchFamily="34" charset="0"/>
-                <a:ea typeface="Calibri" pitchFamily="34" charset="-122"/>
-                <a:cs typeface="Calibri" pitchFamily="34" charset="-120"/>
-              </a:rPr>
-              <a:t>讚 / 留言數:</a:t>
-            </a:r>
-            <a:pPr indent="0" marL="0">
-              <a:buNone/>
-            </a:pPr>
-            <a:r>
-              <a:rPr lang="en-US" sz="1200" b="1" dirty="0">
-                <a:solidFill>
-                  <a:srgbClr val="C8102E"/>
-                </a:solidFill>
-                <a:latin typeface="Calibri" pitchFamily="34" charset="0"/>
-                <a:ea typeface="Calibri" pitchFamily="34" charset="-122"/>
-                <a:cs typeface="Calibri" pitchFamily="34" charset="-120"/>
-              </a:rPr>
-              <a:t>【待補】</a:t>
-            </a:r>
-            <a:endParaRPr lang="en-US" sz="1200" dirty="0"/>
+              <a:t>留言多為零食、節慶賀卡、蛋糕等「小確幸」的羨慕與比較</a:t>
+            </a:r>
+            <a:endParaRPr lang="en-US" sz="1300" dirty="0"/>
           </a:p>
         </p:txBody>
       </p:sp>
@@ -6142,7 +6121,7 @@
                 <a:ea typeface="Calibri" pitchFamily="34" charset="-122"/>
                 <a:cs typeface="Calibri" pitchFamily="34" charset="-120"/>
               </a:rPr>
-              <a:t>B 數據佐證:求職者重視什麼</a:t>
+              <a:t>B 數據佐證:留言怎麼說</a:t>
             </a:r>
             <a:endParaRPr lang="en-US" sz="2600" dirty="0"/>
           </a:p>
@@ -6155,8 +6134,8 @@
           <p:nvPr/>
         </p:nvGraphicFramePr>
         <p:xfrm>
-          <a:off x="457200" y="1051560"/>
-          <a:ext cx="4206240" cy="2651760"/>
+          <a:off x="457200" y="1005840"/>
+          <a:ext cx="5120640" cy="3383280"/>
         </p:xfrm>
         <a:graphic xmlns:a="http://schemas.openxmlformats.org/drawingml/2006/main">
           <a:graphicData uri="http://schemas.openxmlformats.org/drawingml/2006/chart">
@@ -6172,8 +6151,8 @@
         </p:nvSpPr>
         <p:spPr>
           <a:xfrm>
-            <a:off x="457200" y="3749040"/>
-            <a:ext cx="4206240" cy="731520"/>
+            <a:off x="457200" y="4389120"/>
+            <a:ext cx="5120640" cy="548640"/>
           </a:xfrm>
           <a:prstGeom prst="rect">
             <a:avLst/>
@@ -6197,7 +6176,7 @@
                 <a:ea typeface="Calibri" pitchFamily="34" charset="-122"/>
                 <a:cs typeface="Calibri" pitchFamily="34" charset="-120"/>
               </a:rPr>
-              <a:t>資料來源:104 人力銀行員工調查(2024);其餘項目(交通、獎金、福利制度)請依原始報告補入並核對數字。</a:t>
+              <a:t>統計方式:案例 1 共 35 則留言,截圖可見 20 則,其中 17 則談到福利內容;一則可提及多項。案例 2 可見 11 則,其中 4 則談零食/賀卡。</a:t>
             </a:r>
             <a:endParaRPr lang="en-US" sz="1100" dirty="0"/>
           </a:p>
@@ -6211,12 +6190,12 @@
         </p:nvSpPr>
         <p:spPr>
           <a:xfrm>
-            <a:off x="4846320" y="1051560"/>
-            <a:ext cx="3840480" cy="3429000"/>
+            <a:off x="5760720" y="1005840"/>
+            <a:ext cx="2926080" cy="1828800"/>
           </a:xfrm>
           <a:prstGeom prst="roundRect">
             <a:avLst>
-              <a:gd name="adj" fmla="val 2133"/>
+              <a:gd name="adj" fmla="val 4000"/>
             </a:avLst>
           </a:prstGeom>
           <a:solidFill>
@@ -6238,8 +6217,8 @@
         </p:nvSpPr>
         <p:spPr>
           <a:xfrm>
-            <a:off x="5029200" y="1161288"/>
-            <a:ext cx="3474720" cy="365760"/>
+            <a:off x="5943600" y="1115568"/>
+            <a:ext cx="2560320" cy="365760"/>
           </a:xfrm>
           <a:prstGeom prst="rect">
             <a:avLst/>
@@ -6263,7 +6242,7 @@
                 <a:ea typeface="Calibri" pitchFamily="34" charset="-122"/>
                 <a:cs typeface="Calibri" pitchFamily="34" charset="-120"/>
               </a:rPr>
-              <a:t>平台數據(自行蒐集)</a:t>
+              <a:t>兩篇貼文互動合計</a:t>
             </a:r>
             <a:endParaRPr lang="en-US" sz="1600" dirty="0"/>
           </a:p>
@@ -6277,8 +6256,8 @@
         </p:nvSpPr>
         <p:spPr>
           <a:xfrm>
-            <a:off x="5029200" y="1554480"/>
-            <a:ext cx="3474720" cy="2834640"/>
+            <a:off x="5943600" y="1508760"/>
+            <a:ext cx="2560320" cy="1234440"/>
           </a:xfrm>
           <a:prstGeom prst="rect">
             <a:avLst/>
@@ -6305,7 +6284,7 @@
                 <a:ea typeface="Calibri" pitchFamily="34" charset="-122"/>
                 <a:cs typeface="Calibri" pitchFamily="34" charset="-120"/>
               </a:rPr>
-              <a:t>被提及最多的福利:</a:t>
+              <a:t>愛心 224 ・ 留言 50</a:t>
             </a:r>
             <a:endParaRPr lang="en-US" sz="1400" dirty="0"/>
           </a:p>
@@ -6317,31 +6296,113 @@
               <a:buNone/>
             </a:pPr>
             <a:r>
-              <a:rPr lang="en-US" sz="1400" b="1" dirty="0">
-                <a:solidFill>
-                  <a:srgbClr val="C8102E"/>
-                </a:solidFill>
-                <a:latin typeface="Calibri" pitchFamily="34" charset="0"/>
-                <a:ea typeface="Calibri" pitchFamily="34" charset="-122"/>
-                <a:cs typeface="Calibri" pitchFamily="34" charset="-120"/>
-              </a:rPr>
-              <a:t>【待補】</a:t>
-            </a:r>
+              <a:rPr lang="en-US" sz="1400" dirty="0">
+                <a:solidFill>
+                  <a:srgbClr val="222222"/>
+                </a:solidFill>
+                <a:latin typeface="Calibri" pitchFamily="34" charset="0"/>
+                <a:ea typeface="Calibri" pitchFamily="34" charset="-122"/>
+                <a:cs typeface="Calibri" pitchFamily="34" charset="-120"/>
+              </a:rPr>
+              <a:t>收藏 842 ・ 分享 52</a:t>
+            </a:r>
+            <a:endParaRPr lang="en-US" sz="1400" dirty="0"/>
+          </a:p>
+        </p:txBody>
+      </p:sp>
+      <p:sp>
+        <p:nvSpPr>
+          <p:cNvPr id="10" name="Shape 7"/>
+          <p:cNvSpPr/>
+          <p:nvPr/>
+        </p:nvSpPr>
+        <p:spPr>
+          <a:xfrm>
+            <a:off x="5760720" y="2971800"/>
+            <a:ext cx="2926080" cy="1828800"/>
+          </a:xfrm>
+          <a:prstGeom prst="roundRect">
+            <a:avLst>
+              <a:gd name="adj" fmla="val 4000"/>
+            </a:avLst>
+          </a:prstGeom>
+          <a:solidFill>
+            <a:srgbClr val="F3F5F8"/>
+          </a:solidFill>
+          <a:ln w="12700">
+            <a:solidFill>
+              <a:srgbClr val="F3F5F8"/>
+            </a:solidFill>
+            <a:prstDash val="solid"/>
+          </a:ln>
+        </p:spPr>
+      </p:sp>
+      <p:sp>
+        <p:nvSpPr>
+          <p:cNvPr id="11" name="Text 8"/>
+          <p:cNvSpPr txBox="1"/>
+          <p:nvPr/>
+        </p:nvSpPr>
+        <p:spPr>
+          <a:xfrm>
+            <a:off x="5943600" y="3081528"/>
+            <a:ext cx="2560320" cy="365760"/>
+          </a:xfrm>
+          <a:prstGeom prst="rect">
+            <a:avLst/>
+          </a:prstGeom>
+          <a:noFill/>
+          <a:ln/>
+        </p:spPr>
+        <p:txBody>
+          <a:bodyPr wrap="square" lIns="0" tIns="0" rIns="0" bIns="0" rtlCol="0" anchor="ctr"/>
+          <a:lstStyle/>
+          <a:p>
+            <a:pPr indent="0" marL="0">
+              <a:buNone/>
+            </a:pPr>
+            <a:r>
+              <a:rPr lang="en-US" sz="1600" b="1" dirty="0">
+                <a:solidFill>
+                  <a:srgbClr val="1B2A41"/>
+                </a:solidFill>
+                <a:latin typeface="Calibri" pitchFamily="34" charset="0"/>
+                <a:ea typeface="Calibri" pitchFamily="34" charset="-122"/>
+                <a:cs typeface="Calibri" pitchFamily="34" charset="-120"/>
+              </a:rPr>
+              <a:t>外部對照(待核對)</a:t>
+            </a:r>
+            <a:endParaRPr lang="en-US" sz="1600" dirty="0"/>
+          </a:p>
+        </p:txBody>
+      </p:sp>
+      <p:sp>
+        <p:nvSpPr>
+          <p:cNvPr id="12" name="Text 9"/>
+          <p:cNvSpPr txBox="1"/>
+          <p:nvPr/>
+        </p:nvSpPr>
+        <p:spPr>
+          <a:xfrm>
+            <a:off x="5943600" y="3474720"/>
+            <a:ext cx="2560320" cy="1234440"/>
+          </a:xfrm>
+          <a:prstGeom prst="rect">
+            <a:avLst/>
+          </a:prstGeom>
+          <a:noFill/>
+          <a:ln/>
+        </p:spPr>
+        <p:txBody>
+          <a:bodyPr wrap="square" lIns="0" tIns="0" rIns="0" bIns="0" rtlCol="0" anchor="t"/>
+          <a:lstStyle/>
+          <a:p>
             <a:pPr indent="0" marL="0">
               <a:spcAft>
                 <a:spcPts val="400"/>
               </a:spcAft>
               <a:buNone/>
             </a:pPr>
-            <a:endParaRPr lang="en-US" sz="1400" dirty="0"/>
-          </a:p>
-          <a:p>
-            <a:pPr indent="0" marL="0">
-              <a:spcAft>
-                <a:spcPts val="400"/>
-              </a:spcAft>
-              <a:buNone/>
-            </a:pPr>
             <a:r>
               <a:rPr lang="en-US" sz="1400" dirty="0">
                 <a:solidFill>
@@ -6351,73 +6412,7 @@
                 <a:ea typeface="Calibri" pitchFamily="34" charset="-122"/>
                 <a:cs typeface="Calibri" pitchFamily="34" charset="-120"/>
               </a:rPr>
-              <a:t>貼文樣本數:</a:t>
-            </a:r>
-            <a:endParaRPr lang="en-US" sz="1400" dirty="0"/>
-          </a:p>
-          <a:p>
-            <a:pPr indent="0" marL="0">
-              <a:spcAft>
-                <a:spcPts val="400"/>
-              </a:spcAft>
-              <a:buNone/>
-            </a:pPr>
-            <a:r>
-              <a:rPr lang="en-US" sz="1400" b="1" dirty="0">
-                <a:solidFill>
-                  <a:srgbClr val="C8102E"/>
-                </a:solidFill>
-                <a:latin typeface="Calibri" pitchFamily="34" charset="0"/>
-                <a:ea typeface="Calibri" pitchFamily="34" charset="-122"/>
-                <a:cs typeface="Calibri" pitchFamily="34" charset="-120"/>
-              </a:rPr>
-              <a:t>【待補】</a:t>
-            </a:r>
-            <a:pPr indent="0" marL="0">
-              <a:spcAft>
-                <a:spcPts val="400"/>
-              </a:spcAft>
-              <a:buNone/>
-            </a:pPr>
-            <a:endParaRPr lang="en-US" sz="1400" dirty="0"/>
-          </a:p>
-          <a:p>
-            <a:pPr indent="0" marL="0">
-              <a:spcAft>
-                <a:spcPts val="400"/>
-              </a:spcAft>
-              <a:buNone/>
-            </a:pPr>
-            <a:r>
-              <a:rPr lang="en-US" sz="1400" dirty="0">
-                <a:solidFill>
-                  <a:srgbClr val="222222"/>
-                </a:solidFill>
-                <a:latin typeface="Calibri" pitchFamily="34" charset="0"/>
-                <a:ea typeface="Calibri" pitchFamily="34" charset="-122"/>
-                <a:cs typeface="Calibri" pitchFamily="34" charset="-120"/>
-              </a:rPr>
-              <a:t>平均互動(讚 / 留言):</a:t>
-            </a:r>
-            <a:endParaRPr lang="en-US" sz="1400" dirty="0"/>
-          </a:p>
-          <a:p>
-            <a:pPr indent="0" marL="0">
-              <a:spcAft>
-                <a:spcPts val="400"/>
-              </a:spcAft>
-              <a:buNone/>
-            </a:pPr>
-            <a:r>
-              <a:rPr lang="en-US" sz="1400" b="1" dirty="0">
-                <a:solidFill>
-                  <a:srgbClr val="C8102E"/>
-                </a:solidFill>
-                <a:latin typeface="Calibri" pitchFamily="34" charset="0"/>
-                <a:ea typeface="Calibri" pitchFamily="34" charset="-122"/>
-                <a:cs typeface="Calibri" pitchFamily="34" charset="-120"/>
-              </a:rPr>
-              <a:t>【待補】</a:t>
+              <a:t>104 員工調查(2024):求職在意「薪資條件符合期待」64%</a:t>
             </a:r>
             <a:endParaRPr lang="en-US" sz="1400" dirty="0"/>
           </a:p>
@@ -6656,7 +6651,7 @@
                 <a:ea typeface="Calibri" pitchFamily="34" charset="-122"/>
                 <a:cs typeface="Calibri" pitchFamily="34" charset="-120"/>
               </a:rPr>
-              <a:t>薪資仍是求職首要條件,福利是同薪資下的加分項</a:t>
+              <a:t>新鮮人談福利,第一關仍是「錢」:17 則中 14 則提到薪資、獎金或年終</a:t>
             </a:r>
             <a:endParaRPr lang="en-US" sz="1400" dirty="0"/>
           </a:p>
@@ -6677,27 +6672,49 @@
                 <a:ea typeface="Calibri" pitchFamily="34" charset="-122"/>
                 <a:cs typeface="Calibri" pitchFamily="34" charset="-120"/>
               </a:rPr>
-              <a:t>畢業生在乎「看得到、用得到」的福利:工作生活平衡、進修、彈性</a:t>
+              <a:t>其次是「日常體驗」:餐飲零食、彈性/遠端、優於勞基法的休假</a:t>
             </a:r>
             <a:endParaRPr lang="en-US" sz="1400" dirty="0"/>
           </a:p>
           <a:p>
-            <a:pPr indent="0" marL="0">
+            <a:pPr marL="342900" indent="-342900">
               <a:spcAft>
                 <a:spcPts val="400"/>
               </a:spcAft>
-              <a:buNone/>
-            </a:pPr>
-            <a:r>
-              <a:rPr lang="en-US" sz="1400" b="1" dirty="0">
-                <a:solidFill>
-                  <a:srgbClr val="C8102E"/>
-                </a:solidFill>
-                <a:latin typeface="Calibri" pitchFamily="34" charset="0"/>
-                <a:ea typeface="Calibri" pitchFamily="34" charset="-122"/>
-                <a:cs typeface="Calibri" pitchFamily="34" charset="-120"/>
-              </a:rPr>
-              <a:t>【依你的平台觀察補充 1–2 點】</a:t>
+              <a:buSzPct val="100000"/>
+              <a:buChar char="•"/>
+            </a:pPr>
+            <a:r>
+              <a:rPr lang="en-US" sz="1400" dirty="0">
+                <a:solidFill>
+                  <a:srgbClr val="222222"/>
+                </a:solidFill>
+                <a:latin typeface="Calibri" pitchFamily="34" charset="0"/>
+                <a:ea typeface="Calibri" pitchFamily="34" charset="-122"/>
+                <a:cs typeface="Calibri" pitchFamily="34" charset="-120"/>
+              </a:rPr>
+              <a:t>小確幸(生日、蛋糕、零食)互動雖低,卻最容易引發羨慕與分享</a:t>
+            </a:r>
+            <a:endParaRPr lang="en-US" sz="1400" dirty="0"/>
+          </a:p>
+          <a:p>
+            <a:pPr marL="342900" indent="-342900">
+              <a:spcAft>
+                <a:spcPts val="400"/>
+              </a:spcAft>
+              <a:buSzPct val="100000"/>
+              <a:buChar char="•"/>
+            </a:pPr>
+            <a:r>
+              <a:rPr lang="en-US" sz="1400" dirty="0">
+                <a:solidFill>
+                  <a:srgbClr val="222222"/>
+                </a:solidFill>
+                <a:latin typeface="Calibri" pitchFamily="34" charset="0"/>
+                <a:ea typeface="Calibri" pitchFamily="34" charset="-122"/>
+                <a:cs typeface="Calibri" pitchFamily="34" charset="-120"/>
+              </a:rPr>
+              <a:t>也有人提醒:員工旅遊、聚餐若不能折現,對內向者是負擔</a:t>
             </a:r>
             <a:endParaRPr lang="en-US" sz="1400" dirty="0"/>
           </a:p>
@@ -6806,7 +6823,7 @@
                 <a:ea typeface="Calibri" pitchFamily="34" charset="-122"/>
                 <a:cs typeface="Calibri" pitchFamily="34" charset="-120"/>
               </a:rPr>
-              <a:t>中華汽車曾獲勞動部「工作生活平衡獎」(2014、2022),可作為雇主品牌亮點</a:t>
+              <a:t>招募溝通先講清楚薪資結構、年終與獎金,再談其他福利</a:t>
             </a:r>
             <a:endParaRPr lang="en-US" sz="1400" dirty="0"/>
           </a:p>
@@ -6827,27 +6844,49 @@
                 <a:ea typeface="Calibri" pitchFamily="34" charset="-122"/>
                 <a:cs typeface="Calibri" pitchFamily="34" charset="-120"/>
               </a:rPr>
-              <a:t>在校園活動與社群中,把福利與真實員工故事一起呈現</a:t>
+              <a:t>把彈性、休假與員工日常的小確幸做成真實員工故事,放在校園與社群</a:t>
             </a:r>
             <a:endParaRPr lang="en-US" sz="1400" dirty="0"/>
           </a:p>
           <a:p>
-            <a:pPr indent="0" marL="0">
+            <a:pPr marL="342900" indent="-342900">
               <a:spcAft>
                 <a:spcPts val="400"/>
               </a:spcAft>
-              <a:buNone/>
-            </a:pPr>
-            <a:r>
-              <a:rPr lang="en-US" sz="1400" b="1" dirty="0">
-                <a:solidFill>
-                  <a:srgbClr val="C8102E"/>
-                </a:solidFill>
-                <a:latin typeface="Calibri" pitchFamily="34" charset="0"/>
-                <a:ea typeface="Calibri" pitchFamily="34" charset="-122"/>
-                <a:cs typeface="Calibri" pitchFamily="34" charset="-120"/>
-              </a:rPr>
-              <a:t>【可補充具體建議】</a:t>
+              <a:buSzPct val="100000"/>
+              <a:buChar char="•"/>
+            </a:pPr>
+            <a:r>
+              <a:rPr lang="en-US" sz="1400" dirty="0">
+                <a:solidFill>
+                  <a:srgbClr val="222222"/>
+                </a:solidFill>
+                <a:latin typeface="Calibri" pitchFamily="34" charset="0"/>
+                <a:ea typeface="Calibri" pitchFamily="34" charset="-122"/>
+                <a:cs typeface="Calibri" pitchFamily="34" charset="-120"/>
+              </a:rPr>
+              <a:t>校園活動(如研習營)可穿插福利 Q&amp;A,回應新鮮人最常問的問題</a:t>
+            </a:r>
+            <a:endParaRPr lang="en-US" sz="1400" dirty="0"/>
+          </a:p>
+          <a:p>
+            <a:pPr marL="342900" indent="-342900">
+              <a:spcAft>
+                <a:spcPts val="400"/>
+              </a:spcAft>
+              <a:buSzPct val="100000"/>
+              <a:buChar char="•"/>
+            </a:pPr>
+            <a:r>
+              <a:rPr lang="en-US" sz="1400" dirty="0">
+                <a:solidFill>
+                  <a:srgbClr val="222222"/>
+                </a:solidFill>
+                <a:latin typeface="Calibri" pitchFamily="34" charset="0"/>
+                <a:ea typeface="Calibri" pitchFamily="34" charset="-122"/>
+                <a:cs typeface="Calibri" pitchFamily="34" charset="-120"/>
+              </a:rPr>
+              <a:t>中華汽車工作生活平衡獎(2014、2022)可作亮點</a:t>
             </a:r>
             <a:endParaRPr lang="en-US" sz="1400" dirty="0"/>
           </a:p>

</xml_diff>

<commit_message>
Revise deck: cropped screenshots, CMC benefits comparison, layout fixes
Co-Authored-By: Claude Sonnet 5.5 <noreply@anthropic.com>
Claude-Session: https://claude.ai/code/session_01YWYmCoF2kfC3GxD29xN2Db
</commit_message>
<xml_diff>
--- a/deliverables/CMC_10月_AB任務簡報.pptx
+++ b/deliverables/CMC_10月_AB任務簡報.pptx
@@ -15,9 +15,10 @@
     <p:sldId id="263" r:id="rId9"/>
     <p:sldId id="264" r:id="rId10"/>
     <p:sldId id="265" r:id="rId11"/>
+    <p:sldId id="266" r:id="rId12"/>
   </p:sldIdLst>
   <p:notesMasterIdLst>
-    <p:notesMasterId r:id="rId12"/>
+    <p:notesMasterId r:id="rId13"/>
   </p:notesMasterIdLst>
   <p:sldSz cx="9144000" cy="5143500"/>
   <p:notesSz cx="5143500" cy="9144000"/>
@@ -918,6 +919,94 @@
             <a:fld id="{F7021451-1387-4CA6-816F-3879F97B5CBC}" type="slidenum">
               <a:rPr lang="en-US"/>
               <a:t>10</a:t>
+            </a:fld>
+            <a:endParaRPr lang="en-US"/>
+          </a:p>
+        </p:txBody>
+      </p:sp>
+    </p:spTree>
+    <p:extLst>
+      <p:ext uri="{BB962C8B-B14F-4D97-AF65-F5344CB8AC3E}">
+        <p14:creationId xmlns:p14="http://schemas.microsoft.com/office/powerpoint/2010/main" val="1024086991"/>
+      </p:ext>
+    </p:extLst>
+  </p:cSld>
+  <p:clrMapOvr>
+    <a:masterClrMapping/>
+  </p:clrMapOvr>
+</p:notes>
+</file>
+
+<file path=ppt/notesSlides/notesSlide11.xml><?xml version="1.0" encoding="utf-8"?>
+<p:notes xmlns:a="http://schemas.openxmlformats.org/drawingml/2006/main" xmlns:r="http://schemas.openxmlformats.org/officeDocument/2006/relationships" xmlns:p="http://schemas.openxmlformats.org/presentationml/2006/main">
+  <p:cSld>
+    <p:spTree>
+      <p:nvGrpSpPr>
+        <p:cNvPr id="1" name=""/>
+        <p:cNvGrpSpPr/>
+        <p:nvPr/>
+      </p:nvGrpSpPr>
+      <p:grpSpPr>
+        <a:xfrm>
+          <a:off x="0" y="0"/>
+          <a:ext cx="0" cy="0"/>
+          <a:chOff x="0" y="0"/>
+          <a:chExt cx="0" cy="0"/>
+        </a:xfrm>
+      </p:grpSpPr>
+      <p:sp>
+        <p:nvSpPr>
+          <p:cNvPr id="2" name="Slide Image Placeholder 1"/>
+          <p:cNvSpPr>
+            <a:spLocks noGrp="1" noRot="1" noChangeAspect="1"/>
+          </p:cNvSpPr>
+          <p:nvPr>
+            <p:ph type="sldImg"/>
+          </p:nvPr>
+        </p:nvSpPr>
+        <p:spPr/>
+      </p:sp>
+      <p:sp>
+        <p:nvSpPr>
+          <p:cNvPr id="3" name="Notes Placeholder 2"/>
+          <p:cNvSpPr>
+            <a:spLocks noGrp="1"/>
+          </p:cNvSpPr>
+          <p:nvPr>
+            <p:ph type="body" idx="1"/>
+          </p:nvPr>
+        </p:nvSpPr>
+        <p:spPr/>
+        <p:txBody>
+          <a:bodyPr/>
+          <a:lstStyle/>
+          <a:p>
+            <a:r>
+              <a:rPr lang="en-US" dirty="0"/>
+              <a:t/>
+            </a:r>
+            <a:endParaRPr lang="en-US" dirty="0"/>
+          </a:p>
+        </p:txBody>
+      </p:sp>
+      <p:sp>
+        <p:nvSpPr>
+          <p:cNvPr id="4" name="Slide Number Placeholder 3"/>
+          <p:cNvSpPr>
+            <a:spLocks noGrp="1"/>
+          </p:cNvSpPr>
+          <p:nvPr>
+            <p:ph type="sldNum" sz="quarter" idx="10"/>
+          </p:nvPr>
+        </p:nvSpPr>
+        <p:spPr/>
+        <p:txBody>
+          <a:bodyPr/>
+          <a:lstStyle/>
+          <a:p>
+            <a:fld id="{F7021451-1387-4CA6-816F-3879F97B5CBC}" type="slidenum">
+              <a:rPr lang="en-US"/>
+              <a:t>11</a:t>
             </a:fld>
             <a:endParaRPr lang="en-US"/>
           </a:p>
@@ -2058,7 +2147,7 @@
         <p:spPr>
           <a:xfrm>
             <a:off x="640080" y="2743200"/>
-            <a:ext cx="7863840" cy="1188720"/>
+            <a:ext cx="6766560" cy="1188720"/>
           </a:xfrm>
           <a:prstGeom prst="rect">
             <a:avLst/>
@@ -2085,7 +2174,7 @@
                 <a:ea typeface="Calibri" pitchFamily="34" charset="-122"/>
                 <a:cs typeface="Calibri" pitchFamily="34" charset="-120"/>
               </a:rPr>
-              <a:t>任務月份:10 月</a:t>
+              <a:t>大使姓名/學校:簡懷辰 / 元智大學</a:t>
             </a:r>
             <a:endParaRPr lang="en-US" sz="1800" dirty="0"/>
           </a:p>
@@ -2105,7 +2194,7 @@
                 <a:ea typeface="Calibri" pitchFamily="34" charset="-122"/>
                 <a:cs typeface="Calibri" pitchFamily="34" charset="-120"/>
               </a:rPr>
-              <a:t>A. 社群內容創作 ・ B. 趨勢觀察</a:t>
+              <a:t>任務月份:10 月</a:t>
             </a:r>
             <a:endParaRPr lang="en-US" sz="1800" dirty="0"/>
           </a:p>
@@ -2125,24 +2214,7 @@
                 <a:ea typeface="Calibri" pitchFamily="34" charset="-122"/>
                 <a:cs typeface="Calibri" pitchFamily="34" charset="-120"/>
               </a:rPr>
-              <a:t>大使姓名/學校:</a:t>
-            </a:r>
-            <a:pPr indent="0" marL="0">
-              <a:spcAft>
-                <a:spcPts val="600"/>
-              </a:spcAft>
-              <a:buNone/>
-            </a:pPr>
-            <a:r>
-              <a:rPr lang="en-US" sz="1800" b="1" dirty="0">
-                <a:solidFill>
-                  <a:srgbClr val="C8102E"/>
-                </a:solidFill>
-                <a:latin typeface="Calibri" pitchFamily="34" charset="0"/>
-                <a:ea typeface="Calibri" pitchFamily="34" charset="-122"/>
-                <a:cs typeface="Calibri" pitchFamily="34" charset="-120"/>
-              </a:rPr>
-              <a:t>【請填寫姓名 / 學校】</a:t>
+              <a:t>A. 社群內容創作 ・ B. 趨勢觀察</a:t>
             </a:r>
             <a:endParaRPr lang="en-US" sz="1800" dirty="0"/>
           </a:p>
@@ -2241,14 +2313,34 @@
       </p:grpSpPr>
       <p:sp>
         <p:nvSpPr>
-          <p:cNvPr id="2" name="Text 0"/>
+          <p:cNvPr id="2" name="Shape 0"/>
+          <p:cNvSpPr/>
+          <p:nvPr/>
+        </p:nvSpPr>
+        <p:spPr>
+          <a:xfrm>
+            <a:off x="457200" y="347472"/>
+            <a:ext cx="457200" cy="457200"/>
+          </a:xfrm>
+          <a:prstGeom prst="ellipse">
+            <a:avLst/>
+          </a:prstGeom>
+          <a:solidFill>
+            <a:srgbClr val="1B2A41"/>
+          </a:solidFill>
+          <a:ln/>
+        </p:spPr>
+      </p:sp>
+      <p:sp>
+        <p:nvSpPr>
+          <p:cNvPr id="3" name="Text 1"/>
           <p:cNvSpPr txBox="1"/>
           <p:nvPr/>
         </p:nvSpPr>
         <p:spPr>
           <a:xfrm>
-            <a:off x="457200" y="320040"/>
-            <a:ext cx="7589520" cy="502920"/>
+            <a:off x="457200" y="347472"/>
+            <a:ext cx="457200" cy="457200"/>
           </a:xfrm>
           <a:prstGeom prst="rect">
             <a:avLst/>
@@ -2260,6 +2352,45 @@
           <a:bodyPr wrap="square" lIns="0" tIns="0" rIns="0" bIns="0" rtlCol="0" anchor="ctr"/>
           <a:lstStyle/>
           <a:p>
+            <a:pPr algn="ctr" indent="0" marL="0">
+              <a:buNone/>
+            </a:pPr>
+            <a:r>
+              <a:rPr lang="en-US" sz="1800" b="1" dirty="0">
+                <a:solidFill>
+                  <a:srgbClr val="FFFFFF"/>
+                </a:solidFill>
+                <a:latin typeface="Calibri" pitchFamily="34" charset="0"/>
+                <a:ea typeface="Calibri" pitchFamily="34" charset="-122"/>
+                <a:cs typeface="Calibri" pitchFamily="34" charset="-120"/>
+              </a:rPr>
+              <a:t>B</a:t>
+            </a:r>
+            <a:endParaRPr lang="en-US" sz="1800" dirty="0"/>
+          </a:p>
+        </p:txBody>
+      </p:sp>
+      <p:sp>
+        <p:nvSpPr>
+          <p:cNvPr id="4" name="Text 2"/>
+          <p:cNvSpPr txBox="1"/>
+          <p:nvPr/>
+        </p:nvSpPr>
+        <p:spPr>
+          <a:xfrm>
+            <a:off x="1051560" y="320040"/>
+            <a:ext cx="7589520" cy="502920"/>
+          </a:xfrm>
+          <a:prstGeom prst="rect">
+            <a:avLst/>
+          </a:prstGeom>
+          <a:noFill/>
+          <a:ln/>
+        </p:spPr>
+        <p:txBody>
+          <a:bodyPr wrap="square" lIns="0" tIns="0" rIns="0" bIns="0" rtlCol="0" anchor="ctr"/>
+          <a:lstStyle/>
+          <a:p>
             <a:pPr indent="0" marL="0">
               <a:buNone/>
             </a:pPr>
@@ -2272,7 +2403,7 @@
                 <a:ea typeface="Calibri" pitchFamily="34" charset="-122"/>
                 <a:cs typeface="Calibri" pitchFamily="34" charset="-120"/>
               </a:rPr>
-              <a:t>執行心得或意見</a:t>
+              <a:t>分析與建議</a:t>
             </a:r>
             <a:endParaRPr lang="en-US" sz="2600" dirty="0"/>
           </a:p>
@@ -2280,18 +2411,18 @@
       </p:sp>
       <p:sp>
         <p:nvSpPr>
-          <p:cNvPr id="3" name="Shape 1"/>
+          <p:cNvPr id="5" name="Shape 3"/>
           <p:cNvSpPr/>
           <p:nvPr/>
         </p:nvSpPr>
         <p:spPr>
           <a:xfrm>
             <a:off x="457200" y="1051560"/>
-            <a:ext cx="4023360" cy="3566160"/>
+            <a:ext cx="4023360" cy="3749040"/>
           </a:xfrm>
           <a:prstGeom prst="roundRect">
             <a:avLst>
-              <a:gd name="adj" fmla="val 2051"/>
+              <a:gd name="adj" fmla="val 1951"/>
             </a:avLst>
           </a:prstGeom>
           <a:solidFill>
@@ -2307,7 +2438,7 @@
       </p:sp>
       <p:sp>
         <p:nvSpPr>
-          <p:cNvPr id="4" name="Text 2"/>
+          <p:cNvPr id="6" name="Text 4"/>
           <p:cNvSpPr txBox="1"/>
           <p:nvPr/>
         </p:nvSpPr>
@@ -2332,13 +2463,13 @@
             <a:r>
               <a:rPr lang="en-US" sz="1600" b="1" dirty="0">
                 <a:solidFill>
-                  <a:srgbClr val="C8102E"/>
-                </a:solidFill>
-                <a:latin typeface="Calibri" pitchFamily="34" charset="0"/>
-                <a:ea typeface="Calibri" pitchFamily="34" charset="-122"/>
-                <a:cs typeface="Calibri" pitchFamily="34" charset="-120"/>
-              </a:rPr>
-              <a:t>A 任務心得</a:t>
+                  <a:srgbClr val="1B2A41"/>
+                </a:solidFill>
+                <a:latin typeface="Calibri" pitchFamily="34" charset="0"/>
+                <a:ea typeface="Calibri" pitchFamily="34" charset="-122"/>
+                <a:cs typeface="Calibri" pitchFamily="34" charset="-120"/>
+              </a:rPr>
+              <a:t>觀察分析</a:t>
             </a:r>
             <a:endParaRPr lang="en-US" sz="1600" dirty="0"/>
           </a:p>
@@ -2346,14 +2477,14 @@
       </p:sp>
       <p:sp>
         <p:nvSpPr>
-          <p:cNvPr id="5" name="Text 3"/>
+          <p:cNvPr id="7" name="Text 5"/>
           <p:cNvSpPr txBox="1"/>
           <p:nvPr/>
         </p:nvSpPr>
         <p:spPr>
           <a:xfrm>
-            <a:off x="640080" y="1554480"/>
-            <a:ext cx="3657600" cy="2971800"/>
+            <a:off x="640080" y="1581912"/>
+            <a:ext cx="3657600" cy="3063240"/>
           </a:xfrm>
           <a:prstGeom prst="rect">
             <a:avLst/>
@@ -2365,41 +2496,84 @@
           <a:bodyPr wrap="square" lIns="0" tIns="0" rIns="0" bIns="0" rtlCol="0" anchor="t"/>
           <a:lstStyle/>
           <a:p>
-            <a:pPr indent="0" marL="0">
+            <a:pPr marL="342900" indent="-342900">
               <a:spcAft>
                 <a:spcPts val="400"/>
               </a:spcAft>
-              <a:buNone/>
-            </a:pPr>
-            <a:r>
-              <a:rPr lang="en-US" sz="1400" b="1" dirty="0">
-                <a:solidFill>
-                  <a:srgbClr val="C8102E"/>
-                </a:solidFill>
-                <a:latin typeface="Calibri" pitchFamily="34" charset="0"/>
-                <a:ea typeface="Calibri" pitchFamily="34" charset="-122"/>
-                <a:cs typeface="Calibri" pitchFamily="34" charset="-120"/>
-              </a:rPr>
-              <a:t>【待補:例如拍攝挑戰、互動回饋、學到什麼】</a:t>
-            </a:r>
-            <a:endParaRPr lang="en-US" sz="1400" dirty="0"/>
-          </a:p>
-        </p:txBody>
-      </p:sp>
-      <p:sp>
-        <p:nvSpPr>
-          <p:cNvPr id="6" name="Shape 4"/>
+              <a:buSzPct val="100000"/>
+              <a:buChar char="•"/>
+            </a:pPr>
+            <a:r>
+              <a:rPr lang="en-US" sz="1300" dirty="0">
+                <a:solidFill>
+                  <a:srgbClr val="222222"/>
+                </a:solidFill>
+                <a:latin typeface="Calibri" pitchFamily="34" charset="0"/>
+                <a:ea typeface="Calibri" pitchFamily="34" charset="-122"/>
+                <a:cs typeface="Calibri" pitchFamily="34" charset="-120"/>
+              </a:rPr>
+              <a:t>新鮮人談福利,第一關仍是「錢」:17 則中 14 則提到薪資、獎金或年終</a:t>
+            </a:r>
+            <a:endParaRPr lang="en-US" sz="1300" dirty="0"/>
+          </a:p>
+          <a:p>
+            <a:pPr marL="342900" indent="-342900">
+              <a:spcAft>
+                <a:spcPts val="400"/>
+              </a:spcAft>
+              <a:buSzPct val="100000"/>
+              <a:buChar char="•"/>
+            </a:pPr>
+            <a:r>
+              <a:rPr lang="en-US" sz="1300" dirty="0">
+                <a:solidFill>
+                  <a:srgbClr val="222222"/>
+                </a:solidFill>
+                <a:latin typeface="Calibri" pitchFamily="34" charset="0"/>
+                <a:ea typeface="Calibri" pitchFamily="34" charset="-122"/>
+                <a:cs typeface="Calibri" pitchFamily="34" charset="-120"/>
+              </a:rPr>
+              <a:t>其次是日常體驗:餐飲零食、彈性遠端、優於勞基法的休假</a:t>
+            </a:r>
+            <a:endParaRPr lang="en-US" sz="1300" dirty="0"/>
+          </a:p>
+          <a:p>
+            <a:pPr marL="342900" indent="-342900">
+              <a:spcAft>
+                <a:spcPts val="400"/>
+              </a:spcAft>
+              <a:buSzPct val="100000"/>
+              <a:buChar char="•"/>
+            </a:pPr>
+            <a:r>
+              <a:rPr lang="en-US" sz="1300" dirty="0">
+                <a:solidFill>
+                  <a:srgbClr val="222222"/>
+                </a:solidFill>
+                <a:latin typeface="Calibri" pitchFamily="34" charset="0"/>
+                <a:ea typeface="Calibri" pitchFamily="34" charset="-122"/>
+                <a:cs typeface="Calibri" pitchFamily="34" charset="-120"/>
+              </a:rPr>
+              <a:t>小確幸互動不高,卻最容易引發羨慕與分享</a:t>
+            </a:r>
+            <a:endParaRPr lang="en-US" sz="1300" dirty="0"/>
+          </a:p>
+        </p:txBody>
+      </p:sp>
+      <p:sp>
+        <p:nvSpPr>
+          <p:cNvPr id="8" name="Shape 6"/>
           <p:cNvSpPr/>
           <p:nvPr/>
         </p:nvSpPr>
         <p:spPr>
           <a:xfrm>
             <a:off x="4663440" y="1051560"/>
-            <a:ext cx="4023360" cy="3566160"/>
+            <a:ext cx="4023360" cy="3749040"/>
           </a:xfrm>
           <a:prstGeom prst="roundRect">
             <a:avLst>
-              <a:gd name="adj" fmla="val 2051"/>
+              <a:gd name="adj" fmla="val 1951"/>
             </a:avLst>
           </a:prstGeom>
           <a:solidFill>
@@ -2415,7 +2589,7 @@
       </p:sp>
       <p:sp>
         <p:nvSpPr>
-          <p:cNvPr id="7" name="Text 5"/>
+          <p:cNvPr id="9" name="Text 7"/>
           <p:cNvSpPr txBox="1"/>
           <p:nvPr/>
         </p:nvSpPr>
@@ -2440,13 +2614,235 @@
             <a:r>
               <a:rPr lang="en-US" sz="1600" b="1" dirty="0">
                 <a:solidFill>
+                  <a:srgbClr val="C8102E"/>
+                </a:solidFill>
+                <a:latin typeface="Calibri" pitchFamily="34" charset="0"/>
+                <a:ea typeface="Calibri" pitchFamily="34" charset="-122"/>
+                <a:cs typeface="Calibri" pitchFamily="34" charset="-120"/>
+              </a:rPr>
+              <a:t>對中華汽車的建議</a:t>
+            </a:r>
+            <a:endParaRPr lang="en-US" sz="1600" dirty="0"/>
+          </a:p>
+        </p:txBody>
+      </p:sp>
+      <p:sp>
+        <p:nvSpPr>
+          <p:cNvPr id="10" name="Text 8"/>
+          <p:cNvSpPr txBox="1"/>
+          <p:nvPr/>
+        </p:nvSpPr>
+        <p:spPr>
+          <a:xfrm>
+            <a:off x="4846320" y="1581912"/>
+            <a:ext cx="3657600" cy="3063240"/>
+          </a:xfrm>
+          <a:prstGeom prst="rect">
+            <a:avLst/>
+          </a:prstGeom>
+          <a:noFill/>
+          <a:ln/>
+        </p:spPr>
+        <p:txBody>
+          <a:bodyPr wrap="square" lIns="0" tIns="0" rIns="0" bIns="0" rtlCol="0" anchor="t"/>
+          <a:lstStyle/>
+          <a:p>
+            <a:pPr marL="342900" indent="-342900">
+              <a:spcAft>
+                <a:spcPts val="400"/>
+              </a:spcAft>
+              <a:buSzPct val="100000"/>
+              <a:buChar char="•"/>
+            </a:pPr>
+            <a:r>
+              <a:rPr lang="en-US" sz="1300" dirty="0">
+                <a:solidFill>
+                  <a:srgbClr val="222222"/>
+                </a:solidFill>
+                <a:latin typeface="Calibri" pitchFamily="34" charset="0"/>
+                <a:ea typeface="Calibri" pitchFamily="34" charset="-122"/>
+                <a:cs typeface="Calibri" pitchFamily="34" charset="-120"/>
+              </a:rPr>
+              <a:t>薪資與年終是新鮮人最在意的項目,中華汽車已有制度,招募溝通宜優先說清楚</a:t>
+            </a:r>
+            <a:endParaRPr lang="en-US" sz="1300" dirty="0"/>
+          </a:p>
+          <a:p>
+            <a:pPr marL="342900" indent="-342900">
+              <a:spcAft>
+                <a:spcPts val="400"/>
+              </a:spcAft>
+              <a:buSzPct val="100000"/>
+              <a:buChar char="•"/>
+            </a:pPr>
+            <a:r>
+              <a:rPr lang="en-US" sz="1300" dirty="0">
+                <a:solidFill>
+                  <a:srgbClr val="222222"/>
+                </a:solidFill>
+                <a:latin typeface="Calibri" pitchFamily="34" charset="0"/>
+                <a:ea typeface="Calibri" pitchFamily="34" charset="-122"/>
+                <a:cs typeface="Calibri" pitchFamily="34" charset="-120"/>
+              </a:rPr>
+              <a:t>彈性上班、寒暑假、餐廳等福利做成真實員工故事,放到校園與社群</a:t>
+            </a:r>
+            <a:endParaRPr lang="en-US" sz="1300" dirty="0"/>
+          </a:p>
+          <a:p>
+            <a:pPr marL="342900" indent="-342900">
+              <a:spcAft>
+                <a:spcPts val="400"/>
+              </a:spcAft>
+              <a:buSzPct val="100000"/>
+              <a:buChar char="•"/>
+            </a:pPr>
+            <a:r>
+              <a:rPr lang="en-US" sz="1300" dirty="0">
+                <a:solidFill>
+                  <a:srgbClr val="222222"/>
+                </a:solidFill>
+                <a:latin typeface="Calibri" pitchFamily="34" charset="0"/>
+                <a:ea typeface="Calibri" pitchFamily="34" charset="-122"/>
+                <a:cs typeface="Calibri" pitchFamily="34" charset="-120"/>
+              </a:rPr>
+              <a:t>研習營等活動可加入福利 Q&amp;A</a:t>
+            </a:r>
+            <a:endParaRPr lang="en-US" sz="1300" dirty="0"/>
+          </a:p>
+        </p:txBody>
+      </p:sp>
+    </p:spTree>
+  </p:cSld>
+  <p:clrMapOvr>
+    <a:masterClrMapping/>
+  </p:clrMapOvr>
+</p:sld>
+</file>
+
+<file path=ppt/slides/slide11.xml><?xml version="1.0" encoding="utf-8"?>
+<p:sld xmlns:a="http://schemas.openxmlformats.org/drawingml/2006/main" xmlns:r="http://schemas.openxmlformats.org/officeDocument/2006/relationships" xmlns:p="http://schemas.openxmlformats.org/presentationml/2006/main">
+  <p:cSld name="Slide 11">
+    <p:bg>
+      <p:bgPr>
+        <a:solidFill>
+          <a:srgbClr val="FFFFFF"/>
+        </a:solidFill>
+      </p:bgPr>
+    </p:bg>
+    <p:spTree>
+      <p:nvGrpSpPr>
+        <p:cNvPr id="1" name=""/>
+        <p:cNvGrpSpPr/>
+        <p:nvPr/>
+      </p:nvGrpSpPr>
+      <p:grpSpPr>
+        <a:xfrm>
+          <a:off x="0" y="0"/>
+          <a:ext cx="0" cy="0"/>
+          <a:chOff x="0" y="0"/>
+          <a:chExt cx="0" cy="0"/>
+        </a:xfrm>
+      </p:grpSpPr>
+      <p:sp>
+        <p:nvSpPr>
+          <p:cNvPr id="2" name="Text 0"/>
+          <p:cNvSpPr txBox="1"/>
+          <p:nvPr/>
+        </p:nvSpPr>
+        <p:spPr>
+          <a:xfrm>
+            <a:off x="457200" y="320040"/>
+            <a:ext cx="7589520" cy="502920"/>
+          </a:xfrm>
+          <a:prstGeom prst="rect">
+            <a:avLst/>
+          </a:prstGeom>
+          <a:noFill/>
+          <a:ln/>
+        </p:spPr>
+        <p:txBody>
+          <a:bodyPr wrap="square" lIns="0" tIns="0" rIns="0" bIns="0" rtlCol="0" anchor="ctr"/>
+          <a:lstStyle/>
+          <a:p>
+            <a:pPr indent="0" marL="0">
+              <a:buNone/>
+            </a:pPr>
+            <a:r>
+              <a:rPr lang="en-US" sz="2600" b="1" dirty="0">
+                <a:solidFill>
                   <a:srgbClr val="1B2A41"/>
                 </a:solidFill>
                 <a:latin typeface="Calibri" pitchFamily="34" charset="0"/>
                 <a:ea typeface="Calibri" pitchFamily="34" charset="-122"/>
                 <a:cs typeface="Calibri" pitchFamily="34" charset="-120"/>
               </a:rPr>
-              <a:t>B 任務心得</a:t>
+              <a:t>執行心得或意見</a:t>
+            </a:r>
+            <a:endParaRPr lang="en-US" sz="2600" dirty="0"/>
+          </a:p>
+        </p:txBody>
+      </p:sp>
+      <p:sp>
+        <p:nvSpPr>
+          <p:cNvPr id="3" name="Shape 1"/>
+          <p:cNvSpPr/>
+          <p:nvPr/>
+        </p:nvSpPr>
+        <p:spPr>
+          <a:xfrm>
+            <a:off x="457200" y="1051560"/>
+            <a:ext cx="4023360" cy="3749040"/>
+          </a:xfrm>
+          <a:prstGeom prst="roundRect">
+            <a:avLst>
+              <a:gd name="adj" fmla="val 1951"/>
+            </a:avLst>
+          </a:prstGeom>
+          <a:solidFill>
+            <a:srgbClr val="F3F5F8"/>
+          </a:solidFill>
+          <a:ln w="12700">
+            <a:solidFill>
+              <a:srgbClr val="F3F5F8"/>
+            </a:solidFill>
+            <a:prstDash val="solid"/>
+          </a:ln>
+        </p:spPr>
+      </p:sp>
+      <p:sp>
+        <p:nvSpPr>
+          <p:cNvPr id="4" name="Text 2"/>
+          <p:cNvSpPr txBox="1"/>
+          <p:nvPr/>
+        </p:nvSpPr>
+        <p:spPr>
+          <a:xfrm>
+            <a:off x="640080" y="1161288"/>
+            <a:ext cx="3657600" cy="365760"/>
+          </a:xfrm>
+          <a:prstGeom prst="rect">
+            <a:avLst/>
+          </a:prstGeom>
+          <a:noFill/>
+          <a:ln/>
+        </p:spPr>
+        <p:txBody>
+          <a:bodyPr wrap="square" lIns="0" tIns="0" rIns="0" bIns="0" rtlCol="0" anchor="ctr"/>
+          <a:lstStyle/>
+          <a:p>
+            <a:pPr indent="0" marL="0">
+              <a:buNone/>
+            </a:pPr>
+            <a:r>
+              <a:rPr lang="en-US" sz="1600" b="1" dirty="0">
+                <a:solidFill>
+                  <a:srgbClr val="C8102E"/>
+                </a:solidFill>
+                <a:latin typeface="Calibri" pitchFamily="34" charset="0"/>
+                <a:ea typeface="Calibri" pitchFamily="34" charset="-122"/>
+                <a:cs typeface="Calibri" pitchFamily="34" charset="-120"/>
+              </a:rPr>
+              <a:t>A 任務心得</a:t>
             </a:r>
             <a:endParaRPr lang="en-US" sz="1600" dirty="0"/>
           </a:p>
@@ -2454,14 +2850,14 @@
       </p:sp>
       <p:sp>
         <p:nvSpPr>
-          <p:cNvPr id="8" name="Text 6"/>
+          <p:cNvPr id="5" name="Text 3"/>
           <p:cNvSpPr txBox="1"/>
           <p:nvPr/>
         </p:nvSpPr>
         <p:spPr>
           <a:xfrm>
-            <a:off x="4846320" y="1554480"/>
-            <a:ext cx="3657600" cy="2971800"/>
+            <a:off x="640080" y="1581912"/>
+            <a:ext cx="3657600" cy="3063240"/>
           </a:xfrm>
           <a:prstGeom prst="rect">
             <a:avLst/>
@@ -2488,7 +2884,115 @@
                 <a:ea typeface="Calibri" pitchFamily="34" charset="-122"/>
                 <a:cs typeface="Calibri" pitchFamily="34" charset="-120"/>
               </a:rPr>
-              <a:t>【待補:例如觀察到的世代想法、對品牌溝通的啟發】</a:t>
+              <a:t>【待補】</a:t>
+            </a:r>
+            <a:endParaRPr lang="en-US" sz="1400" dirty="0"/>
+          </a:p>
+        </p:txBody>
+      </p:sp>
+      <p:sp>
+        <p:nvSpPr>
+          <p:cNvPr id="6" name="Shape 4"/>
+          <p:cNvSpPr/>
+          <p:nvPr/>
+        </p:nvSpPr>
+        <p:spPr>
+          <a:xfrm>
+            <a:off x="4663440" y="1051560"/>
+            <a:ext cx="4023360" cy="3749040"/>
+          </a:xfrm>
+          <a:prstGeom prst="roundRect">
+            <a:avLst>
+              <a:gd name="adj" fmla="val 1951"/>
+            </a:avLst>
+          </a:prstGeom>
+          <a:solidFill>
+            <a:srgbClr val="F3F5F8"/>
+          </a:solidFill>
+          <a:ln w="12700">
+            <a:solidFill>
+              <a:srgbClr val="F3F5F8"/>
+            </a:solidFill>
+            <a:prstDash val="solid"/>
+          </a:ln>
+        </p:spPr>
+      </p:sp>
+      <p:sp>
+        <p:nvSpPr>
+          <p:cNvPr id="7" name="Text 5"/>
+          <p:cNvSpPr txBox="1"/>
+          <p:nvPr/>
+        </p:nvSpPr>
+        <p:spPr>
+          <a:xfrm>
+            <a:off x="4846320" y="1161288"/>
+            <a:ext cx="3657600" cy="365760"/>
+          </a:xfrm>
+          <a:prstGeom prst="rect">
+            <a:avLst/>
+          </a:prstGeom>
+          <a:noFill/>
+          <a:ln/>
+        </p:spPr>
+        <p:txBody>
+          <a:bodyPr wrap="square" lIns="0" tIns="0" rIns="0" bIns="0" rtlCol="0" anchor="ctr"/>
+          <a:lstStyle/>
+          <a:p>
+            <a:pPr indent="0" marL="0">
+              <a:buNone/>
+            </a:pPr>
+            <a:r>
+              <a:rPr lang="en-US" sz="1600" b="1" dirty="0">
+                <a:solidFill>
+                  <a:srgbClr val="1B2A41"/>
+                </a:solidFill>
+                <a:latin typeface="Calibri" pitchFamily="34" charset="0"/>
+                <a:ea typeface="Calibri" pitchFamily="34" charset="-122"/>
+                <a:cs typeface="Calibri" pitchFamily="34" charset="-120"/>
+              </a:rPr>
+              <a:t>B 任務心得</a:t>
+            </a:r>
+            <a:endParaRPr lang="en-US" sz="1600" dirty="0"/>
+          </a:p>
+        </p:txBody>
+      </p:sp>
+      <p:sp>
+        <p:nvSpPr>
+          <p:cNvPr id="8" name="Text 6"/>
+          <p:cNvSpPr txBox="1"/>
+          <p:nvPr/>
+        </p:nvSpPr>
+        <p:spPr>
+          <a:xfrm>
+            <a:off x="4846320" y="1581912"/>
+            <a:ext cx="3657600" cy="3063240"/>
+          </a:xfrm>
+          <a:prstGeom prst="rect">
+            <a:avLst/>
+          </a:prstGeom>
+          <a:noFill/>
+          <a:ln/>
+        </p:spPr>
+        <p:txBody>
+          <a:bodyPr wrap="square" lIns="0" tIns="0" rIns="0" bIns="0" rtlCol="0" anchor="t"/>
+          <a:lstStyle/>
+          <a:p>
+            <a:pPr indent="0" marL="0">
+              <a:spcAft>
+                <a:spcPts val="400"/>
+              </a:spcAft>
+              <a:buNone/>
+            </a:pPr>
+            <a:r>
+              <a:rPr lang="en-US" sz="1400" b="1" dirty="0">
+                <a:solidFill>
+                  <a:srgbClr val="C8102E"/>
+                </a:solidFill>
+                <a:latin typeface="Calibri" pitchFamily="34" charset="0"/>
+                <a:ea typeface="Calibri" pitchFamily="34" charset="-122"/>
+                <a:cs typeface="Calibri" pitchFamily="34" charset="-120"/>
+              </a:rPr>
+              <a:t>【待補】</a:t>
             </a:r>
             <a:endParaRPr lang="en-US" sz="1400" dirty="0"/>
           </a:p>
@@ -2574,11 +3078,11 @@
         <p:spPr>
           <a:xfrm>
             <a:off x="457200" y="1051560"/>
-            <a:ext cx="4023360" cy="2148840"/>
+            <a:ext cx="4023360" cy="2194560"/>
           </a:xfrm>
           <a:prstGeom prst="roundRect">
             <a:avLst>
-              <a:gd name="adj" fmla="val 3404"/>
+              <a:gd name="adj" fmla="val 3333"/>
             </a:avLst>
           </a:prstGeom>
           <a:solidFill>
@@ -2639,8 +3143,8 @@
         </p:nvSpPr>
         <p:spPr>
           <a:xfrm>
-            <a:off x="640080" y="1554480"/>
-            <a:ext cx="3657600" cy="1554480"/>
+            <a:off x="640080" y="1581912"/>
+            <a:ext cx="3657600" cy="1508760"/>
           </a:xfrm>
           <a:prstGeom prst="rect">
             <a:avLst/>
@@ -2725,11 +3229,11 @@
         <p:spPr>
           <a:xfrm>
             <a:off x="4663440" y="1051560"/>
-            <a:ext cx="4023360" cy="2148840"/>
+            <a:ext cx="4023360" cy="2194560"/>
           </a:xfrm>
           <a:prstGeom prst="roundRect">
             <a:avLst>
-              <a:gd name="adj" fmla="val 3404"/>
+              <a:gd name="adj" fmla="val 3333"/>
             </a:avLst>
           </a:prstGeom>
           <a:solidFill>
@@ -2790,8 +3294,8 @@
         </p:nvSpPr>
         <p:spPr>
           <a:xfrm>
-            <a:off x="4846320" y="1554480"/>
-            <a:ext cx="3657600" cy="1554480"/>
+            <a:off x="4846320" y="1581912"/>
+            <a:ext cx="3657600" cy="1508760"/>
           </a:xfrm>
           <a:prstGeom prst="rect">
             <a:avLst/>
@@ -2861,7 +3365,7 @@
                 <a:ea typeface="Calibri" pitchFamily="34" charset="-122"/>
                 <a:cs typeface="Calibri" pitchFamily="34" charset="-120"/>
               </a:rPr>
-              <a:t>形式:第一線觀察 + 分析 + 數據</a:t>
+              <a:t>形式:觀察 + 分析 + 數據</a:t>
             </a:r>
             <a:endParaRPr lang="en-US" sz="1400" dirty="0"/>
           </a:p>
@@ -2875,7 +3379,7 @@
         </p:nvSpPr>
         <p:spPr>
           <a:xfrm>
-            <a:off x="457200" y="3429000"/>
+            <a:off x="457200" y="3474720"/>
             <a:ext cx="8229600" cy="320040"/>
           </a:xfrm>
           <a:prstGeom prst="rect">
@@ -2914,8 +3418,8 @@
         </p:nvSpPr>
         <p:spPr>
           <a:xfrm>
-            <a:off x="457200" y="3794760"/>
-            <a:ext cx="8229600" cy="640080"/>
+            <a:off x="457200" y="3840480"/>
+            <a:ext cx="8229600" cy="731520"/>
           </a:xfrm>
           <a:prstGeom prst="rect">
             <a:avLst/>
@@ -3069,7 +3573,7 @@
                 <a:ea typeface="Calibri" pitchFamily="34" charset="-122"/>
                 <a:cs typeface="Calibri" pitchFamily="34" charset="-120"/>
               </a:rPr>
-              <a:t>A 社群內容創作:基本資訊</a:t>
+              <a:t>社群內容創作:基本資訊</a:t>
             </a:r>
             <a:endParaRPr lang="en-US" sz="2600" dirty="0"/>
           </a:p>
@@ -3193,15 +3697,15 @@
               <a:buNone/>
             </a:pPr>
             <a:r>
-              <a:rPr lang="en-US" sz="1400" b="1" dirty="0">
-                <a:solidFill>
-                  <a:srgbClr val="C8102E"/>
-                </a:solidFill>
-                <a:latin typeface="Calibri" pitchFamily="34" charset="0"/>
-                <a:ea typeface="Calibri" pitchFamily="34" charset="-122"/>
-                <a:cs typeface="Calibri" pitchFamily="34" charset="-120"/>
-              </a:rPr>
-              <a:t>【請填寫姓名 / 學校】</a:t>
+              <a:rPr lang="en-US" sz="1400" dirty="0">
+                <a:solidFill>
+                  <a:srgbClr val="222222"/>
+                </a:solidFill>
+                <a:latin typeface="Calibri" pitchFamily="34" charset="0"/>
+                <a:ea typeface="Calibri" pitchFamily="34" charset="-122"/>
+                <a:cs typeface="Calibri" pitchFamily="34" charset="-120"/>
+              </a:rPr>
+              <a:t>簡懷辰 / 元智大學</a:t>
             </a:r>
             <a:endParaRPr lang="en-US" sz="1400" dirty="0"/>
           </a:p>
@@ -3729,7 +4233,7 @@
                 <a:ea typeface="Calibri" pitchFamily="34" charset="-122"/>
                 <a:cs typeface="Calibri" pitchFamily="34" charset="-120"/>
               </a:rPr>
-              <a:t>https://www.instagram.com/reel/DejgEzCAkPm/</a:t>
+              <a:t>instagram.com/reel/DejgEzCAkPm</a:t>
             </a:r>
             <a:endParaRPr lang="en-US" sz="1400" dirty="0"/>
           </a:p>
@@ -3859,47 +4363,46 @@
                 <a:ea typeface="Calibri" pitchFamily="34" charset="-122"/>
                 <a:cs typeface="Calibri" pitchFamily="34" charset="-120"/>
               </a:rPr>
-              <a:t>A 內容分享與說明:發想與執行方式</a:t>
+              <a:t>內容分享與說明:發想與執行方式</a:t>
             </a:r>
             <a:endParaRPr lang="en-US" sz="2600" dirty="0"/>
           </a:p>
         </p:txBody>
       </p:sp>
-      <p:sp>
-        <p:nvSpPr>
-          <p:cNvPr id="5" name="Shape 3"/>
-          <p:cNvSpPr/>
-          <p:nvPr/>
-        </p:nvSpPr>
+      <p:pic>
+        <p:nvPicPr>
+          <p:cNvPr id="5" name="Image 0" descr="img/reel.jpg">    </p:cNvPr>
+          <p:cNvPicPr>
+            <a:picLocks noChangeAspect="1"/>
+          </p:cNvPicPr>
+          <p:nvPr/>
+        </p:nvPicPr>
+        <p:blipFill>
+          <a:blip r:embed="rId1"/>
+          <a:stretch>
+            <a:fillRect/>
+          </a:stretch>
+        </p:blipFill>
         <p:spPr>
           <a:xfrm>
             <a:off x="457200" y="1051560"/>
-            <a:ext cx="2743200" cy="3566160"/>
-          </a:xfrm>
-          <a:prstGeom prst="rect">
-            <a:avLst/>
-          </a:prstGeom>
-          <a:solidFill>
-            <a:srgbClr val="FFFFFF"/>
-          </a:solidFill>
-          <a:ln w="15875">
-            <a:solidFill>
-              <a:srgbClr val="9AA3B2"/>
-            </a:solidFill>
-            <a:prstDash val="dash"/>
-          </a:ln>
-        </p:spPr>
-      </p:sp>
-      <p:sp>
-        <p:nvSpPr>
-          <p:cNvPr id="6" name="Text 4"/>
+            <a:ext cx="3200400" cy="2322576"/>
+          </a:xfrm>
+          <a:prstGeom prst="rect">
+            <a:avLst/>
+          </a:prstGeom>
+        </p:spPr>
+      </p:pic>
+      <p:sp>
+        <p:nvSpPr>
+          <p:cNvPr id="6" name="Text 3"/>
           <p:cNvSpPr txBox="1"/>
           <p:nvPr/>
         </p:nvSpPr>
         <p:spPr>
           <a:xfrm>
-            <a:off x="457200" y="1051560"/>
-            <a:ext cx="2743200" cy="3566160"/>
+            <a:off x="457200" y="3429000"/>
+            <a:ext cx="3200400" cy="320040"/>
           </a:xfrm>
           <a:prstGeom prst="rect">
             <a:avLst/>
@@ -3908,14 +4411,14 @@
           <a:ln/>
         </p:spPr>
         <p:txBody>
-          <a:bodyPr wrap="square" rtlCol="0" anchor="ctr"/>
-          <a:lstStyle/>
-          <a:p>
-            <a:pPr algn="ctr" indent="0" marL="0">
+          <a:bodyPr wrap="square" lIns="0" tIns="0" rIns="0" bIns="0" rtlCol="0" anchor="ctr"/>
+          <a:lstStyle/>
+          <a:p>
+            <a:pPr indent="0" marL="0">
               <a:buNone/>
             </a:pPr>
             <a:r>
-              <a:rPr lang="en-US" sz="1400" dirty="0">
+              <a:rPr lang="en-US" sz="1200" dirty="0">
                 <a:solidFill>
                   <a:srgbClr val="5B6575"/>
                 </a:solidFill>
@@ -3923,26 +4426,26 @@
                 <a:ea typeface="Calibri" pitchFamily="34" charset="-122"/>
                 <a:cs typeface="Calibri" pitchFamily="34" charset="-120"/>
               </a:rPr>
-              <a:t>【貼上 Reel 截圖 / 影片畫面】</a:t>
-            </a:r>
-            <a:endParaRPr lang="en-US" sz="1400" dirty="0"/>
-          </a:p>
-        </p:txBody>
-      </p:sp>
-      <p:sp>
-        <p:nvSpPr>
-          <p:cNvPr id="7" name="Shape 5"/>
+              <a:t>IG Reel「My CMC Vlog」畫面</a:t>
+            </a:r>
+            <a:endParaRPr lang="en-US" sz="1200" dirty="0"/>
+          </a:p>
+        </p:txBody>
+      </p:sp>
+      <p:sp>
+        <p:nvSpPr>
+          <p:cNvPr id="7" name="Shape 4"/>
           <p:cNvSpPr/>
           <p:nvPr/>
         </p:nvSpPr>
         <p:spPr>
           <a:xfrm>
-            <a:off x="3383280" y="1051560"/>
-            <a:ext cx="5303520" cy="1371600"/>
+            <a:off x="3840480" y="1051560"/>
+            <a:ext cx="4846320" cy="1600200"/>
           </a:xfrm>
           <a:prstGeom prst="roundRect">
             <a:avLst>
-              <a:gd name="adj" fmla="val 5333"/>
+              <a:gd name="adj" fmla="val 4571"/>
             </a:avLst>
           </a:prstGeom>
           <a:solidFill>
@@ -3958,14 +4461,14 @@
       </p:sp>
       <p:sp>
         <p:nvSpPr>
-          <p:cNvPr id="8" name="Text 6"/>
+          <p:cNvPr id="8" name="Text 5"/>
           <p:cNvSpPr txBox="1"/>
           <p:nvPr/>
         </p:nvSpPr>
         <p:spPr>
           <a:xfrm>
-            <a:off x="3566160" y="1161288"/>
-            <a:ext cx="4937760" cy="365760"/>
+            <a:off x="4023360" y="1161288"/>
+            <a:ext cx="4480560" cy="365760"/>
           </a:xfrm>
           <a:prstGeom prst="rect">
             <a:avLst/>
@@ -3997,14 +4500,14 @@
       </p:sp>
       <p:sp>
         <p:nvSpPr>
-          <p:cNvPr id="9" name="Text 7"/>
+          <p:cNvPr id="9" name="Text 6"/>
           <p:cNvSpPr txBox="1"/>
           <p:nvPr/>
         </p:nvSpPr>
         <p:spPr>
           <a:xfrm>
-            <a:off x="3566160" y="1554480"/>
-            <a:ext cx="4937760" cy="777240"/>
+            <a:off x="4023360" y="1581912"/>
+            <a:ext cx="4480560" cy="914400"/>
           </a:xfrm>
           <a:prstGeom prst="rect">
             <a:avLst/>
@@ -4032,7 +4535,7 @@
                 <a:ea typeface="Calibri" pitchFamily="34" charset="-122"/>
                 <a:cs typeface="Calibri" pitchFamily="34" charset="-120"/>
               </a:rPr>
-              <a:t>參與研習營時,把「一台車從材質桌開始」的幕後現場帶給同學看</a:t>
+              <a:t>把「一台車從材質桌開始」的幕後現場帶給同學看</a:t>
             </a:r>
             <a:endParaRPr lang="en-US" sz="1400" dirty="0"/>
           </a:p>
@@ -4053,7 +4556,7 @@
                 <a:ea typeface="Calibri" pitchFamily="34" charset="-122"/>
                 <a:cs typeface="Calibri" pitchFamily="34" charset="-120"/>
               </a:rPr>
-              <a:t>以第一人稱視角呈現,縮短校園與車輛產業的距離</a:t>
+              <a:t>第一人稱視角,拉近校園與車輛產業</a:t>
             </a:r>
             <a:endParaRPr lang="en-US" sz="1400" dirty="0"/>
           </a:p>
@@ -4061,18 +4564,18 @@
       </p:sp>
       <p:sp>
         <p:nvSpPr>
-          <p:cNvPr id="10" name="Shape 8"/>
+          <p:cNvPr id="10" name="Shape 7"/>
           <p:cNvSpPr/>
           <p:nvPr/>
         </p:nvSpPr>
         <p:spPr>
           <a:xfrm>
-            <a:off x="3383280" y="2560320"/>
-            <a:ext cx="5303520" cy="2103120"/>
+            <a:off x="3840480" y="2788920"/>
+            <a:ext cx="4846320" cy="2011680"/>
           </a:xfrm>
           <a:prstGeom prst="roundRect">
             <a:avLst>
-              <a:gd name="adj" fmla="val 3478"/>
+              <a:gd name="adj" fmla="val 3636"/>
             </a:avLst>
           </a:prstGeom>
           <a:solidFill>
@@ -4088,14 +4591,14 @@
       </p:sp>
       <p:sp>
         <p:nvSpPr>
-          <p:cNvPr id="11" name="Text 9"/>
+          <p:cNvPr id="11" name="Text 8"/>
           <p:cNvSpPr txBox="1"/>
           <p:nvPr/>
         </p:nvSpPr>
         <p:spPr>
           <a:xfrm>
-            <a:off x="3566160" y="2670048"/>
-            <a:ext cx="4937760" cy="365760"/>
+            <a:off x="4023360" y="2898648"/>
+            <a:ext cx="4480560" cy="365760"/>
           </a:xfrm>
           <a:prstGeom prst="rect">
             <a:avLst/>
@@ -4127,14 +4630,14 @@
       </p:sp>
       <p:sp>
         <p:nvSpPr>
-          <p:cNvPr id="12" name="Text 10"/>
+          <p:cNvPr id="12" name="Text 9"/>
           <p:cNvSpPr txBox="1"/>
           <p:nvPr/>
         </p:nvSpPr>
         <p:spPr>
           <a:xfrm>
-            <a:off x="3566160" y="3063240"/>
-            <a:ext cx="4937760" cy="1508760"/>
+            <a:off x="4023360" y="3319272"/>
+            <a:ext cx="4480560" cy="1325880"/>
           </a:xfrm>
           <a:prstGeom prst="rect">
             <a:avLst/>
@@ -4162,7 +4665,7 @@
                 <a:ea typeface="Calibri" pitchFamily="34" charset="-122"/>
                 <a:cs typeface="Calibri" pitchFamily="34" charset="-120"/>
               </a:rPr>
-              <a:t>活動:AI 輔助內裝設計、CMF 實物、VR 設計體驗、油土模型、四足機器人</a:t>
+              <a:t>研習營體驗:AI 內裝設計、CMF、VR、油土模型、四足機器人</a:t>
             </a:r>
             <a:endParaRPr lang="en-US" sz="1400" dirty="0"/>
           </a:p>
@@ -4183,7 +4686,7 @@
                 <a:ea typeface="Calibri" pitchFamily="34" charset="-122"/>
                 <a:cs typeface="Calibri" pitchFamily="34" charset="-120"/>
               </a:rPr>
-              <a:t>形式:影片記錄 + 貼文文案 + 互動提問「你最想體驗哪一關?」</a:t>
+              <a:t>影片記錄 + 貼文文案,結尾提問「你最想體驗哪一關?」</a:t>
             </a:r>
             <a:endParaRPr lang="en-US" sz="1400" dirty="0"/>
           </a:p>
@@ -4204,7 +4707,7 @@
                 <a:ea typeface="Calibri" pitchFamily="34" charset="-122"/>
                 <a:cs typeface="Calibri" pitchFamily="34" charset="-120"/>
               </a:rPr>
-              <a:t>標籤:#中華汽車 #車輛設計 #校園大使 #設計研習營 #產學合作</a:t>
+              <a:t>標籤:#中華汽車 #車輛設計 #校園大使</a:t>
             </a:r>
             <a:endParaRPr lang="en-US" sz="1400" dirty="0"/>
           </a:p>
@@ -4334,7 +4837,7 @@
                 <a:ea typeface="Calibri" pitchFamily="34" charset="-122"/>
                 <a:cs typeface="Calibri" pitchFamily="34" charset="-120"/>
               </a:rPr>
-              <a:t>A 成效:具體數據</a:t>
+              <a:t>成效:具體數據</a:t>
             </a:r>
             <a:endParaRPr lang="en-US" sz="2600" dirty="0"/>
           </a:p>
@@ -4979,7 +5482,7 @@
         <p:spPr>
           <a:xfrm>
             <a:off x="457200" y="4297680"/>
-            <a:ext cx="5669280" cy="548640"/>
+            <a:ext cx="5669280" cy="640080"/>
           </a:xfrm>
           <a:prstGeom prst="rect">
             <a:avLst/>
@@ -5003,7 +5506,7 @@
                 <a:ea typeface="Calibri" pitchFamily="34" charset="-122"/>
                 <a:cs typeface="Calibri" pitchFamily="34" charset="-120"/>
               </a:rPr>
-              <a:t>互動數 = 按讚 34 + 留言 1 + 分享 1(轉發、儲存皆 0)。平均觀看時間 3 秒,新增追蹤 0。資料來源:IG Reel 後台洞察。</a:t>
+              <a:t>互動數 = 按讚 34 + 留言 1 + 分享 1(轉發、儲存皆 0)。平均觀看 3 秒,新增追蹤 0。資料來源:IG Reel 後台洞察。</a:t>
             </a:r>
             <a:endParaRPr lang="en-US" sz="1200" dirty="0"/>
           </a:p>
@@ -5011,7 +5514,7 @@
       </p:sp>
       <p:pic>
         <p:nvPicPr>
-          <p:cNvPr id="24" name="Image 0" descr="img/3028a033.jpg">    </p:cNvPr>
+          <p:cNvPr id="24" name="Image 0" descr="img/ig.jpg">    </p:cNvPr>
           <p:cNvPicPr>
             <a:picLocks noChangeAspect="1"/>
           </p:cNvPicPr>
@@ -5019,13 +5522,14 @@
         </p:nvPicPr>
         <p:blipFill>
           <a:blip r:embed="rId1"/>
-          <a:srcRect l="0" r="0" t="0" b="0"/>
-          <a:stretch/>
+          <a:stretch>
+            <a:fillRect/>
+          </a:stretch>
         </p:blipFill>
         <p:spPr>
           <a:xfrm>
-            <a:off x="6583680" y="868680"/>
-            <a:ext cx="1783080" cy="3877056"/>
+            <a:off x="6675120" y="868680"/>
+            <a:ext cx="2194560" cy="3648456"/>
           </a:xfrm>
           <a:prstGeom prst="rect">
             <a:avLst/>
@@ -5156,7 +5660,7 @@
                 <a:ea typeface="Calibri" pitchFamily="34" charset="-122"/>
                 <a:cs typeface="Calibri" pitchFamily="34" charset="-120"/>
               </a:rPr>
-              <a:t>B 趨勢觀察:主題與方法</a:t>
+              <a:t>趨勢觀察:主題與方法</a:t>
             </a:r>
             <a:endParaRPr lang="en-US" sz="2600" dirty="0"/>
           </a:p>
@@ -5171,11 +5675,11 @@
         <p:spPr>
           <a:xfrm>
             <a:off x="457200" y="1051560"/>
-            <a:ext cx="4023360" cy="1554480"/>
+            <a:ext cx="4023360" cy="1645920"/>
           </a:xfrm>
           <a:prstGeom prst="roundRect">
             <a:avLst>
-              <a:gd name="adj" fmla="val 4706"/>
+              <a:gd name="adj" fmla="val 4444"/>
             </a:avLst>
           </a:prstGeom>
           <a:solidFill>
@@ -5236,7 +5740,7 @@
         </p:nvSpPr>
         <p:spPr>
           <a:xfrm>
-            <a:off x="640080" y="1554480"/>
+            <a:off x="640080" y="1581912"/>
             <a:ext cx="3657600" cy="960120"/>
           </a:xfrm>
           <a:prstGeom prst="rect">
@@ -5299,11 +5803,11 @@
         <p:spPr>
           <a:xfrm>
             <a:off x="4663440" y="1051560"/>
-            <a:ext cx="4023360" cy="1554480"/>
+            <a:ext cx="4023360" cy="1645920"/>
           </a:xfrm>
           <a:prstGeom prst="roundRect">
             <a:avLst>
-              <a:gd name="adj" fmla="val 4706"/>
+              <a:gd name="adj" fmla="val 4444"/>
             </a:avLst>
           </a:prstGeom>
           <a:solidFill>
@@ -5364,7 +5868,7 @@
         </p:nvSpPr>
         <p:spPr>
           <a:xfrm>
-            <a:off x="4846320" y="1554480"/>
+            <a:off x="4846320" y="1581912"/>
             <a:ext cx="3657600" cy="960120"/>
           </a:xfrm>
           <a:prstGeom prst="rect">
@@ -5435,7 +5939,7 @@
                 <a:ea typeface="Calibri" pitchFamily="34" charset="-122"/>
                 <a:cs typeface="Calibri" pitchFamily="34" charset="-120"/>
               </a:rPr>
-              <a:t>(實際統計 31 則可見留言)</a:t>
+              <a:t>可見留言 31 則納入統計</a:t>
             </a:r>
             <a:endParaRPr lang="en-US" sz="1400" dirty="0"/>
           </a:p>
@@ -5449,12 +5953,12 @@
         </p:nvSpPr>
         <p:spPr>
           <a:xfrm>
-            <a:off x="457200" y="2788920"/>
-            <a:ext cx="8229600" cy="1828800"/>
+            <a:off x="457200" y="2880360"/>
+            <a:ext cx="8229600" cy="1920240"/>
           </a:xfrm>
           <a:prstGeom prst="roundRect">
             <a:avLst>
-              <a:gd name="adj" fmla="val 4000"/>
+              <a:gd name="adj" fmla="val 3810"/>
             </a:avLst>
           </a:prstGeom>
           <a:solidFill>
@@ -5476,7 +5980,7 @@
         </p:nvSpPr>
         <p:spPr>
           <a:xfrm>
-            <a:off x="640080" y="2898648"/>
+            <a:off x="640080" y="2990088"/>
             <a:ext cx="7863840" cy="365760"/>
           </a:xfrm>
           <a:prstGeom prst="rect">
@@ -5515,7 +6019,7 @@
         </p:nvSpPr>
         <p:spPr>
           <a:xfrm>
-            <a:off x="640080" y="3291840"/>
+            <a:off x="640080" y="3410712"/>
             <a:ext cx="7863840" cy="1234440"/>
           </a:xfrm>
           <a:prstGeom prst="rect">
@@ -5544,7 +6048,7 @@
                 <a:ea typeface="Calibri" pitchFamily="34" charset="-122"/>
                 <a:cs typeface="Calibri" pitchFamily="34" charset="-120"/>
               </a:rPr>
-              <a:t>選擇與福利、新鮮人職場生活最相關的兩篇貼文,記錄發文日期、愛心、留言、收藏、分享數</a:t>
+              <a:t>選出與福利、新鮮人職場最相關的兩篇貼文,記錄愛心、留言、收藏、分享數</a:t>
             </a:r>
             <a:endParaRPr lang="en-US" sz="1400" dirty="0"/>
           </a:p>
@@ -5565,7 +6069,7 @@
                 <a:ea typeface="Calibri" pitchFamily="34" charset="-122"/>
                 <a:cs typeface="Calibri" pitchFamily="34" charset="-120"/>
               </a:rPr>
-              <a:t>逐則閱讀可見留言,依福利類別統計被提及的次數(一則留言可提及多項)</a:t>
+              <a:t>逐則閱讀可見留言,依福利類別統計提及次數(一則可提及多項)</a:t>
             </a:r>
             <a:endParaRPr lang="en-US" sz="1400" dirty="0"/>
           </a:p>
@@ -5586,7 +6090,7 @@
                 <a:ea typeface="Calibri" pitchFamily="34" charset="-122"/>
                 <a:cs typeface="Calibri" pitchFamily="34" charset="-120"/>
               </a:rPr>
-              <a:t>再與公開人力銀行調查交叉比對,避免僅憑單一貼文下結論</a:t>
+              <a:t>對照 104 公開的中華汽車福利,找出新鮮人需求與企業現況的落差</a:t>
             </a:r>
             <a:endParaRPr lang="en-US" sz="1400" dirty="0"/>
           </a:p>
@@ -5716,15 +6220,54 @@
                 <a:ea typeface="Calibri" pitchFamily="34" charset="-122"/>
                 <a:cs typeface="Calibri" pitchFamily="34" charset="-120"/>
               </a:rPr>
-              <a:t>B 第一線觀察:Dcard 案例</a:t>
+              <a:t>第一線觀察:Dcard 案例</a:t>
             </a:r>
             <a:endParaRPr lang="en-US" sz="2600" dirty="0"/>
+          </a:p>
+        </p:txBody>
+      </p:sp>
+      <p:sp>
+        <p:nvSpPr>
+          <p:cNvPr id="5" name="Text 3"/>
+          <p:cNvSpPr txBox="1"/>
+          <p:nvPr/>
+        </p:nvSpPr>
+        <p:spPr>
+          <a:xfrm>
+            <a:off x="457200" y="960120"/>
+            <a:ext cx="4023360" cy="502920"/>
+          </a:xfrm>
+          <a:prstGeom prst="rect">
+            <a:avLst/>
+          </a:prstGeom>
+          <a:noFill/>
+          <a:ln/>
+        </p:spPr>
+        <p:txBody>
+          <a:bodyPr wrap="square" lIns="0" tIns="0" rIns="0" bIns="0" rtlCol="0" anchor="t"/>
+          <a:lstStyle/>
+          <a:p>
+            <a:pPr indent="0" marL="0">
+              <a:buNone/>
+            </a:pPr>
+            <a:r>
+              <a:rPr lang="en-US" sz="1400" b="1" dirty="0">
+                <a:solidFill>
+                  <a:srgbClr val="1B2A41"/>
+                </a:solidFill>
+                <a:latin typeface="Calibri" pitchFamily="34" charset="0"/>
+                <a:ea typeface="Calibri" pitchFamily="34" charset="-122"/>
+                <a:cs typeface="Calibri" pitchFamily="34" charset="-120"/>
+              </a:rPr>
+              <a:t>案例 1|#請益 大家都在乎什麼公司福利?</a:t>
+            </a:r>
+            <a:endParaRPr lang="en-US" sz="1400" dirty="0"/>
           </a:p>
         </p:txBody>
       </p:sp>
       <p:pic>
         <p:nvPicPr>
-          <p:cNvPr id="5" name="Image 0" descr="img/6ff4206d.jpg">    </p:cNvPr>
+          <p:cNvPr id="6" name="Image 0" descr="img/case1.jpg">    </p:cNvPr>
           <p:cNvPicPr>
             <a:picLocks noChangeAspect="1"/>
           </p:cNvPicPr>
@@ -5732,13 +6275,14 @@
         </p:nvPicPr>
         <p:blipFill>
           <a:blip r:embed="rId1"/>
-          <a:srcRect l="0" r="0" t="0" b="0"/>
-          <a:stretch/>
+          <a:stretch>
+            <a:fillRect/>
+          </a:stretch>
         </p:blipFill>
         <p:spPr>
           <a:xfrm>
-            <a:off x="457200" y="960120"/>
-            <a:ext cx="1554480" cy="3383280"/>
+            <a:off x="457200" y="1554480"/>
+            <a:ext cx="1645920" cy="2990088"/>
           </a:xfrm>
           <a:prstGeom prst="rect">
             <a:avLst/>
@@ -5747,14 +6291,14 @@
       </p:pic>
       <p:sp>
         <p:nvSpPr>
-          <p:cNvPr id="6" name="Text 3"/>
+          <p:cNvPr id="7" name="Text 4"/>
           <p:cNvSpPr txBox="1"/>
           <p:nvPr/>
         </p:nvSpPr>
         <p:spPr>
           <a:xfrm>
-            <a:off x="2194560" y="960120"/>
-            <a:ext cx="2240280" cy="3566160"/>
+            <a:off x="2240280" y="1554480"/>
+            <a:ext cx="2240280" cy="685800"/>
           </a:xfrm>
           <a:prstGeom prst="rect">
             <a:avLst/>
@@ -5767,29 +6311,23 @@
           <a:lstStyle/>
           <a:p>
             <a:pPr indent="0" marL="0">
-              <a:spcAft>
-                <a:spcPts val="500"/>
-              </a:spcAft>
               <a:buNone/>
             </a:pPr>
             <a:r>
-              <a:rPr lang="en-US" sz="1300" b="1" dirty="0">
-                <a:solidFill>
-                  <a:srgbClr val="1B2A41"/>
-                </a:solidFill>
-                <a:latin typeface="Calibri" pitchFamily="34" charset="0"/>
-                <a:ea typeface="Calibri" pitchFamily="34" charset="-122"/>
-                <a:cs typeface="Calibri" pitchFamily="34" charset="-120"/>
-              </a:rPr>
-              <a:t>案例 1|#請益 大家都在乎什麼公司福利?</a:t>
-            </a:r>
-            <a:endParaRPr lang="en-US" sz="1300" dirty="0"/>
+              <a:rPr lang="en-US" sz="1200" dirty="0">
+                <a:solidFill>
+                  <a:srgbClr val="5B6575"/>
+                </a:solidFill>
+                <a:latin typeface="Calibri" pitchFamily="34" charset="0"/>
+                <a:ea typeface="Calibri" pitchFamily="34" charset="-122"/>
+                <a:cs typeface="Calibri" pitchFamily="34" charset="-120"/>
+              </a:rPr>
+              <a:t>2025/2/15 發文</a:t>
+            </a:r>
+            <a:endParaRPr lang="en-US" sz="1200" dirty="0"/>
           </a:p>
           <a:p>
             <a:pPr indent="0" marL="0">
-              <a:spcAft>
-                <a:spcPts val="500"/>
-              </a:spcAft>
               <a:buNone/>
             </a:pPr>
             <a:r>
@@ -5801,10 +6339,49 @@
                 <a:ea typeface="Calibri" pitchFamily="34" charset="-122"/>
                 <a:cs typeface="Calibri" pitchFamily="34" charset="-120"/>
               </a:rPr>
-              <a:t>發文:2025/2/15 ・ 愛心 142 ・ 留言 35 ・ 收藏 832 ・ 分享 50</a:t>
-            </a:r>
-            <a:endParaRPr lang="en-US" sz="1300" dirty="0"/>
-          </a:p>
+              <a:t>愛心 142 ・ 留言 35</a:t>
+            </a:r>
+            <a:endParaRPr lang="en-US" sz="1200" dirty="0"/>
+          </a:p>
+          <a:p>
+            <a:pPr indent="0" marL="0">
+              <a:buNone/>
+            </a:pPr>
+            <a:r>
+              <a:rPr lang="en-US" sz="1200" dirty="0">
+                <a:solidFill>
+                  <a:srgbClr val="5B6575"/>
+                </a:solidFill>
+                <a:latin typeface="Calibri" pitchFamily="34" charset="0"/>
+                <a:ea typeface="Calibri" pitchFamily="34" charset="-122"/>
+                <a:cs typeface="Calibri" pitchFamily="34" charset="-120"/>
+              </a:rPr>
+              <a:t>收藏 832 ・ 分享 50</a:t>
+            </a:r>
+            <a:endParaRPr lang="en-US" sz="1200" dirty="0"/>
+          </a:p>
+        </p:txBody>
+      </p:sp>
+      <p:sp>
+        <p:nvSpPr>
+          <p:cNvPr id="8" name="Text 5"/>
+          <p:cNvSpPr txBox="1"/>
+          <p:nvPr/>
+        </p:nvSpPr>
+        <p:spPr>
+          <a:xfrm>
+            <a:off x="2240280" y="2286000"/>
+            <a:ext cx="2240280" cy="2514600"/>
+          </a:xfrm>
+          <a:prstGeom prst="rect">
+            <a:avLst/>
+          </a:prstGeom>
+          <a:noFill/>
+          <a:ln/>
+        </p:spPr>
+        <p:txBody>
+          <a:bodyPr wrap="square" lIns="0" tIns="0" rIns="0" bIns="0" rtlCol="0" anchor="t"/>
+          <a:lstStyle/>
           <a:p>
             <a:pPr marL="342900" indent="-342900">
               <a:spcAft>
@@ -5822,7 +6399,7 @@
                 <a:ea typeface="Calibri" pitchFamily="34" charset="-122"/>
                 <a:cs typeface="Calibri" pitchFamily="34" charset="-120"/>
               </a:rPr>
-              <a:t>新鮮人拿到錄取通知,請教哪些福利是必問、必備</a:t>
+              <a:t>新鮮人請教哪些福利是必問、必備</a:t>
             </a:r>
             <a:endParaRPr lang="en-US" sz="1300" dirty="0"/>
           </a:p>
@@ -5843,7 +6420,7 @@
                 <a:ea typeface="Calibri" pitchFamily="34" charset="-122"/>
                 <a:cs typeface="Calibri" pitchFamily="34" charset="-120"/>
               </a:rPr>
-              <a:t>最高讚留言(246 讚):入職前要確認試用期、薪資結構、休假、三節/年終、加班費、勞健保級距</a:t>
+              <a:t>最高讚留言(246 讚):入職前先確認薪資結構、休假、三節年終、加班費</a:t>
             </a:r>
             <a:endParaRPr lang="en-US" sz="1300" dirty="0"/>
           </a:p>
@@ -5864,15 +6441,54 @@
                 <a:ea typeface="Calibri" pitchFamily="34" charset="-122"/>
                 <a:cs typeface="Calibri" pitchFamily="34" charset="-120"/>
               </a:rPr>
-              <a:t>「錢才是重點,優於勞基法的才叫福利」(72 讚)</a:t>
+              <a:t>「錢才是重點」(72 讚)</a:t>
             </a:r>
             <a:endParaRPr lang="en-US" sz="1300" dirty="0"/>
+          </a:p>
+        </p:txBody>
+      </p:sp>
+      <p:sp>
+        <p:nvSpPr>
+          <p:cNvPr id="9" name="Text 6"/>
+          <p:cNvSpPr txBox="1"/>
+          <p:nvPr/>
+        </p:nvSpPr>
+        <p:spPr>
+          <a:xfrm>
+            <a:off x="4663440" y="960120"/>
+            <a:ext cx="4023360" cy="502920"/>
+          </a:xfrm>
+          <a:prstGeom prst="rect">
+            <a:avLst/>
+          </a:prstGeom>
+          <a:noFill/>
+          <a:ln/>
+        </p:spPr>
+        <p:txBody>
+          <a:bodyPr wrap="square" lIns="0" tIns="0" rIns="0" bIns="0" rtlCol="0" anchor="t"/>
+          <a:lstStyle/>
+          <a:p>
+            <a:pPr indent="0" marL="0">
+              <a:buNone/>
+            </a:pPr>
+            <a:r>
+              <a:rPr lang="en-US" sz="1400" b="1" dirty="0">
+                <a:solidFill>
+                  <a:srgbClr val="1B2A41"/>
+                </a:solidFill>
+                <a:latin typeface="Calibri" pitchFamily="34" charset="0"/>
+                <a:ea typeface="Calibri" pitchFamily="34" charset="-122"/>
+                <a:cs typeface="Calibri" pitchFamily="34" charset="-120"/>
+              </a:rPr>
+              <a:t>案例 2|#閒聊 社會新鮮人的小確幸公司</a:t>
+            </a:r>
+            <a:endParaRPr lang="en-US" sz="1400" dirty="0"/>
           </a:p>
         </p:txBody>
       </p:sp>
       <p:pic>
         <p:nvPicPr>
-          <p:cNvPr id="7" name="Image 1" descr="img/3928ddfb.jpg">    </p:cNvPr>
+          <p:cNvPr id="10" name="Image 1" descr="img/case2.jpg">    </p:cNvPr>
           <p:cNvPicPr>
             <a:picLocks noChangeAspect="1"/>
           </p:cNvPicPr>
@@ -5880,13 +6496,14 @@
         </p:nvPicPr>
         <p:blipFill>
           <a:blip r:embed="rId2"/>
-          <a:srcRect l="0" r="0" t="0" b="0"/>
-          <a:stretch/>
+          <a:stretch>
+            <a:fillRect/>
+          </a:stretch>
         </p:blipFill>
         <p:spPr>
           <a:xfrm>
-            <a:off x="4663440" y="960120"/>
-            <a:ext cx="1554480" cy="3383280"/>
+            <a:off x="4663440" y="1554480"/>
+            <a:ext cx="1645920" cy="2990088"/>
           </a:xfrm>
           <a:prstGeom prst="rect">
             <a:avLst/>
@@ -5895,14 +6512,14 @@
       </p:pic>
       <p:sp>
         <p:nvSpPr>
-          <p:cNvPr id="8" name="Text 4"/>
+          <p:cNvPr id="11" name="Text 7"/>
           <p:cNvSpPr txBox="1"/>
           <p:nvPr/>
         </p:nvSpPr>
         <p:spPr>
           <a:xfrm>
-            <a:off x="6400800" y="960120"/>
-            <a:ext cx="2286000" cy="3566160"/>
+            <a:off x="6446520" y="1554480"/>
+            <a:ext cx="2240280" cy="685800"/>
           </a:xfrm>
           <a:prstGeom prst="rect">
             <a:avLst/>
@@ -5915,29 +6532,23 @@
           <a:lstStyle/>
           <a:p>
             <a:pPr indent="0" marL="0">
-              <a:spcAft>
-                <a:spcPts val="500"/>
-              </a:spcAft>
               <a:buNone/>
             </a:pPr>
             <a:r>
-              <a:rPr lang="en-US" sz="1300" b="1" dirty="0">
-                <a:solidFill>
-                  <a:srgbClr val="1B2A41"/>
-                </a:solidFill>
-                <a:latin typeface="Calibri" pitchFamily="34" charset="0"/>
-                <a:ea typeface="Calibri" pitchFamily="34" charset="-122"/>
-                <a:cs typeface="Calibri" pitchFamily="34" charset="-120"/>
-              </a:rPr>
-              <a:t>案例 2|#閒聊 社會新鮮人的小確幸公司</a:t>
-            </a:r>
-            <a:endParaRPr lang="en-US" sz="1300" dirty="0"/>
+              <a:rPr lang="en-US" sz="1200" dirty="0">
+                <a:solidFill>
+                  <a:srgbClr val="5B6575"/>
+                </a:solidFill>
+                <a:latin typeface="Calibri" pitchFamily="34" charset="0"/>
+                <a:ea typeface="Calibri" pitchFamily="34" charset="-122"/>
+                <a:cs typeface="Calibri" pitchFamily="34" charset="-120"/>
+              </a:rPr>
+              <a:t>2025/12/18 發文</a:t>
+            </a:r>
+            <a:endParaRPr lang="en-US" sz="1200" dirty="0"/>
           </a:p>
           <a:p>
             <a:pPr indent="0" marL="0">
-              <a:spcAft>
-                <a:spcPts val="500"/>
-              </a:spcAft>
               <a:buNone/>
             </a:pPr>
             <a:r>
@@ -5949,10 +6560,49 @@
                 <a:ea typeface="Calibri" pitchFamily="34" charset="-122"/>
                 <a:cs typeface="Calibri" pitchFamily="34" charset="-120"/>
               </a:rPr>
-              <a:t>發文:2025/12/18 ・ 愛心 82 ・ 留言 15 ・ 收藏 10 ・ 分享 2</a:t>
-            </a:r>
-            <a:endParaRPr lang="en-US" sz="1300" dirty="0"/>
-          </a:p>
+              <a:t>愛心 82 ・ 留言 15</a:t>
+            </a:r>
+            <a:endParaRPr lang="en-US" sz="1200" dirty="0"/>
+          </a:p>
+          <a:p>
+            <a:pPr indent="0" marL="0">
+              <a:buNone/>
+            </a:pPr>
+            <a:r>
+              <a:rPr lang="en-US" sz="1200" dirty="0">
+                <a:solidFill>
+                  <a:srgbClr val="5B6575"/>
+                </a:solidFill>
+                <a:latin typeface="Calibri" pitchFamily="34" charset="0"/>
+                <a:ea typeface="Calibri" pitchFamily="34" charset="-122"/>
+                <a:cs typeface="Calibri" pitchFamily="34" charset="-120"/>
+              </a:rPr>
+              <a:t>收藏 10 ・ 分享 2</a:t>
+            </a:r>
+            <a:endParaRPr lang="en-US" sz="1200" dirty="0"/>
+          </a:p>
+        </p:txBody>
+      </p:sp>
+      <p:sp>
+        <p:nvSpPr>
+          <p:cNvPr id="12" name="Text 8"/>
+          <p:cNvSpPr txBox="1"/>
+          <p:nvPr/>
+        </p:nvSpPr>
+        <p:spPr>
+          <a:xfrm>
+            <a:off x="6446520" y="2286000"/>
+            <a:ext cx="2240280" cy="2514600"/>
+          </a:xfrm>
+          <a:prstGeom prst="rect">
+            <a:avLst/>
+          </a:prstGeom>
+          <a:noFill/>
+          <a:ln/>
+        </p:spPr>
+        <p:txBody>
+          <a:bodyPr wrap="square" lIns="0" tIns="0" rIns="0" bIns="0" rtlCol="0" anchor="t"/>
+          <a:lstStyle/>
           <a:p>
             <a:pPr marL="342900" indent="-342900">
               <a:spcAft>
@@ -5970,7 +6620,7 @@
                 <a:ea typeface="Calibri" pitchFamily="34" charset="-122"/>
                 <a:cs typeface="Calibri" pitchFamily="34" charset="-120"/>
               </a:rPr>
-              <a:t>原 PO 喜歡:月底放風日、Work From Anywhere、午休 1.5 小時、病假 10 天不扣薪、生日月福利</a:t>
+              <a:t>原 PO 最愛:放風日、Work From Anywhere、午休 1.5 小時、生日月福利</a:t>
             </a:r>
             <a:endParaRPr lang="en-US" sz="1300" dirty="0"/>
           </a:p>
@@ -5991,7 +6641,7 @@
                 <a:ea typeface="Calibri" pitchFamily="34" charset="-122"/>
                 <a:cs typeface="Calibri" pitchFamily="34" charset="-120"/>
               </a:rPr>
-              <a:t>留言多為零食、節慶賀卡、蛋糕等「小確幸」的羨慕與比較</a:t>
+              <a:t>留言多羨慕零食、賀卡、蛋糕等小確幸</a:t>
             </a:r>
             <a:endParaRPr lang="en-US" sz="1300" dirty="0"/>
           </a:p>
@@ -6121,7 +6771,7 @@
                 <a:ea typeface="Calibri" pitchFamily="34" charset="-122"/>
                 <a:cs typeface="Calibri" pitchFamily="34" charset="-120"/>
               </a:rPr>
-              <a:t>B 數據佐證:留言怎麼說</a:t>
+              <a:t>數據佐證:留言怎麼說</a:t>
             </a:r>
             <a:endParaRPr lang="en-US" sz="2600" dirty="0"/>
           </a:p>
@@ -6152,7 +6802,7 @@
         <p:spPr>
           <a:xfrm>
             <a:off x="457200" y="4389120"/>
-            <a:ext cx="5120640" cy="548640"/>
+            <a:ext cx="5120640" cy="594360"/>
           </a:xfrm>
           <a:prstGeom prst="rect">
             <a:avLst/>
@@ -6176,7 +6826,7 @@
                 <a:ea typeface="Calibri" pitchFamily="34" charset="-122"/>
                 <a:cs typeface="Calibri" pitchFamily="34" charset="-120"/>
               </a:rPr>
-              <a:t>統計方式:案例 1 共 35 則留言,截圖可見 20 則,其中 17 則談到福利內容;一則可提及多項。案例 2 可見 11 則,其中 4 則談零食/賀卡。</a:t>
+              <a:t>統計方式:案例 1 共 35 則留言,可見 20 則,其中 17 則談福利;一則可提及多項。案例 2 可見 11 則,其中 4 則談零食/賀卡。</a:t>
             </a:r>
             <a:endParaRPr lang="en-US" sz="1100" dirty="0"/>
           </a:p>
@@ -6191,11 +6841,11 @@
         <p:spPr>
           <a:xfrm>
             <a:off x="5760720" y="1005840"/>
-            <a:ext cx="2926080" cy="1828800"/>
+            <a:ext cx="2926080" cy="1737360"/>
           </a:xfrm>
           <a:prstGeom prst="roundRect">
             <a:avLst>
-              <a:gd name="adj" fmla="val 4000"/>
+              <a:gd name="adj" fmla="val 4211"/>
             </a:avLst>
           </a:prstGeom>
           <a:solidFill>
@@ -6256,8 +6906,8 @@
         </p:nvSpPr>
         <p:spPr>
           <a:xfrm>
-            <a:off x="5943600" y="1508760"/>
-            <a:ext cx="2560320" cy="1234440"/>
+            <a:off x="5943600" y="1536192"/>
+            <a:ext cx="2560320" cy="1051560"/>
           </a:xfrm>
           <a:prstGeom prst="rect">
             <a:avLst/>
@@ -6318,12 +6968,12 @@
         </p:nvSpPr>
         <p:spPr>
           <a:xfrm>
-            <a:off x="5760720" y="2971800"/>
-            <a:ext cx="2926080" cy="1828800"/>
+            <a:off x="5760720" y="2880360"/>
+            <a:ext cx="2926080" cy="1920240"/>
           </a:xfrm>
           <a:prstGeom prst="roundRect">
             <a:avLst>
-              <a:gd name="adj" fmla="val 4000"/>
+              <a:gd name="adj" fmla="val 3810"/>
             </a:avLst>
           </a:prstGeom>
           <a:solidFill>
@@ -6345,7 +6995,7 @@
         </p:nvSpPr>
         <p:spPr>
           <a:xfrm>
-            <a:off x="5943600" y="3081528"/>
+            <a:off x="5943600" y="2990088"/>
             <a:ext cx="2560320" cy="365760"/>
           </a:xfrm>
           <a:prstGeom prst="rect">
@@ -6370,7 +7020,7 @@
                 <a:ea typeface="Calibri" pitchFamily="34" charset="-122"/>
                 <a:cs typeface="Calibri" pitchFamily="34" charset="-120"/>
               </a:rPr>
-              <a:t>外部對照(待核對)</a:t>
+              <a:t>資料侷限</a:t>
             </a:r>
             <a:endParaRPr lang="en-US" sz="1600" dirty="0"/>
           </a:p>
@@ -6384,7 +7034,7 @@
         </p:nvSpPr>
         <p:spPr>
           <a:xfrm>
-            <a:off x="5943600" y="3474720"/>
+            <a:off x="5943600" y="3410712"/>
             <a:ext cx="2560320" cy="1234440"/>
           </a:xfrm>
           <a:prstGeom prst="rect">
@@ -6412,7 +7062,7 @@
                 <a:ea typeface="Calibri" pitchFamily="34" charset="-122"/>
                 <a:cs typeface="Calibri" pitchFamily="34" charset="-120"/>
               </a:rPr>
-              <a:t>104 員工調查(2024):求職在意「薪資條件符合期待」64%</a:t>
+              <a:t>僅 Dcard 兩篇貼文的可見留言,屬質性觀察,不代表全體畢業生</a:t>
             </a:r>
             <a:endParaRPr lang="en-US" sz="1400" dirty="0"/>
           </a:p>
@@ -6542,49 +7192,1519 @@
                 <a:ea typeface="Calibri" pitchFamily="34" charset="-122"/>
                 <a:cs typeface="Calibri" pitchFamily="34" charset="-120"/>
               </a:rPr>
-              <a:t>B 分析與中華汽車的連結</a:t>
+              <a:t>福利對照:新鮮人需求 vs. 中華汽車</a:t>
             </a:r>
             <a:endParaRPr lang="en-US" sz="2600" dirty="0"/>
           </a:p>
         </p:txBody>
       </p:sp>
-      <p:sp>
-        <p:nvSpPr>
-          <p:cNvPr id="5" name="Shape 3"/>
-          <p:cNvSpPr/>
-          <p:nvPr/>
-        </p:nvSpPr>
-        <p:spPr>
-          <a:xfrm>
-            <a:off x="457200" y="1051560"/>
-            <a:ext cx="4023360" cy="3566160"/>
-          </a:xfrm>
-          <a:prstGeom prst="roundRect">
-            <a:avLst>
-              <a:gd name="adj" fmla="val 2051"/>
-            </a:avLst>
-          </a:prstGeom>
-          <a:solidFill>
-            <a:srgbClr val="F3F5F8"/>
-          </a:solidFill>
-          <a:ln w="12700">
-            <a:solidFill>
-              <a:srgbClr val="F3F5F8"/>
-            </a:solidFill>
-            <a:prstDash val="solid"/>
-          </a:ln>
-        </p:spPr>
-      </p:sp>
-      <p:sp>
-        <p:nvSpPr>
-          <p:cNvPr id="6" name="Text 4"/>
+      <p:graphicFrame>
+        <p:nvGraphicFramePr>
+          <p:cNvPr id="10" name="Table 0"/>
+          <p:cNvGraphicFramePr>
+            <a:graphicFrameLocks noGrp="1"/>
+          </p:cNvGraphicFramePr>
+          <p:nvPr>
+            <p:extLst>
+              <p:ext uri="{D42A27DB-BD31-4B8C-83A1-F6EECF244321}">
+                <p14:modId xmlns:p14="http://schemas.microsoft.com/office/powerpoint/2010/main" val="1579011935"/>
+              </p:ext>
+            </p:extLst>
+          </p:nvPr>
+        </p:nvGraphicFramePr>
+        <p:xfrm>
+          <a:off x="457200" y="1005840"/>
+          <a:ext cx="5394960" cy="914400"/>
+        </p:xfrm>
+        <a:graphic>
+          <a:graphicData uri="http://schemas.openxmlformats.org/drawingml/2006/table">
+            <a:tbl>
+              <a:tblPr/>
+              <a:tblGrid>
+                <a:gridCol w="1280160"/>
+                <a:gridCol w="502920"/>
+                <a:gridCol w="3611880"/>
+              </a:tblGrid>
+              <a:tr h="365760">
+                <a:tc>
+                  <a:txBody>
+                    <a:bodyPr/>
+                    <a:lstStyle/>
+                    <a:p>
+                      <a:pPr indent="0" marL="0">
+                        <a:buNone/>
+                      </a:pPr>
+                      <a:r>
+                        <a:rPr lang="en-US" sz="1300" b="1" dirty="0">
+                          <a:solidFill>
+                            <a:srgbClr val="FFFFFF"/>
+                          </a:solidFill>
+                          <a:latin typeface="Calibri" pitchFamily="34" charset="0"/>
+                          <a:ea typeface="Calibri" pitchFamily="34" charset="-122"/>
+                          <a:cs typeface="Calibri" pitchFamily="34" charset="-120"/>
+                        </a:rPr>
+                        <a:t>Dcard 最在意</a:t>
+                      </a:r>
+                      <a:endParaRPr lang="en-US" sz="1300" dirty="0">
+                        <a:latin typeface="Calibri" charset="0"/>
+                        <a:ea typeface="Calibri" charset="0"/>
+                        <a:cs typeface="Calibri" charset="0"/>
+                      </a:endParaRPr>
+                    </a:p>
+                  </a:txBody>
+                  <a:tcPr marL="91440" marR="91440" marT="45720" marB="45720" anchor="ctr">
+                    <a:lnL w="6350" cap="flat" cmpd="sng" algn="ctr">
+                      <a:solidFill>
+                        <a:srgbClr val="D5DBE6"/>
+                      </a:solidFill>
+                      <a:prstDash val="solid"/>
+                      <a:round/>
+                      <a:headEnd type="none" w="med" len="med"/>
+                      <a:tailEnd type="none" w="med" len="med"/>
+                    </a:lnL>
+                    <a:lnR w="6350" cap="flat" cmpd="sng" algn="ctr">
+                      <a:solidFill>
+                        <a:srgbClr val="D5DBE6"/>
+                      </a:solidFill>
+                      <a:prstDash val="solid"/>
+                      <a:round/>
+                      <a:headEnd type="none" w="med" len="med"/>
+                      <a:tailEnd type="none" w="med" len="med"/>
+                    </a:lnR>
+                    <a:lnT w="6350" cap="flat" cmpd="sng" algn="ctr">
+                      <a:solidFill>
+                        <a:srgbClr val="D5DBE6"/>
+                      </a:solidFill>
+                      <a:prstDash val="solid"/>
+                      <a:round/>
+                      <a:headEnd type="none" w="med" len="med"/>
+                      <a:tailEnd type="none" w="med" len="med"/>
+                    </a:lnT>
+                    <a:lnB w="6350" cap="flat" cmpd="sng" algn="ctr">
+                      <a:solidFill>
+                        <a:srgbClr val="D5DBE6"/>
+                      </a:solidFill>
+                      <a:prstDash val="solid"/>
+                      <a:round/>
+                      <a:headEnd type="none" w="med" len="med"/>
+                      <a:tailEnd type="none" w="med" len="med"/>
+                    </a:lnB>
+                    <a:solidFill>
+                      <a:srgbClr val="1B2A41"/>
+                    </a:solidFill>
+                  </a:tcPr>
+                </a:tc>
+                <a:tc>
+                  <a:txBody>
+                    <a:bodyPr/>
+                    <a:lstStyle/>
+                    <a:p>
+                      <a:pPr indent="0" marL="0">
+                        <a:buNone/>
+                      </a:pPr>
+                      <a:r>
+                        <a:rPr lang="en-US" sz="1300" b="1" dirty="0">
+                          <a:solidFill>
+                            <a:srgbClr val="FFFFFF"/>
+                          </a:solidFill>
+                          <a:latin typeface="Calibri" pitchFamily="34" charset="0"/>
+                          <a:ea typeface="Calibri" pitchFamily="34" charset="-122"/>
+                          <a:cs typeface="Calibri" pitchFamily="34" charset="-120"/>
+                        </a:rPr>
+                        <a:t>則數</a:t>
+                      </a:r>
+                      <a:endParaRPr lang="en-US" sz="1300" dirty="0">
+                        <a:latin typeface="Calibri" charset="0"/>
+                        <a:ea typeface="Calibri" charset="0"/>
+                        <a:cs typeface="Calibri" charset="0"/>
+                      </a:endParaRPr>
+                    </a:p>
+                  </a:txBody>
+                  <a:tcPr marL="91440" marR="91440" marT="45720" marB="45720" anchor="ctr">
+                    <a:lnL w="6350" cap="flat" cmpd="sng" algn="ctr">
+                      <a:solidFill>
+                        <a:srgbClr val="D5DBE6"/>
+                      </a:solidFill>
+                      <a:prstDash val="solid"/>
+                      <a:round/>
+                      <a:headEnd type="none" w="med" len="med"/>
+                      <a:tailEnd type="none" w="med" len="med"/>
+                    </a:lnL>
+                    <a:lnR w="6350" cap="flat" cmpd="sng" algn="ctr">
+                      <a:solidFill>
+                        <a:srgbClr val="D5DBE6"/>
+                      </a:solidFill>
+                      <a:prstDash val="solid"/>
+                      <a:round/>
+                      <a:headEnd type="none" w="med" len="med"/>
+                      <a:tailEnd type="none" w="med" len="med"/>
+                    </a:lnR>
+                    <a:lnT w="6350" cap="flat" cmpd="sng" algn="ctr">
+                      <a:solidFill>
+                        <a:srgbClr val="D5DBE6"/>
+                      </a:solidFill>
+                      <a:prstDash val="solid"/>
+                      <a:round/>
+                      <a:headEnd type="none" w="med" len="med"/>
+                      <a:tailEnd type="none" w="med" len="med"/>
+                    </a:lnT>
+                    <a:lnB w="6350" cap="flat" cmpd="sng" algn="ctr">
+                      <a:solidFill>
+                        <a:srgbClr val="D5DBE6"/>
+                      </a:solidFill>
+                      <a:prstDash val="solid"/>
+                      <a:round/>
+                      <a:headEnd type="none" w="med" len="med"/>
+                      <a:tailEnd type="none" w="med" len="med"/>
+                    </a:lnB>
+                    <a:solidFill>
+                      <a:srgbClr val="1B2A41"/>
+                    </a:solidFill>
+                  </a:tcPr>
+                </a:tc>
+                <a:tc>
+                  <a:txBody>
+                    <a:bodyPr/>
+                    <a:lstStyle/>
+                    <a:p>
+                      <a:pPr indent="0" marL="0">
+                        <a:buNone/>
+                      </a:pPr>
+                      <a:r>
+                        <a:rPr lang="en-US" sz="1300" b="1" dirty="0">
+                          <a:solidFill>
+                            <a:srgbClr val="FFFFFF"/>
+                          </a:solidFill>
+                          <a:latin typeface="Calibri" pitchFamily="34" charset="0"/>
+                          <a:ea typeface="Calibri" pitchFamily="34" charset="-122"/>
+                          <a:cs typeface="Calibri" pitchFamily="34" charset="-120"/>
+                        </a:rPr>
+                        <a:t>中華汽車(104 公司頁)</a:t>
+                      </a:r>
+                      <a:endParaRPr lang="en-US" sz="1300" dirty="0">
+                        <a:latin typeface="Calibri" charset="0"/>
+                        <a:ea typeface="Calibri" charset="0"/>
+                        <a:cs typeface="Calibri" charset="0"/>
+                      </a:endParaRPr>
+                    </a:p>
+                  </a:txBody>
+                  <a:tcPr marL="91440" marR="91440" marT="45720" marB="45720" anchor="ctr">
+                    <a:lnL w="6350" cap="flat" cmpd="sng" algn="ctr">
+                      <a:solidFill>
+                        <a:srgbClr val="D5DBE6"/>
+                      </a:solidFill>
+                      <a:prstDash val="solid"/>
+                      <a:round/>
+                      <a:headEnd type="none" w="med" len="med"/>
+                      <a:tailEnd type="none" w="med" len="med"/>
+                    </a:lnL>
+                    <a:lnR w="6350" cap="flat" cmpd="sng" algn="ctr">
+                      <a:solidFill>
+                        <a:srgbClr val="D5DBE6"/>
+                      </a:solidFill>
+                      <a:prstDash val="solid"/>
+                      <a:round/>
+                      <a:headEnd type="none" w="med" len="med"/>
+                      <a:tailEnd type="none" w="med" len="med"/>
+                    </a:lnR>
+                    <a:lnT w="6350" cap="flat" cmpd="sng" algn="ctr">
+                      <a:solidFill>
+                        <a:srgbClr val="D5DBE6"/>
+                      </a:solidFill>
+                      <a:prstDash val="solid"/>
+                      <a:round/>
+                      <a:headEnd type="none" w="med" len="med"/>
+                      <a:tailEnd type="none" w="med" len="med"/>
+                    </a:lnT>
+                    <a:lnB w="6350" cap="flat" cmpd="sng" algn="ctr">
+                      <a:solidFill>
+                        <a:srgbClr val="D5DBE6"/>
+                      </a:solidFill>
+                      <a:prstDash val="solid"/>
+                      <a:round/>
+                      <a:headEnd type="none" w="med" len="med"/>
+                      <a:tailEnd type="none" w="med" len="med"/>
+                    </a:lnB>
+                    <a:solidFill>
+                      <a:srgbClr val="1B2A41"/>
+                    </a:solidFill>
+                  </a:tcPr>
+                </a:tc>
+              </a:tr>
+              <a:tr h="640080">
+                <a:tc>
+                  <a:txBody>
+                    <a:bodyPr/>
+                    <a:lstStyle/>
+                    <a:p>
+                      <a:pPr indent="0" marL="0">
+                        <a:buNone/>
+                      </a:pPr>
+                      <a:r>
+                        <a:rPr lang="en-US" sz="1200" b="1" dirty="0">
+                          <a:solidFill>
+                            <a:srgbClr val="222222"/>
+                          </a:solidFill>
+                          <a:latin typeface="Calibri" pitchFamily="34" charset="0"/>
+                          <a:ea typeface="Calibri" pitchFamily="34" charset="-122"/>
+                          <a:cs typeface="Calibri" pitchFamily="34" charset="-120"/>
+                        </a:rPr>
+                        <a:t>薪資/獎金/年終</a:t>
+                      </a:r>
+                      <a:endParaRPr lang="en-US" sz="1200" dirty="0">
+                        <a:latin typeface="Calibri" charset="0"/>
+                        <a:ea typeface="Calibri" charset="0"/>
+                        <a:cs typeface="Calibri" charset="0"/>
+                      </a:endParaRPr>
+                    </a:p>
+                  </a:txBody>
+                  <a:tcPr marL="91440" marR="91440" marT="45720" marB="45720" anchor="ctr">
+                    <a:lnL w="6350" cap="flat" cmpd="sng" algn="ctr">
+                      <a:solidFill>
+                        <a:srgbClr val="D5DBE6"/>
+                      </a:solidFill>
+                      <a:prstDash val="solid"/>
+                      <a:round/>
+                      <a:headEnd type="none" w="med" len="med"/>
+                      <a:tailEnd type="none" w="med" len="med"/>
+                    </a:lnL>
+                    <a:lnR w="6350" cap="flat" cmpd="sng" algn="ctr">
+                      <a:solidFill>
+                        <a:srgbClr val="D5DBE6"/>
+                      </a:solidFill>
+                      <a:prstDash val="solid"/>
+                      <a:round/>
+                      <a:headEnd type="none" w="med" len="med"/>
+                      <a:tailEnd type="none" w="med" len="med"/>
+                    </a:lnR>
+                    <a:lnT w="6350" cap="flat" cmpd="sng" algn="ctr">
+                      <a:solidFill>
+                        <a:srgbClr val="D5DBE6"/>
+                      </a:solidFill>
+                      <a:prstDash val="solid"/>
+                      <a:round/>
+                      <a:headEnd type="none" w="med" len="med"/>
+                      <a:tailEnd type="none" w="med" len="med"/>
+                    </a:lnT>
+                    <a:lnB w="6350" cap="flat" cmpd="sng" algn="ctr">
+                      <a:solidFill>
+                        <a:srgbClr val="D5DBE6"/>
+                      </a:solidFill>
+                      <a:prstDash val="solid"/>
+                      <a:round/>
+                      <a:headEnd type="none" w="med" len="med"/>
+                      <a:tailEnd type="none" w="med" len="med"/>
+                    </a:lnB>
+                    <a:solidFill>
+                      <a:srgbClr val="FFFFFF"/>
+                    </a:solidFill>
+                  </a:tcPr>
+                </a:tc>
+                <a:tc>
+                  <a:txBody>
+                    <a:bodyPr/>
+                    <a:lstStyle/>
+                    <a:p>
+                      <a:pPr indent="0" marL="0">
+                        <a:buNone/>
+                      </a:pPr>
+                      <a:r>
+                        <a:rPr lang="en-US" sz="1200" dirty="0">
+                          <a:solidFill>
+                            <a:srgbClr val="222222"/>
+                          </a:solidFill>
+                          <a:latin typeface="Calibri" pitchFamily="34" charset="0"/>
+                          <a:ea typeface="Calibri" pitchFamily="34" charset="-122"/>
+                          <a:cs typeface="Calibri" pitchFamily="34" charset="-120"/>
+                        </a:rPr>
+                        <a:t>14</a:t>
+                      </a:r>
+                      <a:endParaRPr lang="en-US" sz="1200" dirty="0">
+                        <a:latin typeface="Calibri" charset="0"/>
+                        <a:ea typeface="Calibri" charset="0"/>
+                        <a:cs typeface="Calibri" charset="0"/>
+                      </a:endParaRPr>
+                    </a:p>
+                  </a:txBody>
+                  <a:tcPr marL="91440" marR="91440" marT="45720" marB="45720" anchor="ctr">
+                    <a:lnL w="6350" cap="flat" cmpd="sng" algn="ctr">
+                      <a:solidFill>
+                        <a:srgbClr val="D5DBE6"/>
+                      </a:solidFill>
+                      <a:prstDash val="solid"/>
+                      <a:round/>
+                      <a:headEnd type="none" w="med" len="med"/>
+                      <a:tailEnd type="none" w="med" len="med"/>
+                    </a:lnL>
+                    <a:lnR w="6350" cap="flat" cmpd="sng" algn="ctr">
+                      <a:solidFill>
+                        <a:srgbClr val="D5DBE6"/>
+                      </a:solidFill>
+                      <a:prstDash val="solid"/>
+                      <a:round/>
+                      <a:headEnd type="none" w="med" len="med"/>
+                      <a:tailEnd type="none" w="med" len="med"/>
+                    </a:lnR>
+                    <a:lnT w="6350" cap="flat" cmpd="sng" algn="ctr">
+                      <a:solidFill>
+                        <a:srgbClr val="D5DBE6"/>
+                      </a:solidFill>
+                      <a:prstDash val="solid"/>
+                      <a:round/>
+                      <a:headEnd type="none" w="med" len="med"/>
+                      <a:tailEnd type="none" w="med" len="med"/>
+                    </a:lnT>
+                    <a:lnB w="6350" cap="flat" cmpd="sng" algn="ctr">
+                      <a:solidFill>
+                        <a:srgbClr val="D5DBE6"/>
+                      </a:solidFill>
+                      <a:prstDash val="solid"/>
+                      <a:round/>
+                      <a:headEnd type="none" w="med" len="med"/>
+                      <a:tailEnd type="none" w="med" len="med"/>
+                    </a:lnB>
+                    <a:solidFill>
+                      <a:srgbClr val="FFFFFF"/>
+                    </a:solidFill>
+                  </a:tcPr>
+                </a:tc>
+                <a:tc>
+                  <a:txBody>
+                    <a:bodyPr/>
+                    <a:lstStyle/>
+                    <a:p>
+                      <a:pPr indent="0" marL="0">
+                        <a:buNone/>
+                      </a:pPr>
+                      <a:r>
+                        <a:rPr lang="en-US" sz="1200" dirty="0">
+                          <a:solidFill>
+                            <a:srgbClr val="222222"/>
+                          </a:solidFill>
+                          <a:latin typeface="Calibri" pitchFamily="34" charset="0"/>
+                          <a:ea typeface="Calibri" pitchFamily="34" charset="-122"/>
+                          <a:cs typeface="Calibri" pitchFamily="34" charset="-120"/>
+                        </a:rPr>
+                        <a:t>年終獎金(含中秋、端午),依營運與考績加發獎金及紅利,三節/生日禮券</a:t>
+                      </a:r>
+                      <a:endParaRPr lang="en-US" sz="1200" dirty="0">
+                        <a:latin typeface="Calibri" charset="0"/>
+                        <a:ea typeface="Calibri" charset="0"/>
+                        <a:cs typeface="Calibri" charset="0"/>
+                      </a:endParaRPr>
+                    </a:p>
+                  </a:txBody>
+                  <a:tcPr marL="91440" marR="91440" marT="45720" marB="45720" anchor="ctr">
+                    <a:lnL w="6350" cap="flat" cmpd="sng" algn="ctr">
+                      <a:solidFill>
+                        <a:srgbClr val="D5DBE6"/>
+                      </a:solidFill>
+                      <a:prstDash val="solid"/>
+                      <a:round/>
+                      <a:headEnd type="none" w="med" len="med"/>
+                      <a:tailEnd type="none" w="med" len="med"/>
+                    </a:lnL>
+                    <a:lnR w="6350" cap="flat" cmpd="sng" algn="ctr">
+                      <a:solidFill>
+                        <a:srgbClr val="D5DBE6"/>
+                      </a:solidFill>
+                      <a:prstDash val="solid"/>
+                      <a:round/>
+                      <a:headEnd type="none" w="med" len="med"/>
+                      <a:tailEnd type="none" w="med" len="med"/>
+                    </a:lnR>
+                    <a:lnT w="6350" cap="flat" cmpd="sng" algn="ctr">
+                      <a:solidFill>
+                        <a:srgbClr val="D5DBE6"/>
+                      </a:solidFill>
+                      <a:prstDash val="solid"/>
+                      <a:round/>
+                      <a:headEnd type="none" w="med" len="med"/>
+                      <a:tailEnd type="none" w="med" len="med"/>
+                    </a:lnT>
+                    <a:lnB w="6350" cap="flat" cmpd="sng" algn="ctr">
+                      <a:solidFill>
+                        <a:srgbClr val="D5DBE6"/>
+                      </a:solidFill>
+                      <a:prstDash val="solid"/>
+                      <a:round/>
+                      <a:headEnd type="none" w="med" len="med"/>
+                      <a:tailEnd type="none" w="med" len="med"/>
+                    </a:lnB>
+                    <a:solidFill>
+                      <a:srgbClr val="FFFFFF"/>
+                    </a:solidFill>
+                  </a:tcPr>
+                </a:tc>
+              </a:tr>
+              <a:tr h="594360">
+                <a:tc>
+                  <a:txBody>
+                    <a:bodyPr/>
+                    <a:lstStyle/>
+                    <a:p>
+                      <a:pPr indent="0" marL="0">
+                        <a:buNone/>
+                      </a:pPr>
+                      <a:r>
+                        <a:rPr lang="en-US" sz="1200" b="1" dirty="0">
+                          <a:solidFill>
+                            <a:srgbClr val="222222"/>
+                          </a:solidFill>
+                          <a:latin typeface="Calibri" pitchFamily="34" charset="0"/>
+                          <a:ea typeface="Calibri" pitchFamily="34" charset="-122"/>
+                          <a:cs typeface="Calibri" pitchFamily="34" charset="-120"/>
+                        </a:rPr>
+                        <a:t>餐飲/設備</a:t>
+                      </a:r>
+                      <a:endParaRPr lang="en-US" sz="1200" dirty="0">
+                        <a:latin typeface="Calibri" charset="0"/>
+                        <a:ea typeface="Calibri" charset="0"/>
+                        <a:cs typeface="Calibri" charset="0"/>
+                      </a:endParaRPr>
+                    </a:p>
+                  </a:txBody>
+                  <a:tcPr marL="91440" marR="91440" marT="45720" marB="45720" anchor="ctr">
+                    <a:lnL w="6350" cap="flat" cmpd="sng" algn="ctr">
+                      <a:solidFill>
+                        <a:srgbClr val="D5DBE6"/>
+                      </a:solidFill>
+                      <a:prstDash val="solid"/>
+                      <a:round/>
+                      <a:headEnd type="none" w="med" len="med"/>
+                      <a:tailEnd type="none" w="med" len="med"/>
+                    </a:lnL>
+                    <a:lnR w="6350" cap="flat" cmpd="sng" algn="ctr">
+                      <a:solidFill>
+                        <a:srgbClr val="D5DBE6"/>
+                      </a:solidFill>
+                      <a:prstDash val="solid"/>
+                      <a:round/>
+                      <a:headEnd type="none" w="med" len="med"/>
+                      <a:tailEnd type="none" w="med" len="med"/>
+                    </a:lnR>
+                    <a:lnT w="6350" cap="flat" cmpd="sng" algn="ctr">
+                      <a:solidFill>
+                        <a:srgbClr val="D5DBE6"/>
+                      </a:solidFill>
+                      <a:prstDash val="solid"/>
+                      <a:round/>
+                      <a:headEnd type="none" w="med" len="med"/>
+                      <a:tailEnd type="none" w="med" len="med"/>
+                    </a:lnT>
+                    <a:lnB w="6350" cap="flat" cmpd="sng" algn="ctr">
+                      <a:solidFill>
+                        <a:srgbClr val="D5DBE6"/>
+                      </a:solidFill>
+                      <a:prstDash val="solid"/>
+                      <a:round/>
+                      <a:headEnd type="none" w="med" len="med"/>
+                      <a:tailEnd type="none" w="med" len="med"/>
+                    </a:lnB>
+                    <a:solidFill>
+                      <a:srgbClr val="FFFFFF"/>
+                    </a:solidFill>
+                  </a:tcPr>
+                </a:tc>
+                <a:tc>
+                  <a:txBody>
+                    <a:bodyPr/>
+                    <a:lstStyle/>
+                    <a:p>
+                      <a:pPr indent="0" marL="0">
+                        <a:buNone/>
+                      </a:pPr>
+                      <a:r>
+                        <a:rPr lang="en-US" sz="1200" dirty="0">
+                          <a:solidFill>
+                            <a:srgbClr val="222222"/>
+                          </a:solidFill>
+                          <a:latin typeface="Calibri" pitchFamily="34" charset="0"/>
+                          <a:ea typeface="Calibri" pitchFamily="34" charset="-122"/>
+                          <a:cs typeface="Calibri" pitchFamily="34" charset="-120"/>
+                        </a:rPr>
+                        <a:t>5</a:t>
+                      </a:r>
+                      <a:endParaRPr lang="en-US" sz="1200" dirty="0">
+                        <a:latin typeface="Calibri" charset="0"/>
+                        <a:ea typeface="Calibri" charset="0"/>
+                        <a:cs typeface="Calibri" charset="0"/>
+                      </a:endParaRPr>
+                    </a:p>
+                  </a:txBody>
+                  <a:tcPr marL="91440" marR="91440" marT="45720" marB="45720" anchor="ctr">
+                    <a:lnL w="6350" cap="flat" cmpd="sng" algn="ctr">
+                      <a:solidFill>
+                        <a:srgbClr val="D5DBE6"/>
+                      </a:solidFill>
+                      <a:prstDash val="solid"/>
+                      <a:round/>
+                      <a:headEnd type="none" w="med" len="med"/>
+                      <a:tailEnd type="none" w="med" len="med"/>
+                    </a:lnL>
+                    <a:lnR w="6350" cap="flat" cmpd="sng" algn="ctr">
+                      <a:solidFill>
+                        <a:srgbClr val="D5DBE6"/>
+                      </a:solidFill>
+                      <a:prstDash val="solid"/>
+                      <a:round/>
+                      <a:headEnd type="none" w="med" len="med"/>
+                      <a:tailEnd type="none" w="med" len="med"/>
+                    </a:lnR>
+                    <a:lnT w="6350" cap="flat" cmpd="sng" algn="ctr">
+                      <a:solidFill>
+                        <a:srgbClr val="D5DBE6"/>
+                      </a:solidFill>
+                      <a:prstDash val="solid"/>
+                      <a:round/>
+                      <a:headEnd type="none" w="med" len="med"/>
+                      <a:tailEnd type="none" w="med" len="med"/>
+                    </a:lnT>
+                    <a:lnB w="6350" cap="flat" cmpd="sng" algn="ctr">
+                      <a:solidFill>
+                        <a:srgbClr val="D5DBE6"/>
+                      </a:solidFill>
+                      <a:prstDash val="solid"/>
+                      <a:round/>
+                      <a:headEnd type="none" w="med" len="med"/>
+                      <a:tailEnd type="none" w="med" len="med"/>
+                    </a:lnB>
+                    <a:solidFill>
+                      <a:srgbClr val="FFFFFF"/>
+                    </a:solidFill>
+                  </a:tcPr>
+                </a:tc>
+                <a:tc>
+                  <a:txBody>
+                    <a:bodyPr/>
+                    <a:lstStyle/>
+                    <a:p>
+                      <a:pPr indent="0" marL="0">
+                        <a:buNone/>
+                      </a:pPr>
+                      <a:r>
+                        <a:rPr lang="en-US" sz="1200" dirty="0">
+                          <a:solidFill>
+                            <a:srgbClr val="222222"/>
+                          </a:solidFill>
+                          <a:latin typeface="Calibri" pitchFamily="34" charset="0"/>
+                          <a:ea typeface="Calibri" pitchFamily="34" charset="-122"/>
+                          <a:cs typeface="Calibri" pitchFamily="34" charset="-120"/>
+                        </a:rPr>
+                        <a:t>多樣化同仁餐廳(自助餐、麵食、套餐、Cafe'),健身房、球場</a:t>
+                      </a:r>
+                      <a:endParaRPr lang="en-US" sz="1200" dirty="0">
+                        <a:latin typeface="Calibri" charset="0"/>
+                        <a:ea typeface="Calibri" charset="0"/>
+                        <a:cs typeface="Calibri" charset="0"/>
+                      </a:endParaRPr>
+                    </a:p>
+                  </a:txBody>
+                  <a:tcPr marL="91440" marR="91440" marT="45720" marB="45720" anchor="ctr">
+                    <a:lnL w="6350" cap="flat" cmpd="sng" algn="ctr">
+                      <a:solidFill>
+                        <a:srgbClr val="D5DBE6"/>
+                      </a:solidFill>
+                      <a:prstDash val="solid"/>
+                      <a:round/>
+                      <a:headEnd type="none" w="med" len="med"/>
+                      <a:tailEnd type="none" w="med" len="med"/>
+                    </a:lnL>
+                    <a:lnR w="6350" cap="flat" cmpd="sng" algn="ctr">
+                      <a:solidFill>
+                        <a:srgbClr val="D5DBE6"/>
+                      </a:solidFill>
+                      <a:prstDash val="solid"/>
+                      <a:round/>
+                      <a:headEnd type="none" w="med" len="med"/>
+                      <a:tailEnd type="none" w="med" len="med"/>
+                    </a:lnR>
+                    <a:lnT w="6350" cap="flat" cmpd="sng" algn="ctr">
+                      <a:solidFill>
+                        <a:srgbClr val="D5DBE6"/>
+                      </a:solidFill>
+                      <a:prstDash val="solid"/>
+                      <a:round/>
+                      <a:headEnd type="none" w="med" len="med"/>
+                      <a:tailEnd type="none" w="med" len="med"/>
+                    </a:lnT>
+                    <a:lnB w="6350" cap="flat" cmpd="sng" algn="ctr">
+                      <a:solidFill>
+                        <a:srgbClr val="D5DBE6"/>
+                      </a:solidFill>
+                      <a:prstDash val="solid"/>
+                      <a:round/>
+                      <a:headEnd type="none" w="med" len="med"/>
+                      <a:tailEnd type="none" w="med" len="med"/>
+                    </a:lnB>
+                    <a:solidFill>
+                      <a:srgbClr val="FFFFFF"/>
+                    </a:solidFill>
+                  </a:tcPr>
+                </a:tc>
+              </a:tr>
+              <a:tr h="457200">
+                <a:tc>
+                  <a:txBody>
+                    <a:bodyPr/>
+                    <a:lstStyle/>
+                    <a:p>
+                      <a:pPr indent="0" marL="0">
+                        <a:buNone/>
+                      </a:pPr>
+                      <a:r>
+                        <a:rPr lang="en-US" sz="1200" b="1" dirty="0">
+                          <a:solidFill>
+                            <a:srgbClr val="222222"/>
+                          </a:solidFill>
+                          <a:latin typeface="Calibri" pitchFamily="34" charset="0"/>
+                          <a:ea typeface="Calibri" pitchFamily="34" charset="-122"/>
+                          <a:cs typeface="Calibri" pitchFamily="34" charset="-120"/>
+                        </a:rPr>
+                        <a:t>彈性/遠端</a:t>
+                      </a:r>
+                      <a:endParaRPr lang="en-US" sz="1200" dirty="0">
+                        <a:latin typeface="Calibri" charset="0"/>
+                        <a:ea typeface="Calibri" charset="0"/>
+                        <a:cs typeface="Calibri" charset="0"/>
+                      </a:endParaRPr>
+                    </a:p>
+                  </a:txBody>
+                  <a:tcPr marL="91440" marR="91440" marT="45720" marB="45720" anchor="ctr">
+                    <a:lnL w="6350" cap="flat" cmpd="sng" algn="ctr">
+                      <a:solidFill>
+                        <a:srgbClr val="D5DBE6"/>
+                      </a:solidFill>
+                      <a:prstDash val="solid"/>
+                      <a:round/>
+                      <a:headEnd type="none" w="med" len="med"/>
+                      <a:tailEnd type="none" w="med" len="med"/>
+                    </a:lnL>
+                    <a:lnR w="6350" cap="flat" cmpd="sng" algn="ctr">
+                      <a:solidFill>
+                        <a:srgbClr val="D5DBE6"/>
+                      </a:solidFill>
+                      <a:prstDash val="solid"/>
+                      <a:round/>
+                      <a:headEnd type="none" w="med" len="med"/>
+                      <a:tailEnd type="none" w="med" len="med"/>
+                    </a:lnR>
+                    <a:lnT w="6350" cap="flat" cmpd="sng" algn="ctr">
+                      <a:solidFill>
+                        <a:srgbClr val="D5DBE6"/>
+                      </a:solidFill>
+                      <a:prstDash val="solid"/>
+                      <a:round/>
+                      <a:headEnd type="none" w="med" len="med"/>
+                      <a:tailEnd type="none" w="med" len="med"/>
+                    </a:lnT>
+                    <a:lnB w="6350" cap="flat" cmpd="sng" algn="ctr">
+                      <a:solidFill>
+                        <a:srgbClr val="D5DBE6"/>
+                      </a:solidFill>
+                      <a:prstDash val="solid"/>
+                      <a:round/>
+                      <a:headEnd type="none" w="med" len="med"/>
+                      <a:tailEnd type="none" w="med" len="med"/>
+                    </a:lnB>
+                    <a:solidFill>
+                      <a:srgbClr val="FFFFFF"/>
+                    </a:solidFill>
+                  </a:tcPr>
+                </a:tc>
+                <a:tc>
+                  <a:txBody>
+                    <a:bodyPr/>
+                    <a:lstStyle/>
+                    <a:p>
+                      <a:pPr indent="0" marL="0">
+                        <a:buNone/>
+                      </a:pPr>
+                      <a:r>
+                        <a:rPr lang="en-US" sz="1200" dirty="0">
+                          <a:solidFill>
+                            <a:srgbClr val="222222"/>
+                          </a:solidFill>
+                          <a:latin typeface="Calibri" pitchFamily="34" charset="0"/>
+                          <a:ea typeface="Calibri" pitchFamily="34" charset="-122"/>
+                          <a:cs typeface="Calibri" pitchFamily="34" charset="-120"/>
+                        </a:rPr>
+                        <a:t>3</a:t>
+                      </a:r>
+                      <a:endParaRPr lang="en-US" sz="1200" dirty="0">
+                        <a:latin typeface="Calibri" charset="0"/>
+                        <a:ea typeface="Calibri" charset="0"/>
+                        <a:cs typeface="Calibri" charset="0"/>
+                      </a:endParaRPr>
+                    </a:p>
+                  </a:txBody>
+                  <a:tcPr marL="91440" marR="91440" marT="45720" marB="45720" anchor="ctr">
+                    <a:lnL w="6350" cap="flat" cmpd="sng" algn="ctr">
+                      <a:solidFill>
+                        <a:srgbClr val="D5DBE6"/>
+                      </a:solidFill>
+                      <a:prstDash val="solid"/>
+                      <a:round/>
+                      <a:headEnd type="none" w="med" len="med"/>
+                      <a:tailEnd type="none" w="med" len="med"/>
+                    </a:lnL>
+                    <a:lnR w="6350" cap="flat" cmpd="sng" algn="ctr">
+                      <a:solidFill>
+                        <a:srgbClr val="D5DBE6"/>
+                      </a:solidFill>
+                      <a:prstDash val="solid"/>
+                      <a:round/>
+                      <a:headEnd type="none" w="med" len="med"/>
+                      <a:tailEnd type="none" w="med" len="med"/>
+                    </a:lnR>
+                    <a:lnT w="6350" cap="flat" cmpd="sng" algn="ctr">
+                      <a:solidFill>
+                        <a:srgbClr val="D5DBE6"/>
+                      </a:solidFill>
+                      <a:prstDash val="solid"/>
+                      <a:round/>
+                      <a:headEnd type="none" w="med" len="med"/>
+                      <a:tailEnd type="none" w="med" len="med"/>
+                    </a:lnT>
+                    <a:lnB w="6350" cap="flat" cmpd="sng" algn="ctr">
+                      <a:solidFill>
+                        <a:srgbClr val="D5DBE6"/>
+                      </a:solidFill>
+                      <a:prstDash val="solid"/>
+                      <a:round/>
+                      <a:headEnd type="none" w="med" len="med"/>
+                      <a:tailEnd type="none" w="med" len="med"/>
+                    </a:lnB>
+                    <a:solidFill>
+                      <a:srgbClr val="FFFFFF"/>
+                    </a:solidFill>
+                  </a:tcPr>
+                </a:tc>
+                <a:tc>
+                  <a:txBody>
+                    <a:bodyPr/>
+                    <a:lstStyle/>
+                    <a:p>
+                      <a:pPr indent="0" marL="0">
+                        <a:buNone/>
+                      </a:pPr>
+                      <a:r>
+                        <a:rPr lang="en-US" sz="1200" dirty="0">
+                          <a:solidFill>
+                            <a:srgbClr val="222222"/>
+                          </a:solidFill>
+                          <a:latin typeface="Calibri" pitchFamily="34" charset="0"/>
+                          <a:ea typeface="Calibri" pitchFamily="34" charset="-122"/>
+                          <a:cs typeface="Calibri" pitchFamily="34" charset="-120"/>
+                        </a:rPr>
+                        <a:t>彈性上班制度(遠端未見說明)</a:t>
+                      </a:r>
+                      <a:endParaRPr lang="en-US" sz="1200" dirty="0">
+                        <a:latin typeface="Calibri" charset="0"/>
+                        <a:ea typeface="Calibri" charset="0"/>
+                        <a:cs typeface="Calibri" charset="0"/>
+                      </a:endParaRPr>
+                    </a:p>
+                  </a:txBody>
+                  <a:tcPr marL="91440" marR="91440" marT="45720" marB="45720" anchor="ctr">
+                    <a:lnL w="6350" cap="flat" cmpd="sng" algn="ctr">
+                      <a:solidFill>
+                        <a:srgbClr val="D5DBE6"/>
+                      </a:solidFill>
+                      <a:prstDash val="solid"/>
+                      <a:round/>
+                      <a:headEnd type="none" w="med" len="med"/>
+                      <a:tailEnd type="none" w="med" len="med"/>
+                    </a:lnL>
+                    <a:lnR w="6350" cap="flat" cmpd="sng" algn="ctr">
+                      <a:solidFill>
+                        <a:srgbClr val="D5DBE6"/>
+                      </a:solidFill>
+                      <a:prstDash val="solid"/>
+                      <a:round/>
+                      <a:headEnd type="none" w="med" len="med"/>
+                      <a:tailEnd type="none" w="med" len="med"/>
+                    </a:lnR>
+                    <a:lnT w="6350" cap="flat" cmpd="sng" algn="ctr">
+                      <a:solidFill>
+                        <a:srgbClr val="D5DBE6"/>
+                      </a:solidFill>
+                      <a:prstDash val="solid"/>
+                      <a:round/>
+                      <a:headEnd type="none" w="med" len="med"/>
+                      <a:tailEnd type="none" w="med" len="med"/>
+                    </a:lnT>
+                    <a:lnB w="6350" cap="flat" cmpd="sng" algn="ctr">
+                      <a:solidFill>
+                        <a:srgbClr val="D5DBE6"/>
+                      </a:solidFill>
+                      <a:prstDash val="solid"/>
+                      <a:round/>
+                      <a:headEnd type="none" w="med" len="med"/>
+                      <a:tailEnd type="none" w="med" len="med"/>
+                    </a:lnB>
+                    <a:solidFill>
+                      <a:srgbClr val="FFFFFF"/>
+                    </a:solidFill>
+                  </a:tcPr>
+                </a:tc>
+              </a:tr>
+              <a:tr h="594360">
+                <a:tc>
+                  <a:txBody>
+                    <a:bodyPr/>
+                    <a:lstStyle/>
+                    <a:p>
+                      <a:pPr indent="0" marL="0">
+                        <a:buNone/>
+                      </a:pPr>
+                      <a:r>
+                        <a:rPr lang="en-US" sz="1200" b="1" dirty="0">
+                          <a:solidFill>
+                            <a:srgbClr val="222222"/>
+                          </a:solidFill>
+                          <a:latin typeface="Calibri" pitchFamily="34" charset="0"/>
+                          <a:ea typeface="Calibri" pitchFamily="34" charset="-122"/>
+                          <a:cs typeface="Calibri" pitchFamily="34" charset="-120"/>
+                        </a:rPr>
+                        <a:t>休假</a:t>
+                      </a:r>
+                      <a:endParaRPr lang="en-US" sz="1200" dirty="0">
+                        <a:latin typeface="Calibri" charset="0"/>
+                        <a:ea typeface="Calibri" charset="0"/>
+                        <a:cs typeface="Calibri" charset="0"/>
+                      </a:endParaRPr>
+                    </a:p>
+                  </a:txBody>
+                  <a:tcPr marL="91440" marR="91440" marT="45720" marB="45720" anchor="ctr">
+                    <a:lnL w="6350" cap="flat" cmpd="sng" algn="ctr">
+                      <a:solidFill>
+                        <a:srgbClr val="D5DBE6"/>
+                      </a:solidFill>
+                      <a:prstDash val="solid"/>
+                      <a:round/>
+                      <a:headEnd type="none" w="med" len="med"/>
+                      <a:tailEnd type="none" w="med" len="med"/>
+                    </a:lnL>
+                    <a:lnR w="6350" cap="flat" cmpd="sng" algn="ctr">
+                      <a:solidFill>
+                        <a:srgbClr val="D5DBE6"/>
+                      </a:solidFill>
+                      <a:prstDash val="solid"/>
+                      <a:round/>
+                      <a:headEnd type="none" w="med" len="med"/>
+                      <a:tailEnd type="none" w="med" len="med"/>
+                    </a:lnR>
+                    <a:lnT w="6350" cap="flat" cmpd="sng" algn="ctr">
+                      <a:solidFill>
+                        <a:srgbClr val="D5DBE6"/>
+                      </a:solidFill>
+                      <a:prstDash val="solid"/>
+                      <a:round/>
+                      <a:headEnd type="none" w="med" len="med"/>
+                      <a:tailEnd type="none" w="med" len="med"/>
+                    </a:lnT>
+                    <a:lnB w="6350" cap="flat" cmpd="sng" algn="ctr">
+                      <a:solidFill>
+                        <a:srgbClr val="D5DBE6"/>
+                      </a:solidFill>
+                      <a:prstDash val="solid"/>
+                      <a:round/>
+                      <a:headEnd type="none" w="med" len="med"/>
+                      <a:tailEnd type="none" w="med" len="med"/>
+                    </a:lnB>
+                    <a:solidFill>
+                      <a:srgbClr val="FFFFFF"/>
+                    </a:solidFill>
+                  </a:tcPr>
+                </a:tc>
+                <a:tc>
+                  <a:txBody>
+                    <a:bodyPr/>
+                    <a:lstStyle/>
+                    <a:p>
+                      <a:pPr indent="0" marL="0">
+                        <a:buNone/>
+                      </a:pPr>
+                      <a:r>
+                        <a:rPr lang="en-US" sz="1200" dirty="0">
+                          <a:solidFill>
+                            <a:srgbClr val="222222"/>
+                          </a:solidFill>
+                          <a:latin typeface="Calibri" pitchFamily="34" charset="0"/>
+                          <a:ea typeface="Calibri" pitchFamily="34" charset="-122"/>
+                          <a:cs typeface="Calibri" pitchFamily="34" charset="-120"/>
+                        </a:rPr>
+                        <a:t>3</a:t>
+                      </a:r>
+                      <a:endParaRPr lang="en-US" sz="1200" dirty="0">
+                        <a:latin typeface="Calibri" charset="0"/>
+                        <a:ea typeface="Calibri" charset="0"/>
+                        <a:cs typeface="Calibri" charset="0"/>
+                      </a:endParaRPr>
+                    </a:p>
+                  </a:txBody>
+                  <a:tcPr marL="91440" marR="91440" marT="45720" marB="45720" anchor="ctr">
+                    <a:lnL w="6350" cap="flat" cmpd="sng" algn="ctr">
+                      <a:solidFill>
+                        <a:srgbClr val="D5DBE6"/>
+                      </a:solidFill>
+                      <a:prstDash val="solid"/>
+                      <a:round/>
+                      <a:headEnd type="none" w="med" len="med"/>
+                      <a:tailEnd type="none" w="med" len="med"/>
+                    </a:lnL>
+                    <a:lnR w="6350" cap="flat" cmpd="sng" algn="ctr">
+                      <a:solidFill>
+                        <a:srgbClr val="D5DBE6"/>
+                      </a:solidFill>
+                      <a:prstDash val="solid"/>
+                      <a:round/>
+                      <a:headEnd type="none" w="med" len="med"/>
+                      <a:tailEnd type="none" w="med" len="med"/>
+                    </a:lnR>
+                    <a:lnT w="6350" cap="flat" cmpd="sng" algn="ctr">
+                      <a:solidFill>
+                        <a:srgbClr val="D5DBE6"/>
+                      </a:solidFill>
+                      <a:prstDash val="solid"/>
+                      <a:round/>
+                      <a:headEnd type="none" w="med" len="med"/>
+                      <a:tailEnd type="none" w="med" len="med"/>
+                    </a:lnT>
+                    <a:lnB w="6350" cap="flat" cmpd="sng" algn="ctr">
+                      <a:solidFill>
+                        <a:srgbClr val="D5DBE6"/>
+                      </a:solidFill>
+                      <a:prstDash val="solid"/>
+                      <a:round/>
+                      <a:headEnd type="none" w="med" len="med"/>
+                      <a:tailEnd type="none" w="med" len="med"/>
+                    </a:lnB>
+                    <a:solidFill>
+                      <a:srgbClr val="FFFFFF"/>
+                    </a:solidFill>
+                  </a:tcPr>
+                </a:tc>
+                <a:tc>
+                  <a:txBody>
+                    <a:bodyPr/>
+                    <a:lstStyle/>
+                    <a:p>
+                      <a:pPr indent="0" marL="0">
+                        <a:buNone/>
+                      </a:pPr>
+                      <a:r>
+                        <a:rPr lang="en-US" sz="1200" dirty="0">
+                          <a:solidFill>
+                            <a:srgbClr val="222222"/>
+                          </a:solidFill>
+                          <a:latin typeface="Calibri" pitchFamily="34" charset="0"/>
+                          <a:ea typeface="Calibri" pitchFamily="34" charset="-122"/>
+                          <a:cs typeface="Calibri" pitchFamily="34" charset="-120"/>
+                        </a:rPr>
+                        <a:t>週休二日,小寒假、小暑假各約 1 週,優於法令的旅遊假</a:t>
+                      </a:r>
+                      <a:endParaRPr lang="en-US" sz="1200" dirty="0">
+                        <a:latin typeface="Calibri" charset="0"/>
+                        <a:ea typeface="Calibri" charset="0"/>
+                        <a:cs typeface="Calibri" charset="0"/>
+                      </a:endParaRPr>
+                    </a:p>
+                  </a:txBody>
+                  <a:tcPr marL="91440" marR="91440" marT="45720" marB="45720" anchor="ctr">
+                    <a:lnL w="6350" cap="flat" cmpd="sng" algn="ctr">
+                      <a:solidFill>
+                        <a:srgbClr val="D5DBE6"/>
+                      </a:solidFill>
+                      <a:prstDash val="solid"/>
+                      <a:round/>
+                      <a:headEnd type="none" w="med" len="med"/>
+                      <a:tailEnd type="none" w="med" len="med"/>
+                    </a:lnL>
+                    <a:lnR w="6350" cap="flat" cmpd="sng" algn="ctr">
+                      <a:solidFill>
+                        <a:srgbClr val="D5DBE6"/>
+                      </a:solidFill>
+                      <a:prstDash val="solid"/>
+                      <a:round/>
+                      <a:headEnd type="none" w="med" len="med"/>
+                      <a:tailEnd type="none" w="med" len="med"/>
+                    </a:lnR>
+                    <a:lnT w="6350" cap="flat" cmpd="sng" algn="ctr">
+                      <a:solidFill>
+                        <a:srgbClr val="D5DBE6"/>
+                      </a:solidFill>
+                      <a:prstDash val="solid"/>
+                      <a:round/>
+                      <a:headEnd type="none" w="med" len="med"/>
+                      <a:tailEnd type="none" w="med" len="med"/>
+                    </a:lnT>
+                    <a:lnB w="6350" cap="flat" cmpd="sng" algn="ctr">
+                      <a:solidFill>
+                        <a:srgbClr val="D5DBE6"/>
+                      </a:solidFill>
+                      <a:prstDash val="solid"/>
+                      <a:round/>
+                      <a:headEnd type="none" w="med" len="med"/>
+                      <a:tailEnd type="none" w="med" len="med"/>
+                    </a:lnB>
+                    <a:solidFill>
+                      <a:srgbClr val="FFFFFF"/>
+                    </a:solidFill>
+                  </a:tcPr>
+                </a:tc>
+              </a:tr>
+              <a:tr h="411480">
+                <a:tc>
+                  <a:txBody>
+                    <a:bodyPr/>
+                    <a:lstStyle/>
+                    <a:p>
+                      <a:pPr indent="0" marL="0">
+                        <a:buNone/>
+                      </a:pPr>
+                      <a:r>
+                        <a:rPr lang="en-US" sz="1200" b="1" dirty="0">
+                          <a:solidFill>
+                            <a:srgbClr val="222222"/>
+                          </a:solidFill>
+                          <a:latin typeface="Calibri" pitchFamily="34" charset="0"/>
+                          <a:ea typeface="Calibri" pitchFamily="34" charset="-122"/>
+                          <a:cs typeface="Calibri" pitchFamily="34" charset="-120"/>
+                        </a:rPr>
+                        <a:t>體檢</a:t>
+                      </a:r>
+                      <a:endParaRPr lang="en-US" sz="1200" dirty="0">
+                        <a:latin typeface="Calibri" charset="0"/>
+                        <a:ea typeface="Calibri" charset="0"/>
+                        <a:cs typeface="Calibri" charset="0"/>
+                      </a:endParaRPr>
+                    </a:p>
+                  </a:txBody>
+                  <a:tcPr marL="91440" marR="91440" marT="45720" marB="45720" anchor="ctr">
+                    <a:lnL w="6350" cap="flat" cmpd="sng" algn="ctr">
+                      <a:solidFill>
+                        <a:srgbClr val="D5DBE6"/>
+                      </a:solidFill>
+                      <a:prstDash val="solid"/>
+                      <a:round/>
+                      <a:headEnd type="none" w="med" len="med"/>
+                      <a:tailEnd type="none" w="med" len="med"/>
+                    </a:lnL>
+                    <a:lnR w="6350" cap="flat" cmpd="sng" algn="ctr">
+                      <a:solidFill>
+                        <a:srgbClr val="D5DBE6"/>
+                      </a:solidFill>
+                      <a:prstDash val="solid"/>
+                      <a:round/>
+                      <a:headEnd type="none" w="med" len="med"/>
+                      <a:tailEnd type="none" w="med" len="med"/>
+                    </a:lnR>
+                    <a:lnT w="6350" cap="flat" cmpd="sng" algn="ctr">
+                      <a:solidFill>
+                        <a:srgbClr val="D5DBE6"/>
+                      </a:solidFill>
+                      <a:prstDash val="solid"/>
+                      <a:round/>
+                      <a:headEnd type="none" w="med" len="med"/>
+                      <a:tailEnd type="none" w="med" len="med"/>
+                    </a:lnT>
+                    <a:lnB w="6350" cap="flat" cmpd="sng" algn="ctr">
+                      <a:solidFill>
+                        <a:srgbClr val="D5DBE6"/>
+                      </a:solidFill>
+                      <a:prstDash val="solid"/>
+                      <a:round/>
+                      <a:headEnd type="none" w="med" len="med"/>
+                      <a:tailEnd type="none" w="med" len="med"/>
+                    </a:lnB>
+                    <a:solidFill>
+                      <a:srgbClr val="FFFFFF"/>
+                    </a:solidFill>
+                  </a:tcPr>
+                </a:tc>
+                <a:tc>
+                  <a:txBody>
+                    <a:bodyPr/>
+                    <a:lstStyle/>
+                    <a:p>
+                      <a:pPr indent="0" marL="0">
+                        <a:buNone/>
+                      </a:pPr>
+                      <a:r>
+                        <a:rPr lang="en-US" sz="1200" dirty="0">
+                          <a:solidFill>
+                            <a:srgbClr val="222222"/>
+                          </a:solidFill>
+                          <a:latin typeface="Calibri" pitchFamily="34" charset="0"/>
+                          <a:ea typeface="Calibri" pitchFamily="34" charset="-122"/>
+                          <a:cs typeface="Calibri" pitchFamily="34" charset="-120"/>
+                        </a:rPr>
+                        <a:t>1</a:t>
+                      </a:r>
+                      <a:endParaRPr lang="en-US" sz="1200" dirty="0">
+                        <a:latin typeface="Calibri" charset="0"/>
+                        <a:ea typeface="Calibri" charset="0"/>
+                        <a:cs typeface="Calibri" charset="0"/>
+                      </a:endParaRPr>
+                    </a:p>
+                  </a:txBody>
+                  <a:tcPr marL="91440" marR="91440" marT="45720" marB="45720" anchor="ctr">
+                    <a:lnL w="6350" cap="flat" cmpd="sng" algn="ctr">
+                      <a:solidFill>
+                        <a:srgbClr val="D5DBE6"/>
+                      </a:solidFill>
+                      <a:prstDash val="solid"/>
+                      <a:round/>
+                      <a:headEnd type="none" w="med" len="med"/>
+                      <a:tailEnd type="none" w="med" len="med"/>
+                    </a:lnL>
+                    <a:lnR w="6350" cap="flat" cmpd="sng" algn="ctr">
+                      <a:solidFill>
+                        <a:srgbClr val="D5DBE6"/>
+                      </a:solidFill>
+                      <a:prstDash val="solid"/>
+                      <a:round/>
+                      <a:headEnd type="none" w="med" len="med"/>
+                      <a:tailEnd type="none" w="med" len="med"/>
+                    </a:lnR>
+                    <a:lnT w="6350" cap="flat" cmpd="sng" algn="ctr">
+                      <a:solidFill>
+                        <a:srgbClr val="D5DBE6"/>
+                      </a:solidFill>
+                      <a:prstDash val="solid"/>
+                      <a:round/>
+                      <a:headEnd type="none" w="med" len="med"/>
+                      <a:tailEnd type="none" w="med" len="med"/>
+                    </a:lnT>
+                    <a:lnB w="6350" cap="flat" cmpd="sng" algn="ctr">
+                      <a:solidFill>
+                        <a:srgbClr val="D5DBE6"/>
+                      </a:solidFill>
+                      <a:prstDash val="solid"/>
+                      <a:round/>
+                      <a:headEnd type="none" w="med" len="med"/>
+                      <a:tailEnd type="none" w="med" len="med"/>
+                    </a:lnB>
+                    <a:solidFill>
+                      <a:srgbClr val="FFFFFF"/>
+                    </a:solidFill>
+                  </a:tcPr>
+                </a:tc>
+                <a:tc>
+                  <a:txBody>
+                    <a:bodyPr/>
+                    <a:lstStyle/>
+                    <a:p>
+                      <a:pPr indent="0" marL="0">
+                        <a:buNone/>
+                      </a:pPr>
+                      <a:r>
+                        <a:rPr lang="en-US" sz="1200" dirty="0">
+                          <a:solidFill>
+                            <a:srgbClr val="222222"/>
+                          </a:solidFill>
+                          <a:latin typeface="Calibri" pitchFamily="34" charset="0"/>
+                          <a:ea typeface="Calibri" pitchFamily="34" charset="-122"/>
+                          <a:cs typeface="Calibri" pitchFamily="34" charset="-120"/>
+                        </a:rPr>
+                        <a:t>醫師駐廠看診、定期健康檢查</a:t>
+                      </a:r>
+                      <a:endParaRPr lang="en-US" sz="1200" dirty="0">
+                        <a:latin typeface="Calibri" charset="0"/>
+                        <a:ea typeface="Calibri" charset="0"/>
+                        <a:cs typeface="Calibri" charset="0"/>
+                      </a:endParaRPr>
+                    </a:p>
+                  </a:txBody>
+                  <a:tcPr marL="91440" marR="91440" marT="45720" marB="45720" anchor="ctr">
+                    <a:lnL w="6350" cap="flat" cmpd="sng" algn="ctr">
+                      <a:solidFill>
+                        <a:srgbClr val="D5DBE6"/>
+                      </a:solidFill>
+                      <a:prstDash val="solid"/>
+                      <a:round/>
+                      <a:headEnd type="none" w="med" len="med"/>
+                      <a:tailEnd type="none" w="med" len="med"/>
+                    </a:lnL>
+                    <a:lnR w="6350" cap="flat" cmpd="sng" algn="ctr">
+                      <a:solidFill>
+                        <a:srgbClr val="D5DBE6"/>
+                      </a:solidFill>
+                      <a:prstDash val="solid"/>
+                      <a:round/>
+                      <a:headEnd type="none" w="med" len="med"/>
+                      <a:tailEnd type="none" w="med" len="med"/>
+                    </a:lnR>
+                    <a:lnT w="6350" cap="flat" cmpd="sng" algn="ctr">
+                      <a:solidFill>
+                        <a:srgbClr val="D5DBE6"/>
+                      </a:solidFill>
+                      <a:prstDash val="solid"/>
+                      <a:round/>
+                      <a:headEnd type="none" w="med" len="med"/>
+                      <a:tailEnd type="none" w="med" len="med"/>
+                    </a:lnT>
+                    <a:lnB w="6350" cap="flat" cmpd="sng" algn="ctr">
+                      <a:solidFill>
+                        <a:srgbClr val="D5DBE6"/>
+                      </a:solidFill>
+                      <a:prstDash val="solid"/>
+                      <a:round/>
+                      <a:headEnd type="none" w="med" len="med"/>
+                      <a:tailEnd type="none" w="med" len="med"/>
+                    </a:lnB>
+                    <a:solidFill>
+                      <a:srgbClr val="FFFFFF"/>
+                    </a:solidFill>
+                  </a:tcPr>
+                </a:tc>
+              </a:tr>
+              <a:tr h="457200">
+                <a:tc>
+                  <a:txBody>
+                    <a:bodyPr/>
+                    <a:lstStyle/>
+                    <a:p>
+                      <a:pPr indent="0" marL="0">
+                        <a:buNone/>
+                      </a:pPr>
+                      <a:r>
+                        <a:rPr lang="en-US" sz="1200" b="1" dirty="0">
+                          <a:solidFill>
+                            <a:srgbClr val="222222"/>
+                          </a:solidFill>
+                          <a:latin typeface="Calibri" pitchFamily="34" charset="0"/>
+                          <a:ea typeface="Calibri" pitchFamily="34" charset="-122"/>
+                          <a:cs typeface="Calibri" pitchFamily="34" charset="-120"/>
+                        </a:rPr>
+                        <a:t>加班費</a:t>
+                      </a:r>
+                      <a:endParaRPr lang="en-US" sz="1200" dirty="0">
+                        <a:latin typeface="Calibri" charset="0"/>
+                        <a:ea typeface="Calibri" charset="0"/>
+                        <a:cs typeface="Calibri" charset="0"/>
+                      </a:endParaRPr>
+                    </a:p>
+                  </a:txBody>
+                  <a:tcPr marL="91440" marR="91440" marT="45720" marB="45720" anchor="ctr">
+                    <a:lnL w="6350" cap="flat" cmpd="sng" algn="ctr">
+                      <a:solidFill>
+                        <a:srgbClr val="D5DBE6"/>
+                      </a:solidFill>
+                      <a:prstDash val="solid"/>
+                      <a:round/>
+                      <a:headEnd type="none" w="med" len="med"/>
+                      <a:tailEnd type="none" w="med" len="med"/>
+                    </a:lnL>
+                    <a:lnR w="6350" cap="flat" cmpd="sng" algn="ctr">
+                      <a:solidFill>
+                        <a:srgbClr val="D5DBE6"/>
+                      </a:solidFill>
+                      <a:prstDash val="solid"/>
+                      <a:round/>
+                      <a:headEnd type="none" w="med" len="med"/>
+                      <a:tailEnd type="none" w="med" len="med"/>
+                    </a:lnR>
+                    <a:lnT w="6350" cap="flat" cmpd="sng" algn="ctr">
+                      <a:solidFill>
+                        <a:srgbClr val="D5DBE6"/>
+                      </a:solidFill>
+                      <a:prstDash val="solid"/>
+                      <a:round/>
+                      <a:headEnd type="none" w="med" len="med"/>
+                      <a:tailEnd type="none" w="med" len="med"/>
+                    </a:lnT>
+                    <a:lnB w="6350" cap="flat" cmpd="sng" algn="ctr">
+                      <a:solidFill>
+                        <a:srgbClr val="D5DBE6"/>
+                      </a:solidFill>
+                      <a:prstDash val="solid"/>
+                      <a:round/>
+                      <a:headEnd type="none" w="med" len="med"/>
+                      <a:tailEnd type="none" w="med" len="med"/>
+                    </a:lnB>
+                    <a:solidFill>
+                      <a:srgbClr val="FFFFFF"/>
+                    </a:solidFill>
+                  </a:tcPr>
+                </a:tc>
+                <a:tc>
+                  <a:txBody>
+                    <a:bodyPr/>
+                    <a:lstStyle/>
+                    <a:p>
+                      <a:pPr indent="0" marL="0">
+                        <a:buNone/>
+                      </a:pPr>
+                      <a:r>
+                        <a:rPr lang="en-US" sz="1200" dirty="0">
+                          <a:solidFill>
+                            <a:srgbClr val="222222"/>
+                          </a:solidFill>
+                          <a:latin typeface="Calibri" pitchFamily="34" charset="0"/>
+                          <a:ea typeface="Calibri" pitchFamily="34" charset="-122"/>
+                          <a:cs typeface="Calibri" pitchFamily="34" charset="-120"/>
+                        </a:rPr>
+                        <a:t>3</a:t>
+                      </a:r>
+                      <a:endParaRPr lang="en-US" sz="1200" dirty="0">
+                        <a:latin typeface="Calibri" charset="0"/>
+                        <a:ea typeface="Calibri" charset="0"/>
+                        <a:cs typeface="Calibri" charset="0"/>
+                      </a:endParaRPr>
+                    </a:p>
+                  </a:txBody>
+                  <a:tcPr marL="91440" marR="91440" marT="45720" marB="45720" anchor="ctr">
+                    <a:lnL w="6350" cap="flat" cmpd="sng" algn="ctr">
+                      <a:solidFill>
+                        <a:srgbClr val="D5DBE6"/>
+                      </a:solidFill>
+                      <a:prstDash val="solid"/>
+                      <a:round/>
+                      <a:headEnd type="none" w="med" len="med"/>
+                      <a:tailEnd type="none" w="med" len="med"/>
+                    </a:lnL>
+                    <a:lnR w="6350" cap="flat" cmpd="sng" algn="ctr">
+                      <a:solidFill>
+                        <a:srgbClr val="D5DBE6"/>
+                      </a:solidFill>
+                      <a:prstDash val="solid"/>
+                      <a:round/>
+                      <a:headEnd type="none" w="med" len="med"/>
+                      <a:tailEnd type="none" w="med" len="med"/>
+                    </a:lnR>
+                    <a:lnT w="6350" cap="flat" cmpd="sng" algn="ctr">
+                      <a:solidFill>
+                        <a:srgbClr val="D5DBE6"/>
+                      </a:solidFill>
+                      <a:prstDash val="solid"/>
+                      <a:round/>
+                      <a:headEnd type="none" w="med" len="med"/>
+                      <a:tailEnd type="none" w="med" len="med"/>
+                    </a:lnT>
+                    <a:lnB w="6350" cap="flat" cmpd="sng" algn="ctr">
+                      <a:solidFill>
+                        <a:srgbClr val="D5DBE6"/>
+                      </a:solidFill>
+                      <a:prstDash val="solid"/>
+                      <a:round/>
+                      <a:headEnd type="none" w="med" len="med"/>
+                      <a:tailEnd type="none" w="med" len="med"/>
+                    </a:lnB>
+                    <a:solidFill>
+                      <a:srgbClr val="FFFFFF"/>
+                    </a:solidFill>
+                  </a:tcPr>
+                </a:tc>
+                <a:tc>
+                  <a:txBody>
+                    <a:bodyPr/>
+                    <a:lstStyle/>
+                    <a:p>
+                      <a:pPr indent="0" marL="0">
+                        <a:buNone/>
+                      </a:pPr>
+                      <a:r>
+                        <a:rPr lang="en-US" sz="1200" dirty="0">
+                          <a:solidFill>
+                            <a:srgbClr val="222222"/>
+                          </a:solidFill>
+                          <a:latin typeface="Calibri" pitchFamily="34" charset="0"/>
+                          <a:ea typeface="Calibri" pitchFamily="34" charset="-122"/>
+                          <a:cs typeface="Calibri" pitchFamily="34" charset="-120"/>
+                        </a:rPr>
+                        <a:t>公司頁未載明,需向人資確認</a:t>
+                      </a:r>
+                      <a:endParaRPr lang="en-US" sz="1200" dirty="0">
+                        <a:latin typeface="Calibri" charset="0"/>
+                        <a:ea typeface="Calibri" charset="0"/>
+                        <a:cs typeface="Calibri" charset="0"/>
+                      </a:endParaRPr>
+                    </a:p>
+                  </a:txBody>
+                  <a:tcPr marL="91440" marR="91440" marT="45720" marB="45720" anchor="ctr">
+                    <a:lnL w="6350" cap="flat" cmpd="sng" algn="ctr">
+                      <a:solidFill>
+                        <a:srgbClr val="D5DBE6"/>
+                      </a:solidFill>
+                      <a:prstDash val="solid"/>
+                      <a:round/>
+                      <a:headEnd type="none" w="med" len="med"/>
+                      <a:tailEnd type="none" w="med" len="med"/>
+                    </a:lnL>
+                    <a:lnR w="6350" cap="flat" cmpd="sng" algn="ctr">
+                      <a:solidFill>
+                        <a:srgbClr val="D5DBE6"/>
+                      </a:solidFill>
+                      <a:prstDash val="solid"/>
+                      <a:round/>
+                      <a:headEnd type="none" w="med" len="med"/>
+                      <a:tailEnd type="none" w="med" len="med"/>
+                    </a:lnR>
+                    <a:lnT w="6350" cap="flat" cmpd="sng" algn="ctr">
+                      <a:solidFill>
+                        <a:srgbClr val="D5DBE6"/>
+                      </a:solidFill>
+                      <a:prstDash val="solid"/>
+                      <a:round/>
+                      <a:headEnd type="none" w="med" len="med"/>
+                      <a:tailEnd type="none" w="med" len="med"/>
+                    </a:lnT>
+                    <a:lnB w="6350" cap="flat" cmpd="sng" algn="ctr">
+                      <a:solidFill>
+                        <a:srgbClr val="D5DBE6"/>
+                      </a:solidFill>
+                      <a:prstDash val="solid"/>
+                      <a:round/>
+                      <a:headEnd type="none" w="med" len="med"/>
+                      <a:tailEnd type="none" w="med" len="med"/>
+                    </a:lnB>
+                    <a:solidFill>
+                      <a:srgbClr val="FFFFFF"/>
+                    </a:solidFill>
+                  </a:tcPr>
+                </a:tc>
+              </a:tr>
+            </a:tbl>
+          </a:graphicData>
+        </a:graphic>
+      </p:graphicFrame>
+      <p:pic>
+        <p:nvPicPr>
+          <p:cNvPr id="6" name="Image 0" descr="img/cmc.jpg">    </p:cNvPr>
+          <p:cNvPicPr>
+            <a:picLocks noChangeAspect="1"/>
+          </p:cNvPicPr>
+          <p:nvPr/>
+        </p:nvPicPr>
+        <p:blipFill>
+          <a:blip r:embed="rId1"/>
+          <a:stretch>
+            <a:fillRect/>
+          </a:stretch>
+        </p:blipFill>
+        <p:spPr>
+          <a:xfrm>
+            <a:off x="6126480" y="1005840"/>
+            <a:ext cx="2286000" cy="3529584"/>
+          </a:xfrm>
+          <a:prstGeom prst="rect">
+            <a:avLst/>
+          </a:prstGeom>
+        </p:spPr>
+      </p:pic>
+      <p:sp>
+        <p:nvSpPr>
+          <p:cNvPr id="7" name="Text 3"/>
           <p:cNvSpPr txBox="1"/>
           <p:nvPr/>
         </p:nvSpPr>
         <p:spPr>
           <a:xfrm>
-            <a:off x="640080" y="1161288"/>
-            <a:ext cx="3657600" cy="365760"/>
+            <a:off x="457200" y="4663440"/>
+            <a:ext cx="8229600" cy="274320"/>
           </a:xfrm>
           <a:prstGeom prst="rect">
             <a:avLst/>
@@ -6600,295 +8720,17 @@
               <a:buNone/>
             </a:pPr>
             <a:r>
-              <a:rPr lang="en-US" sz="1600" b="1" dirty="0">
-                <a:solidFill>
-                  <a:srgbClr val="1B2A41"/>
-                </a:solidFill>
-                <a:latin typeface="Calibri" pitchFamily="34" charset="0"/>
-                <a:ea typeface="Calibri" pitchFamily="34" charset="-122"/>
-                <a:cs typeface="Calibri" pitchFamily="34" charset="-120"/>
-              </a:rPr>
-              <a:t>觀察分析</a:t>
-            </a:r>
-            <a:endParaRPr lang="en-US" sz="1600" dirty="0"/>
-          </a:p>
-        </p:txBody>
-      </p:sp>
-      <p:sp>
-        <p:nvSpPr>
-          <p:cNvPr id="7" name="Text 5"/>
-          <p:cNvSpPr txBox="1"/>
-          <p:nvPr/>
-        </p:nvSpPr>
-        <p:spPr>
-          <a:xfrm>
-            <a:off x="640080" y="1554480"/>
-            <a:ext cx="3657600" cy="2971800"/>
-          </a:xfrm>
-          <a:prstGeom prst="rect">
-            <a:avLst/>
-          </a:prstGeom>
-          <a:noFill/>
-          <a:ln/>
-        </p:spPr>
-        <p:txBody>
-          <a:bodyPr wrap="square" lIns="0" tIns="0" rIns="0" bIns="0" rtlCol="0" anchor="t"/>
-          <a:lstStyle/>
-          <a:p>
-            <a:pPr marL="342900" indent="-342900">
-              <a:spcAft>
-                <a:spcPts val="400"/>
-              </a:spcAft>
-              <a:buSzPct val="100000"/>
-              <a:buChar char="•"/>
-            </a:pPr>
-            <a:r>
-              <a:rPr lang="en-US" sz="1400" dirty="0">
-                <a:solidFill>
-                  <a:srgbClr val="222222"/>
-                </a:solidFill>
-                <a:latin typeface="Calibri" pitchFamily="34" charset="0"/>
-                <a:ea typeface="Calibri" pitchFamily="34" charset="-122"/>
-                <a:cs typeface="Calibri" pitchFamily="34" charset="-120"/>
-              </a:rPr>
-              <a:t>新鮮人談福利,第一關仍是「錢」:17 則中 14 則提到薪資、獎金或年終</a:t>
-            </a:r>
-            <a:endParaRPr lang="en-US" sz="1400" dirty="0"/>
-          </a:p>
-          <a:p>
-            <a:pPr marL="342900" indent="-342900">
-              <a:spcAft>
-                <a:spcPts val="400"/>
-              </a:spcAft>
-              <a:buSzPct val="100000"/>
-              <a:buChar char="•"/>
-            </a:pPr>
-            <a:r>
-              <a:rPr lang="en-US" sz="1400" dirty="0">
-                <a:solidFill>
-                  <a:srgbClr val="222222"/>
-                </a:solidFill>
-                <a:latin typeface="Calibri" pitchFamily="34" charset="0"/>
-                <a:ea typeface="Calibri" pitchFamily="34" charset="-122"/>
-                <a:cs typeface="Calibri" pitchFamily="34" charset="-120"/>
-              </a:rPr>
-              <a:t>其次是「日常體驗」:餐飲零食、彈性/遠端、優於勞基法的休假</a:t>
-            </a:r>
-            <a:endParaRPr lang="en-US" sz="1400" dirty="0"/>
-          </a:p>
-          <a:p>
-            <a:pPr marL="342900" indent="-342900">
-              <a:spcAft>
-                <a:spcPts val="400"/>
-              </a:spcAft>
-              <a:buSzPct val="100000"/>
-              <a:buChar char="•"/>
-            </a:pPr>
-            <a:r>
-              <a:rPr lang="en-US" sz="1400" dirty="0">
-                <a:solidFill>
-                  <a:srgbClr val="222222"/>
-                </a:solidFill>
-                <a:latin typeface="Calibri" pitchFamily="34" charset="0"/>
-                <a:ea typeface="Calibri" pitchFamily="34" charset="-122"/>
-                <a:cs typeface="Calibri" pitchFamily="34" charset="-120"/>
-              </a:rPr>
-              <a:t>小確幸(生日、蛋糕、零食)互動雖低,卻最容易引發羨慕與分享</a:t>
-            </a:r>
-            <a:endParaRPr lang="en-US" sz="1400" dirty="0"/>
-          </a:p>
-          <a:p>
-            <a:pPr marL="342900" indent="-342900">
-              <a:spcAft>
-                <a:spcPts val="400"/>
-              </a:spcAft>
-              <a:buSzPct val="100000"/>
-              <a:buChar char="•"/>
-            </a:pPr>
-            <a:r>
-              <a:rPr lang="en-US" sz="1400" dirty="0">
-                <a:solidFill>
-                  <a:srgbClr val="222222"/>
-                </a:solidFill>
-                <a:latin typeface="Calibri" pitchFamily="34" charset="0"/>
-                <a:ea typeface="Calibri" pitchFamily="34" charset="-122"/>
-                <a:cs typeface="Calibri" pitchFamily="34" charset="-120"/>
-              </a:rPr>
-              <a:t>也有人提醒:員工旅遊、聚餐若不能折現,對內向者是負擔</a:t>
-            </a:r>
-            <a:endParaRPr lang="en-US" sz="1400" dirty="0"/>
-          </a:p>
-        </p:txBody>
-      </p:sp>
-      <p:sp>
-        <p:nvSpPr>
-          <p:cNvPr id="8" name="Shape 6"/>
-          <p:cNvSpPr/>
-          <p:nvPr/>
-        </p:nvSpPr>
-        <p:spPr>
-          <a:xfrm>
-            <a:off x="4663440" y="1051560"/>
-            <a:ext cx="4023360" cy="3566160"/>
-          </a:xfrm>
-          <a:prstGeom prst="roundRect">
-            <a:avLst>
-              <a:gd name="adj" fmla="val 2051"/>
-            </a:avLst>
-          </a:prstGeom>
-          <a:solidFill>
-            <a:srgbClr val="F3F5F8"/>
-          </a:solidFill>
-          <a:ln w="12700">
-            <a:solidFill>
-              <a:srgbClr val="F3F5F8"/>
-            </a:solidFill>
-            <a:prstDash val="solid"/>
-          </a:ln>
-        </p:spPr>
-      </p:sp>
-      <p:sp>
-        <p:nvSpPr>
-          <p:cNvPr id="9" name="Text 7"/>
-          <p:cNvSpPr txBox="1"/>
-          <p:nvPr/>
-        </p:nvSpPr>
-        <p:spPr>
-          <a:xfrm>
-            <a:off x="4846320" y="1161288"/>
-            <a:ext cx="3657600" cy="365760"/>
-          </a:xfrm>
-          <a:prstGeom prst="rect">
-            <a:avLst/>
-          </a:prstGeom>
-          <a:noFill/>
-          <a:ln/>
-        </p:spPr>
-        <p:txBody>
-          <a:bodyPr wrap="square" lIns="0" tIns="0" rIns="0" bIns="0" rtlCol="0" anchor="ctr"/>
-          <a:lstStyle/>
-          <a:p>
-            <a:pPr indent="0" marL="0">
-              <a:buNone/>
-            </a:pPr>
-            <a:r>
-              <a:rPr lang="en-US" sz="1600" b="1" dirty="0">
-                <a:solidFill>
-                  <a:srgbClr val="C8102E"/>
-                </a:solidFill>
-                <a:latin typeface="Calibri" pitchFamily="34" charset="0"/>
-                <a:ea typeface="Calibri" pitchFamily="34" charset="-122"/>
-                <a:cs typeface="Calibri" pitchFamily="34" charset="-120"/>
-              </a:rPr>
-              <a:t>對中華汽車的建議</a:t>
-            </a:r>
-            <a:endParaRPr lang="en-US" sz="1600" dirty="0"/>
-          </a:p>
-        </p:txBody>
-      </p:sp>
-      <p:sp>
-        <p:nvSpPr>
-          <p:cNvPr id="10" name="Text 8"/>
-          <p:cNvSpPr txBox="1"/>
-          <p:nvPr/>
-        </p:nvSpPr>
-        <p:spPr>
-          <a:xfrm>
-            <a:off x="4846320" y="1554480"/>
-            <a:ext cx="3657600" cy="2971800"/>
-          </a:xfrm>
-          <a:prstGeom prst="rect">
-            <a:avLst/>
-          </a:prstGeom>
-          <a:noFill/>
-          <a:ln/>
-        </p:spPr>
-        <p:txBody>
-          <a:bodyPr wrap="square" lIns="0" tIns="0" rIns="0" bIns="0" rtlCol="0" anchor="t"/>
-          <a:lstStyle/>
-          <a:p>
-            <a:pPr marL="342900" indent="-342900">
-              <a:spcAft>
-                <a:spcPts val="400"/>
-              </a:spcAft>
-              <a:buSzPct val="100000"/>
-              <a:buChar char="•"/>
-            </a:pPr>
-            <a:r>
-              <a:rPr lang="en-US" sz="1400" dirty="0">
-                <a:solidFill>
-                  <a:srgbClr val="222222"/>
-                </a:solidFill>
-                <a:latin typeface="Calibri" pitchFamily="34" charset="0"/>
-                <a:ea typeface="Calibri" pitchFamily="34" charset="-122"/>
-                <a:cs typeface="Calibri" pitchFamily="34" charset="-120"/>
-              </a:rPr>
-              <a:t>招募溝通先講清楚薪資結構、年終與獎金,再談其他福利</a:t>
-            </a:r>
-            <a:endParaRPr lang="en-US" sz="1400" dirty="0"/>
-          </a:p>
-          <a:p>
-            <a:pPr marL="342900" indent="-342900">
-              <a:spcAft>
-                <a:spcPts val="400"/>
-              </a:spcAft>
-              <a:buSzPct val="100000"/>
-              <a:buChar char="•"/>
-            </a:pPr>
-            <a:r>
-              <a:rPr lang="en-US" sz="1400" dirty="0">
-                <a:solidFill>
-                  <a:srgbClr val="222222"/>
-                </a:solidFill>
-                <a:latin typeface="Calibri" pitchFamily="34" charset="0"/>
-                <a:ea typeface="Calibri" pitchFamily="34" charset="-122"/>
-                <a:cs typeface="Calibri" pitchFamily="34" charset="-120"/>
-              </a:rPr>
-              <a:t>把彈性、休假與員工日常的小確幸做成真實員工故事,放在校園與社群</a:t>
-            </a:r>
-            <a:endParaRPr lang="en-US" sz="1400" dirty="0"/>
-          </a:p>
-          <a:p>
-            <a:pPr marL="342900" indent="-342900">
-              <a:spcAft>
-                <a:spcPts val="400"/>
-              </a:spcAft>
-              <a:buSzPct val="100000"/>
-              <a:buChar char="•"/>
-            </a:pPr>
-            <a:r>
-              <a:rPr lang="en-US" sz="1400" dirty="0">
-                <a:solidFill>
-                  <a:srgbClr val="222222"/>
-                </a:solidFill>
-                <a:latin typeface="Calibri" pitchFamily="34" charset="0"/>
-                <a:ea typeface="Calibri" pitchFamily="34" charset="-122"/>
-                <a:cs typeface="Calibri" pitchFamily="34" charset="-120"/>
-              </a:rPr>
-              <a:t>校園活動(如研習營)可穿插福利 Q&amp;A,回應新鮮人最常問的問題</a:t>
-            </a:r>
-            <a:endParaRPr lang="en-US" sz="1400" dirty="0"/>
-          </a:p>
-          <a:p>
-            <a:pPr marL="342900" indent="-342900">
-              <a:spcAft>
-                <a:spcPts val="400"/>
-              </a:spcAft>
-              <a:buSzPct val="100000"/>
-              <a:buChar char="•"/>
-            </a:pPr>
-            <a:r>
-              <a:rPr lang="en-US" sz="1400" dirty="0">
-                <a:solidFill>
-                  <a:srgbClr val="222222"/>
-                </a:solidFill>
-                <a:latin typeface="Calibri" pitchFamily="34" charset="0"/>
-                <a:ea typeface="Calibri" pitchFamily="34" charset="-122"/>
-                <a:cs typeface="Calibri" pitchFamily="34" charset="-120"/>
-              </a:rPr>
-              <a:t>中華汽車工作生活平衡獎(2014、2022)可作亮點</a:t>
-            </a:r>
-            <a:endParaRPr lang="en-US" sz="1400" dirty="0"/>
+              <a:rPr lang="en-US" sz="1100" dirty="0">
+                <a:solidFill>
+                  <a:srgbClr val="5B6575"/>
+                </a:solidFill>
+                <a:latin typeface="Calibri" pitchFamily="34" charset="0"/>
+                <a:ea typeface="Calibri" pitchFamily="34" charset="-122"/>
+                <a:cs typeface="Calibri" pitchFamily="34" charset="-120"/>
+              </a:rPr>
+              <a:t>資料來源:104 人力銀行「中華汽車楊梅廠」公司頁</a:t>
+            </a:r>
+            <a:endParaRPr lang="en-US" sz="1100" dirty="0"/>
           </a:p>
         </p:txBody>
       </p:sp>

</xml_diff>

<commit_message>
Fix deck: crop comments from screenshots, shape-based chart, 1111 survey data
Co-Authored-By: Claude Sonnet 5.5 <noreply@anthropic.com>
Claude-Session: https://claude.ai/code/session_01YWYmCoF2kfC3GxD29xN2Db
</commit_message>
<xml_diff>
--- a/deliverables/CMC_10月_AB任務簡報.pptx
+++ b/deliverables/CMC_10月_AB任務簡報.pptx
@@ -115,301 +115,6 @@
     </a:lvl9pPr>
   </p:defaultTextStyle>
 </p:presentation>
-</file>
-
-<file path=ppt/charts/chart1.xml><?xml version="1.0" encoding="utf-8"?>
-<c:chartSpace xmlns:c="http://schemas.openxmlformats.org/drawingml/2006/chart" xmlns:a="http://schemas.openxmlformats.org/drawingml/2006/main" xmlns:r="http://schemas.openxmlformats.org/officeDocument/2006/relationships">
-  <c:date1904 val="0"/>
-  <c:roundedCorners val="1"/>
-  <c:chart>
-    <c:title>
-      <c:tx>
-        <c:rich>
-          <a:bodyPr/>
-          <a:lstStyle/>
-          <a:p>
-            <a:pPr>
-              <a:defRPr sz="1400" b="0" i="0" u="none" strike="noStrike">
-                <a:solidFill>
-                  <a:srgbClr val="1B2A41"/>
-                </a:solidFill>
-                <a:latin typeface="Arial"/>
-              </a:defRPr>
-            </a:pPr>
-            <a:r>
-              <a:rPr sz="1400" b="0" i="0" u="none" strike="noStrike">
-                <a:solidFill>
-                  <a:srgbClr val="1B2A41"/>
-                </a:solidFill>
-                <a:latin typeface="Arial"/>
-              </a:rPr>
-              <a:t>案例 1 留言提及的福利(則,n=17)</a:t>
-            </a:r>
-          </a:p>
-        </c:rich>
-      </c:tx>
-      <c:layout/>
-      <c:overlay val="0"/>
-    </c:title>
-    <c:autoTitleDeleted val="0"/>
-    <c:plotArea>
-      <c:layout/>
-      <c:barChart>
-        <c:barDir val="bar"/>
-        <c:grouping val="clustered"/>
-        <c:varyColors val="0"/>
-        <c:ser>
-          <c:idx val="0"/>
-          <c:order val="0"/>
-          <c:tx>
-            <c:strRef>
-              <c:f>Sheet1!$B$1</c:f>
-              <c:strCache>
-                <c:ptCount val="1"/>
-                <c:pt idx="0">
-                  <c:v>提及則數</c:v>
-                </c:pt>
-              </c:strCache>
-            </c:strRef>
-          </c:tx>
-          <c:spPr>
-            <a:solidFill>
-              <a:srgbClr val="1B2A41"/>
-            </a:solidFill>
-            <a:effectLst/>
-          </c:spPr>
-          <c:invertIfNegative val="0"/>
-          <c:dLbls>
-            <c:numFmt formatCode="#,##0" sourceLinked="0"/>
-            <c:txPr>
-              <a:bodyPr/>
-              <a:lstStyle/>
-              <a:p>
-                <a:pPr>
-                  <a:defRPr b="0" i="0" strike="noStrike" sz="1200" u="none">
-                    <a:solidFill>
-                      <a:srgbClr val="000000"/>
-                    </a:solidFill>
-                    <a:latin typeface="Arial"/>
-                  </a:defRPr>
-                </a:pPr>
-              </a:p>
-            </c:txPr>
-            <c:showLegendKey val="0"/>
-            <c:showVal val="1"/>
-            <c:showCatName val="0"/>
-            <c:showSerName val="0"/>
-            <c:showPercent val="0"/>
-            <c:showBubbleSize val="0"/>
-            <c:showLeaderLines val="0"/>
-          </c:dLbls>
-          <c:cat>
-            <c:multiLvlStrRef>
-              <c:f>Sheet1!$A$2:$A$8</c:f>
-              <c:multiLvlStrCache>
-                <c:ptCount val="7"/>
-                <c:lvl>
-                  <c:pt idx="0">
-                    <c:v>體檢</c:v>
-                  </c:pt>
-                  <c:pt idx="1">
-                    <c:v>停車位</c:v>
-                  </c:pt>
-                  <c:pt idx="2">
-                    <c:v>加班費/準時下班</c:v>
-                  </c:pt>
-                  <c:pt idx="3">
-                    <c:v>休假</c:v>
-                  </c:pt>
-                  <c:pt idx="4">
-                    <c:v>彈性/遠端</c:v>
-                  </c:pt>
-                  <c:pt idx="5">
-                    <c:v>餐飲/零食/設備</c:v>
-                  </c:pt>
-                  <c:pt idx="6">
-                    <c:v>薪資/獎金/年終</c:v>
-                  </c:pt>
-                </c:lvl>
-              </c:multiLvlStrCache>
-            </c:multiLvlStrRef>
-          </c:cat>
-          <c:val>
-            <c:numRef>
-              <c:f>Sheet1!$B$2:$B$8</c:f>
-              <c:numCache>
-                <c:formatCode>General</c:formatCode>
-                <c:ptCount val="7"/>
-                <c:pt idx="0">
-                  <c:v>1</c:v>
-                </c:pt>
-                <c:pt idx="1">
-                  <c:v>2</c:v>
-                </c:pt>
-                <c:pt idx="2">
-                  <c:v>3</c:v>
-                </c:pt>
-                <c:pt idx="3">
-                  <c:v>3</c:v>
-                </c:pt>
-                <c:pt idx="4">
-                  <c:v>3</c:v>
-                </c:pt>
-                <c:pt idx="5">
-                  <c:v>5</c:v>
-                </c:pt>
-                <c:pt idx="6">
-                  <c:v>14</c:v>
-                </c:pt>
-              </c:numCache>
-            </c:numRef>
-          </c:val>
-        </c:ser>
-        <c:dLbls>
-          <c:numFmt formatCode="#,##0" sourceLinked="0"/>
-          <c:txPr>
-            <a:bodyPr/>
-            <a:lstStyle/>
-            <a:p>
-              <a:pPr>
-                <a:defRPr b="0" i="0" strike="noStrike" sz="1200" u="none">
-                  <a:solidFill>
-                    <a:srgbClr val="000000"/>
-                  </a:solidFill>
-                  <a:latin typeface="Arial"/>
-                </a:defRPr>
-              </a:pPr>
-            </a:p>
-          </c:txPr>
-          <c:showLegendKey val="0"/>
-          <c:showVal val="1"/>
-          <c:showCatName val="0"/>
-          <c:showSerName val="0"/>
-          <c:showPercent val="0"/>
-          <c:showBubbleSize val="0"/>
-          <c:showLeaderLines val="0"/>
-        </c:dLbls>
-        <c:gapWidth val="150"/>
-        <c:overlap val="0"/>
-        <c:axId val="2094734554"/>
-        <c:axId val="2094734552"/>
-        <c:axId val="2094734556"/>
-      </c:barChart>
-      <c:catAx>
-        <c:axId val="2094734554"/>
-        <c:scaling>
-          <c:orientation val="minMax"/>
-        </c:scaling>
-        <c:delete val="0"/>
-        <c:axPos val="l"/>
-        <c:numFmt formatCode="General" sourceLinked="1"/>
-        <c:majorTickMark val="out"/>
-        <c:minorTickMark val="none"/>
-        <c:tickLblPos val="nextTo"/>
-        <c:spPr>
-          <a:ln w="12700" cap="flat">
-            <a:solidFill>
-              <a:srgbClr val="888888"/>
-            </a:solidFill>
-            <a:prstDash val="solid"/>
-            <a:round/>
-          </a:ln>
-        </c:spPr>
-        <c:txPr>
-          <a:bodyPr/>
-          <a:lstStyle/>
-          <a:p>
-            <a:pPr>
-              <a:defRPr sz="1200" b="0" i="0" u="none" strike="noStrike">
-                <a:solidFill>
-                  <a:srgbClr val="000000"/>
-                </a:solidFill>
-                <a:latin typeface="Arial"/>
-              </a:defRPr>
-            </a:pPr>
-            <a:endParaRPr lang="en-US"/>
-          </a:p>
-        </c:txPr>
-        <c:crossAx val="2094734552"/>
-        <c:crosses val="autoZero"/>
-        <c:auto val="1"/>
-        <c:lblAlgn val="ctr"/>
-        <c:noMultiLvlLbl val="1"/>
-      </c:catAx>
-      <c:valAx>
-        <c:axId val="2094734552"/>
-        <c:scaling>
-          <c:orientation val="minMax"/>
-          <c:max val="16"/>
-          <c:min val="0"/>
-        </c:scaling>
-        <c:delete val="0"/>
-        <c:axPos val="b"/>
-        <c:majorGridlines>
-          <c:spPr>
-            <a:ln w="6350" cap="flat">
-              <a:solidFill>
-                <a:srgbClr val="E1E5EB"/>
-              </a:solidFill>
-              <a:prstDash val="solid"/>
-              <a:round/>
-            </a:ln>
-          </c:spPr>
-        </c:majorGridlines>
-        <c:numFmt formatCode="General" sourceLinked="0"/>
-        <c:majorTickMark val="out"/>
-        <c:minorTickMark val="none"/>
-        <c:tickLblPos val="low"/>
-        <c:spPr>
-          <a:ln w="12700" cap="flat">
-            <a:solidFill>
-              <a:srgbClr val="888888"/>
-            </a:solidFill>
-            <a:prstDash val="solid"/>
-            <a:round/>
-          </a:ln>
-        </c:spPr>
-        <c:txPr>
-          <a:bodyPr/>
-          <a:lstStyle/>
-          <a:p>
-            <a:pPr>
-              <a:defRPr sz="1100" b="0" i="0" u="none" strike="noStrike">
-                <a:solidFill>
-                  <a:srgbClr val="000000"/>
-                </a:solidFill>
-                <a:latin typeface="Arial"/>
-              </a:defRPr>
-            </a:pPr>
-            <a:endParaRPr lang="en-US"/>
-          </a:p>
-        </c:txPr>
-        <c:crossAx val="2094734554"/>
-        <c:crosses val="autoZero"/>
-        <c:crossBetween val="between"/>
-      </c:valAx>
-      <c:spPr>
-        <a:noFill/>
-        <a:ln>
-          <a:noFill/>
-        </a:ln>
-        <a:effectLst/>
-      </c:spPr>
-    </c:plotArea>
-    <c:plotVisOnly val="1"/>
-    <c:dispBlanksAs val="span"/>
-  </c:chart>
-  <c:spPr>
-    <a:noFill/>
-    <a:ln>
-      <a:noFill/>
-    </a:ln>
-    <a:effectLst/>
-  </c:spPr>
-  <c:externalData r:id="rId1">
-    <c:autoUpdate val="0"/>
-  </c:externalData>
-</c:chartSpace>
 </file>
 
 <file path=ppt/notesMasters/notesMaster1.xml><?xml version="1.0" encoding="utf-8"?>
@@ -2496,7 +2201,7 @@
           <a:bodyPr wrap="square" lIns="0" tIns="0" rIns="0" bIns="0" rtlCol="0" anchor="t"/>
           <a:lstStyle/>
           <a:p>
-            <a:pPr marL="342900" indent="-342900">
+            <a:pPr marL="190500" indent="-190500">
               <a:spcAft>
                 <a:spcPts val="400"/>
               </a:spcAft>
@@ -2517,7 +2222,7 @@
             <a:endParaRPr lang="en-US" sz="1300" dirty="0"/>
           </a:p>
           <a:p>
-            <a:pPr marL="342900" indent="-342900">
+            <a:pPr marL="190500" indent="-190500">
               <a:spcAft>
                 <a:spcPts val="400"/>
               </a:spcAft>
@@ -2538,7 +2243,7 @@
             <a:endParaRPr lang="en-US" sz="1300" dirty="0"/>
           </a:p>
           <a:p>
-            <a:pPr marL="342900" indent="-342900">
+            <a:pPr marL="190500" indent="-190500">
               <a:spcAft>
                 <a:spcPts val="400"/>
               </a:spcAft>
@@ -2555,6 +2260,27 @@
                 <a:cs typeface="Calibri" pitchFamily="34" charset="-120"/>
               </a:rPr>
               <a:t>小確幸互動不高,卻最容易引發羨慕與分享</a:t>
+            </a:r>
+            <a:endParaRPr lang="en-US" sz="1300" dirty="0"/>
+          </a:p>
+          <a:p>
+            <a:pPr marL="190500" indent="-190500">
+              <a:spcAft>
+                <a:spcPts val="400"/>
+              </a:spcAft>
+              <a:buSzPct val="100000"/>
+              <a:buChar char="•"/>
+            </a:pPr>
+            <a:r>
+              <a:rPr lang="en-US" sz="1300" dirty="0">
+                <a:solidFill>
+                  <a:srgbClr val="222222"/>
+                </a:solidFill>
+                <a:latin typeface="Calibri" pitchFamily="34" charset="0"/>
+                <a:ea typeface="Calibri" pitchFamily="34" charset="-122"/>
+                <a:cs typeface="Calibri" pitchFamily="34" charset="-120"/>
+              </a:rPr>
+              <a:t>與 1111 調查一致:薪資居首(63.7%),不常態加班(45.1%)次之</a:t>
             </a:r>
             <a:endParaRPr lang="en-US" sz="1300" dirty="0"/>
           </a:p>
@@ -2647,7 +2373,7 @@
           <a:bodyPr wrap="square" lIns="0" tIns="0" rIns="0" bIns="0" rtlCol="0" anchor="t"/>
           <a:lstStyle/>
           <a:p>
-            <a:pPr marL="342900" indent="-342900">
+            <a:pPr marL="190500" indent="-190500">
               <a:spcAft>
                 <a:spcPts val="400"/>
               </a:spcAft>
@@ -2668,7 +2394,7 @@
             <a:endParaRPr lang="en-US" sz="1300" dirty="0"/>
           </a:p>
           <a:p>
-            <a:pPr marL="342900" indent="-342900">
+            <a:pPr marL="190500" indent="-190500">
               <a:spcAft>
                 <a:spcPts val="400"/>
               </a:spcAft>
@@ -2689,7 +2415,7 @@
             <a:endParaRPr lang="en-US" sz="1300" dirty="0"/>
           </a:p>
           <a:p>
-            <a:pPr marL="342900" indent="-342900">
+            <a:pPr marL="190500" indent="-190500">
               <a:spcAft>
                 <a:spcPts val="400"/>
               </a:spcAft>
@@ -3156,7 +2882,7 @@
           <a:bodyPr wrap="square" lIns="0" tIns="0" rIns="0" bIns="0" rtlCol="0" anchor="t"/>
           <a:lstStyle/>
           <a:p>
-            <a:pPr marL="342900" indent="-342900">
+            <a:pPr marL="190500" indent="-190500">
               <a:spcAft>
                 <a:spcPts val="400"/>
               </a:spcAft>
@@ -3177,7 +2903,7 @@
             <a:endParaRPr lang="en-US" sz="1400" dirty="0"/>
           </a:p>
           <a:p>
-            <a:pPr marL="342900" indent="-342900">
+            <a:pPr marL="190500" indent="-190500">
               <a:spcAft>
                 <a:spcPts val="400"/>
               </a:spcAft>
@@ -3198,7 +2924,7 @@
             <a:endParaRPr lang="en-US" sz="1400" dirty="0"/>
           </a:p>
           <a:p>
-            <a:pPr marL="342900" indent="-342900">
+            <a:pPr marL="190500" indent="-190500">
               <a:spcAft>
                 <a:spcPts val="400"/>
               </a:spcAft>
@@ -3307,7 +3033,7 @@
           <a:bodyPr wrap="square" lIns="0" tIns="0" rIns="0" bIns="0" rtlCol="0" anchor="t"/>
           <a:lstStyle/>
           <a:p>
-            <a:pPr marL="342900" indent="-342900">
+            <a:pPr marL="190500" indent="-190500">
               <a:spcAft>
                 <a:spcPts val="400"/>
               </a:spcAft>
@@ -3328,7 +3054,7 @@
             <a:endParaRPr lang="en-US" sz="1400" dirty="0"/>
           </a:p>
           <a:p>
-            <a:pPr marL="342900" indent="-342900">
+            <a:pPr marL="190500" indent="-190500">
               <a:spcAft>
                 <a:spcPts val="400"/>
               </a:spcAft>
@@ -3349,7 +3075,7 @@
             <a:endParaRPr lang="en-US" sz="1400" dirty="0"/>
           </a:p>
           <a:p>
-            <a:pPr marL="342900" indent="-342900">
+            <a:pPr marL="190500" indent="-190500">
               <a:spcAft>
                 <a:spcPts val="400"/>
               </a:spcAft>
@@ -4519,7 +4245,7 @@
           <a:bodyPr wrap="square" lIns="0" tIns="0" rIns="0" bIns="0" rtlCol="0" anchor="t"/>
           <a:lstStyle/>
           <a:p>
-            <a:pPr marL="342900" indent="-342900">
+            <a:pPr marL="190500" indent="-190500">
               <a:spcAft>
                 <a:spcPts val="400"/>
               </a:spcAft>
@@ -4540,7 +4266,7 @@
             <a:endParaRPr lang="en-US" sz="1400" dirty="0"/>
           </a:p>
           <a:p>
-            <a:pPr marL="342900" indent="-342900">
+            <a:pPr marL="190500" indent="-190500">
               <a:spcAft>
                 <a:spcPts val="400"/>
               </a:spcAft>
@@ -4649,7 +4375,7 @@
           <a:bodyPr wrap="square" lIns="0" tIns="0" rIns="0" bIns="0" rtlCol="0" anchor="t"/>
           <a:lstStyle/>
           <a:p>
-            <a:pPr marL="342900" indent="-342900">
+            <a:pPr marL="190500" indent="-190500">
               <a:spcAft>
                 <a:spcPts val="400"/>
               </a:spcAft>
@@ -4670,7 +4396,7 @@
             <a:endParaRPr lang="en-US" sz="1400" dirty="0"/>
           </a:p>
           <a:p>
-            <a:pPr marL="342900" indent="-342900">
+            <a:pPr marL="190500" indent="-190500">
               <a:spcAft>
                 <a:spcPts val="400"/>
               </a:spcAft>
@@ -4691,7 +4417,7 @@
             <a:endParaRPr lang="en-US" sz="1400" dirty="0"/>
           </a:p>
           <a:p>
-            <a:pPr marL="342900" indent="-342900">
+            <a:pPr marL="190500" indent="-190500">
               <a:spcAft>
                 <a:spcPts val="400"/>
               </a:spcAft>
@@ -5881,7 +5607,7 @@
           <a:bodyPr wrap="square" lIns="0" tIns="0" rIns="0" bIns="0" rtlCol="0" anchor="t"/>
           <a:lstStyle/>
           <a:p>
-            <a:pPr marL="342900" indent="-342900">
+            <a:pPr marL="190500" indent="-190500">
               <a:spcAft>
                 <a:spcPts val="400"/>
               </a:spcAft>
@@ -5902,7 +5628,7 @@
             <a:endParaRPr lang="en-US" sz="1400" dirty="0"/>
           </a:p>
           <a:p>
-            <a:pPr marL="342900" indent="-342900">
+            <a:pPr marL="190500" indent="-190500">
               <a:spcAft>
                 <a:spcPts val="400"/>
               </a:spcAft>
@@ -5923,7 +5649,7 @@
             <a:endParaRPr lang="en-US" sz="1400" dirty="0"/>
           </a:p>
           <a:p>
-            <a:pPr marL="342900" indent="-342900">
+            <a:pPr marL="190500" indent="-190500">
               <a:spcAft>
                 <a:spcPts val="400"/>
               </a:spcAft>
@@ -6032,7 +5758,7 @@
           <a:bodyPr wrap="square" lIns="0" tIns="0" rIns="0" bIns="0" rtlCol="0" anchor="t"/>
           <a:lstStyle/>
           <a:p>
-            <a:pPr marL="342900" indent="-342900">
+            <a:pPr marL="190500" indent="-190500">
               <a:spcAft>
                 <a:spcPts val="400"/>
               </a:spcAft>
@@ -6053,7 +5779,7 @@
             <a:endParaRPr lang="en-US" sz="1400" dirty="0"/>
           </a:p>
           <a:p>
-            <a:pPr marL="342900" indent="-342900">
+            <a:pPr marL="190500" indent="-190500">
               <a:spcAft>
                 <a:spcPts val="400"/>
               </a:spcAft>
@@ -6074,7 +5800,7 @@
             <a:endParaRPr lang="en-US" sz="1400" dirty="0"/>
           </a:p>
           <a:p>
-            <a:pPr marL="342900" indent="-342900">
+            <a:pPr marL="190500" indent="-190500">
               <a:spcAft>
                 <a:spcPts val="400"/>
               </a:spcAft>
@@ -6281,8 +6007,8 @@
         </p:blipFill>
         <p:spPr>
           <a:xfrm>
-            <a:off x="457200" y="1554480"/>
-            <a:ext cx="1645920" cy="2990088"/>
+            <a:off x="457200" y="1600200"/>
+            <a:ext cx="1645920" cy="2185416"/>
           </a:xfrm>
           <a:prstGeom prst="rect">
             <a:avLst/>
@@ -6383,7 +6109,7 @@
           <a:bodyPr wrap="square" lIns="0" tIns="0" rIns="0" bIns="0" rtlCol="0" anchor="t"/>
           <a:lstStyle/>
           <a:p>
-            <a:pPr marL="342900" indent="-342900">
+            <a:pPr marL="190500" indent="-190500">
               <a:spcAft>
                 <a:spcPts val="500"/>
               </a:spcAft>
@@ -6404,7 +6130,7 @@
             <a:endParaRPr lang="en-US" sz="1300" dirty="0"/>
           </a:p>
           <a:p>
-            <a:pPr marL="342900" indent="-342900">
+            <a:pPr marL="190500" indent="-190500">
               <a:spcAft>
                 <a:spcPts val="500"/>
               </a:spcAft>
@@ -6425,7 +6151,7 @@
             <a:endParaRPr lang="en-US" sz="1300" dirty="0"/>
           </a:p>
           <a:p>
-            <a:pPr marL="342900" indent="-342900">
+            <a:pPr marL="190500" indent="-190500">
               <a:spcAft>
                 <a:spcPts val="500"/>
               </a:spcAft>
@@ -6502,8 +6228,8 @@
         </p:blipFill>
         <p:spPr>
           <a:xfrm>
-            <a:off x="4663440" y="1554480"/>
-            <a:ext cx="1645920" cy="2990088"/>
+            <a:off x="4663440" y="1600200"/>
+            <a:ext cx="1645920" cy="2359152"/>
           </a:xfrm>
           <a:prstGeom prst="rect">
             <a:avLst/>
@@ -6604,7 +6330,7 @@
           <a:bodyPr wrap="square" lIns="0" tIns="0" rIns="0" bIns="0" rtlCol="0" anchor="t"/>
           <a:lstStyle/>
           <a:p>
-            <a:pPr marL="342900" indent="-342900">
+            <a:pPr marL="190500" indent="-190500">
               <a:spcAft>
                 <a:spcPts val="500"/>
               </a:spcAft>
@@ -6625,7 +6351,7 @@
             <a:endParaRPr lang="en-US" sz="1300" dirty="0"/>
           </a:p>
           <a:p>
-            <a:pPr marL="342900" indent="-342900">
+            <a:pPr marL="190500" indent="-190500">
               <a:spcAft>
                 <a:spcPts val="500"/>
               </a:spcAft>
@@ -6777,32 +6503,16 @@
           </a:p>
         </p:txBody>
       </p:sp>
-      <p:graphicFrame>
-        <p:nvGraphicFramePr>
-          <p:cNvPr id="5" name="Chart 0" descr=""/>
-          <p:cNvGraphicFramePr/>
-          <p:nvPr/>
-        </p:nvGraphicFramePr>
-        <p:xfrm>
-          <a:off x="457200" y="1005840"/>
-          <a:ext cx="5120640" cy="3383280"/>
-        </p:xfrm>
-        <a:graphic xmlns:a="http://schemas.openxmlformats.org/drawingml/2006/main">
-          <a:graphicData uri="http://schemas.openxmlformats.org/drawingml/2006/chart">
-            <c:chart xmlns:c="http://schemas.openxmlformats.org/drawingml/2006/chart" r:id="rId1"/>
-          </a:graphicData>
-        </a:graphic>
-      </p:graphicFrame>
-      <p:sp>
-        <p:nvSpPr>
-          <p:cNvPr id="6" name="Text 3"/>
+      <p:sp>
+        <p:nvSpPr>
+          <p:cNvPr id="5" name="Text 3"/>
           <p:cNvSpPr txBox="1"/>
           <p:nvPr/>
         </p:nvSpPr>
         <p:spPr>
           <a:xfrm>
-            <a:off x="457200" y="4389120"/>
-            <a:ext cx="5120640" cy="594360"/>
+            <a:off x="457200" y="1005840"/>
+            <a:ext cx="5120640" cy="365760"/>
           </a:xfrm>
           <a:prstGeom prst="rect">
             <a:avLst/>
@@ -6818,34 +6528,755 @@
               <a:buNone/>
             </a:pPr>
             <a:r>
-              <a:rPr lang="en-US" sz="1100" dirty="0">
-                <a:solidFill>
-                  <a:srgbClr val="5B6575"/>
-                </a:solidFill>
-                <a:latin typeface="Calibri" pitchFamily="34" charset="0"/>
-                <a:ea typeface="Calibri" pitchFamily="34" charset="-122"/>
-                <a:cs typeface="Calibri" pitchFamily="34" charset="-120"/>
-              </a:rPr>
-              <a:t>統計方式:案例 1 共 35 則留言,可見 20 則,其中 17 則談福利;一則可提及多項。案例 2 可見 11 則,其中 4 則談零食/賀卡。</a:t>
-            </a:r>
-            <a:endParaRPr lang="en-US" sz="1100" dirty="0"/>
-          </a:p>
-        </p:txBody>
-      </p:sp>
-      <p:sp>
-        <p:nvSpPr>
-          <p:cNvPr id="7" name="Shape 4"/>
+              <a:rPr lang="en-US" sz="1400" b="1" dirty="0">
+                <a:solidFill>
+                  <a:srgbClr val="1B2A41"/>
+                </a:solidFill>
+                <a:latin typeface="Calibri" pitchFamily="34" charset="0"/>
+                <a:ea typeface="Calibri" pitchFamily="34" charset="-122"/>
+                <a:cs typeface="Calibri" pitchFamily="34" charset="-120"/>
+              </a:rPr>
+              <a:t>Dcard 案例 1 留言提及的福利(則,n=17)</a:t>
+            </a:r>
+            <a:endParaRPr lang="en-US" sz="1400" dirty="0"/>
+          </a:p>
+        </p:txBody>
+      </p:sp>
+      <p:sp>
+        <p:nvSpPr>
+          <p:cNvPr id="6" name="Text 4"/>
+          <p:cNvSpPr txBox="1"/>
+          <p:nvPr/>
+        </p:nvSpPr>
+        <p:spPr>
+          <a:xfrm>
+            <a:off x="457200" y="1463040"/>
+            <a:ext cx="1600200" cy="329184"/>
+          </a:xfrm>
+          <a:prstGeom prst="rect">
+            <a:avLst/>
+          </a:prstGeom>
+          <a:noFill/>
+          <a:ln/>
+        </p:spPr>
+        <p:txBody>
+          <a:bodyPr wrap="square" lIns="0" tIns="0" rIns="0" bIns="0" rtlCol="0" anchor="ctr"/>
+          <a:lstStyle/>
+          <a:p>
+            <a:pPr indent="0" marL="0">
+              <a:buNone/>
+            </a:pPr>
+            <a:r>
+              <a:rPr lang="en-US" sz="1300" dirty="0">
+                <a:solidFill>
+                  <a:srgbClr val="222222"/>
+                </a:solidFill>
+                <a:latin typeface="Calibri" pitchFamily="34" charset="0"/>
+                <a:ea typeface="Calibri" pitchFamily="34" charset="-122"/>
+                <a:cs typeface="Calibri" pitchFamily="34" charset="-120"/>
+              </a:rPr>
+              <a:t>薪資/獎金/年終</a:t>
+            </a:r>
+            <a:endParaRPr lang="en-US" sz="1300" dirty="0"/>
+          </a:p>
+        </p:txBody>
+      </p:sp>
+      <p:sp>
+        <p:nvSpPr>
+          <p:cNvPr id="7" name="Shape 5"/>
           <p:cNvSpPr/>
           <p:nvPr/>
         </p:nvSpPr>
         <p:spPr>
           <a:xfrm>
+            <a:off x="2103120" y="1499616"/>
+            <a:ext cx="2816352" cy="256032"/>
+          </a:xfrm>
+          <a:prstGeom prst="rect">
+            <a:avLst/>
+          </a:prstGeom>
+          <a:solidFill>
+            <a:srgbClr val="C8102E"/>
+          </a:solidFill>
+          <a:ln w="12700">
+            <a:solidFill>
+              <a:srgbClr val="C8102E"/>
+            </a:solidFill>
+            <a:prstDash val="solid"/>
+          </a:ln>
+        </p:spPr>
+      </p:sp>
+      <p:sp>
+        <p:nvSpPr>
+          <p:cNvPr id="8" name="Text 6"/>
+          <p:cNvSpPr txBox="1"/>
+          <p:nvPr/>
+        </p:nvSpPr>
+        <p:spPr>
+          <a:xfrm>
+            <a:off x="4992624" y="1463040"/>
+            <a:ext cx="457200" cy="329184"/>
+          </a:xfrm>
+          <a:prstGeom prst="rect">
+            <a:avLst/>
+          </a:prstGeom>
+          <a:noFill/>
+          <a:ln/>
+        </p:spPr>
+        <p:txBody>
+          <a:bodyPr wrap="square" lIns="0" tIns="0" rIns="0" bIns="0" rtlCol="0" anchor="ctr"/>
+          <a:lstStyle/>
+          <a:p>
+            <a:pPr indent="0" marL="0">
+              <a:buNone/>
+            </a:pPr>
+            <a:r>
+              <a:rPr lang="en-US" sz="1300" b="1" dirty="0">
+                <a:solidFill>
+                  <a:srgbClr val="1B2A41"/>
+                </a:solidFill>
+                <a:latin typeface="Calibri" pitchFamily="34" charset="0"/>
+                <a:ea typeface="Calibri" pitchFamily="34" charset="-122"/>
+                <a:cs typeface="Calibri" pitchFamily="34" charset="-120"/>
+              </a:rPr>
+              <a:t>14</a:t>
+            </a:r>
+            <a:endParaRPr lang="en-US" sz="1300" dirty="0"/>
+          </a:p>
+        </p:txBody>
+      </p:sp>
+      <p:sp>
+        <p:nvSpPr>
+          <p:cNvPr id="9" name="Text 7"/>
+          <p:cNvSpPr txBox="1"/>
+          <p:nvPr/>
+        </p:nvSpPr>
+        <p:spPr>
+          <a:xfrm>
+            <a:off x="457200" y="1883664"/>
+            <a:ext cx="1600200" cy="329184"/>
+          </a:xfrm>
+          <a:prstGeom prst="rect">
+            <a:avLst/>
+          </a:prstGeom>
+          <a:noFill/>
+          <a:ln/>
+        </p:spPr>
+        <p:txBody>
+          <a:bodyPr wrap="square" lIns="0" tIns="0" rIns="0" bIns="0" rtlCol="0" anchor="ctr"/>
+          <a:lstStyle/>
+          <a:p>
+            <a:pPr indent="0" marL="0">
+              <a:buNone/>
+            </a:pPr>
+            <a:r>
+              <a:rPr lang="en-US" sz="1300" dirty="0">
+                <a:solidFill>
+                  <a:srgbClr val="222222"/>
+                </a:solidFill>
+                <a:latin typeface="Calibri" pitchFamily="34" charset="0"/>
+                <a:ea typeface="Calibri" pitchFamily="34" charset="-122"/>
+                <a:cs typeface="Calibri" pitchFamily="34" charset="-120"/>
+              </a:rPr>
+              <a:t>餐飲/零食/設備</a:t>
+            </a:r>
+            <a:endParaRPr lang="en-US" sz="1300" dirty="0"/>
+          </a:p>
+        </p:txBody>
+      </p:sp>
+      <p:sp>
+        <p:nvSpPr>
+          <p:cNvPr id="10" name="Shape 8"/>
+          <p:cNvSpPr/>
+          <p:nvPr/>
+        </p:nvSpPr>
+        <p:spPr>
+          <a:xfrm>
+            <a:off x="2103120" y="1920240"/>
+            <a:ext cx="1005840" cy="256032"/>
+          </a:xfrm>
+          <a:prstGeom prst="rect">
+            <a:avLst/>
+          </a:prstGeom>
+          <a:solidFill>
+            <a:srgbClr val="1B2A41"/>
+          </a:solidFill>
+          <a:ln w="12700">
+            <a:solidFill>
+              <a:srgbClr val="1B2A41"/>
+            </a:solidFill>
+            <a:prstDash val="solid"/>
+          </a:ln>
+        </p:spPr>
+      </p:sp>
+      <p:sp>
+        <p:nvSpPr>
+          <p:cNvPr id="11" name="Text 9"/>
+          <p:cNvSpPr txBox="1"/>
+          <p:nvPr/>
+        </p:nvSpPr>
+        <p:spPr>
+          <a:xfrm>
+            <a:off x="3182112" y="1883664"/>
+            <a:ext cx="457200" cy="329184"/>
+          </a:xfrm>
+          <a:prstGeom prst="rect">
+            <a:avLst/>
+          </a:prstGeom>
+          <a:noFill/>
+          <a:ln/>
+        </p:spPr>
+        <p:txBody>
+          <a:bodyPr wrap="square" lIns="0" tIns="0" rIns="0" bIns="0" rtlCol="0" anchor="ctr"/>
+          <a:lstStyle/>
+          <a:p>
+            <a:pPr indent="0" marL="0">
+              <a:buNone/>
+            </a:pPr>
+            <a:r>
+              <a:rPr lang="en-US" sz="1300" b="1" dirty="0">
+                <a:solidFill>
+                  <a:srgbClr val="1B2A41"/>
+                </a:solidFill>
+                <a:latin typeface="Calibri" pitchFamily="34" charset="0"/>
+                <a:ea typeface="Calibri" pitchFamily="34" charset="-122"/>
+                <a:cs typeface="Calibri" pitchFamily="34" charset="-120"/>
+              </a:rPr>
+              <a:t>5</a:t>
+            </a:r>
+            <a:endParaRPr lang="en-US" sz="1300" dirty="0"/>
+          </a:p>
+        </p:txBody>
+      </p:sp>
+      <p:sp>
+        <p:nvSpPr>
+          <p:cNvPr id="12" name="Text 10"/>
+          <p:cNvSpPr txBox="1"/>
+          <p:nvPr/>
+        </p:nvSpPr>
+        <p:spPr>
+          <a:xfrm>
+            <a:off x="457200" y="2304288"/>
+            <a:ext cx="1600200" cy="329184"/>
+          </a:xfrm>
+          <a:prstGeom prst="rect">
+            <a:avLst/>
+          </a:prstGeom>
+          <a:noFill/>
+          <a:ln/>
+        </p:spPr>
+        <p:txBody>
+          <a:bodyPr wrap="square" lIns="0" tIns="0" rIns="0" bIns="0" rtlCol="0" anchor="ctr"/>
+          <a:lstStyle/>
+          <a:p>
+            <a:pPr indent="0" marL="0">
+              <a:buNone/>
+            </a:pPr>
+            <a:r>
+              <a:rPr lang="en-US" sz="1300" dirty="0">
+                <a:solidFill>
+                  <a:srgbClr val="222222"/>
+                </a:solidFill>
+                <a:latin typeface="Calibri" pitchFamily="34" charset="0"/>
+                <a:ea typeface="Calibri" pitchFamily="34" charset="-122"/>
+                <a:cs typeface="Calibri" pitchFamily="34" charset="-120"/>
+              </a:rPr>
+              <a:t>彈性/遠端</a:t>
+            </a:r>
+            <a:endParaRPr lang="en-US" sz="1300" dirty="0"/>
+          </a:p>
+        </p:txBody>
+      </p:sp>
+      <p:sp>
+        <p:nvSpPr>
+          <p:cNvPr id="13" name="Shape 11"/>
+          <p:cNvSpPr/>
+          <p:nvPr/>
+        </p:nvSpPr>
+        <p:spPr>
+          <a:xfrm>
+            <a:off x="2103120" y="2340864"/>
+            <a:ext cx="603504" cy="256032"/>
+          </a:xfrm>
+          <a:prstGeom prst="rect">
+            <a:avLst/>
+          </a:prstGeom>
+          <a:solidFill>
+            <a:srgbClr val="1B2A41"/>
+          </a:solidFill>
+          <a:ln w="12700">
+            <a:solidFill>
+              <a:srgbClr val="1B2A41"/>
+            </a:solidFill>
+            <a:prstDash val="solid"/>
+          </a:ln>
+        </p:spPr>
+      </p:sp>
+      <p:sp>
+        <p:nvSpPr>
+          <p:cNvPr id="14" name="Text 12"/>
+          <p:cNvSpPr txBox="1"/>
+          <p:nvPr/>
+        </p:nvSpPr>
+        <p:spPr>
+          <a:xfrm>
+            <a:off x="2779776" y="2304288"/>
+            <a:ext cx="457200" cy="329184"/>
+          </a:xfrm>
+          <a:prstGeom prst="rect">
+            <a:avLst/>
+          </a:prstGeom>
+          <a:noFill/>
+          <a:ln/>
+        </p:spPr>
+        <p:txBody>
+          <a:bodyPr wrap="square" lIns="0" tIns="0" rIns="0" bIns="0" rtlCol="0" anchor="ctr"/>
+          <a:lstStyle/>
+          <a:p>
+            <a:pPr indent="0" marL="0">
+              <a:buNone/>
+            </a:pPr>
+            <a:r>
+              <a:rPr lang="en-US" sz="1300" b="1" dirty="0">
+                <a:solidFill>
+                  <a:srgbClr val="1B2A41"/>
+                </a:solidFill>
+                <a:latin typeface="Calibri" pitchFamily="34" charset="0"/>
+                <a:ea typeface="Calibri" pitchFamily="34" charset="-122"/>
+                <a:cs typeface="Calibri" pitchFamily="34" charset="-120"/>
+              </a:rPr>
+              <a:t>3</a:t>
+            </a:r>
+            <a:endParaRPr lang="en-US" sz="1300" dirty="0"/>
+          </a:p>
+        </p:txBody>
+      </p:sp>
+      <p:sp>
+        <p:nvSpPr>
+          <p:cNvPr id="15" name="Text 13"/>
+          <p:cNvSpPr txBox="1"/>
+          <p:nvPr/>
+        </p:nvSpPr>
+        <p:spPr>
+          <a:xfrm>
+            <a:off x="457200" y="2724912"/>
+            <a:ext cx="1600200" cy="329184"/>
+          </a:xfrm>
+          <a:prstGeom prst="rect">
+            <a:avLst/>
+          </a:prstGeom>
+          <a:noFill/>
+          <a:ln/>
+        </p:spPr>
+        <p:txBody>
+          <a:bodyPr wrap="square" lIns="0" tIns="0" rIns="0" bIns="0" rtlCol="0" anchor="ctr"/>
+          <a:lstStyle/>
+          <a:p>
+            <a:pPr indent="0" marL="0">
+              <a:buNone/>
+            </a:pPr>
+            <a:r>
+              <a:rPr lang="en-US" sz="1300" dirty="0">
+                <a:solidFill>
+                  <a:srgbClr val="222222"/>
+                </a:solidFill>
+                <a:latin typeface="Calibri" pitchFamily="34" charset="0"/>
+                <a:ea typeface="Calibri" pitchFamily="34" charset="-122"/>
+                <a:cs typeface="Calibri" pitchFamily="34" charset="-120"/>
+              </a:rPr>
+              <a:t>休假</a:t>
+            </a:r>
+            <a:endParaRPr lang="en-US" sz="1300" dirty="0"/>
+          </a:p>
+        </p:txBody>
+      </p:sp>
+      <p:sp>
+        <p:nvSpPr>
+          <p:cNvPr id="16" name="Shape 14"/>
+          <p:cNvSpPr/>
+          <p:nvPr/>
+        </p:nvSpPr>
+        <p:spPr>
+          <a:xfrm>
+            <a:off x="2103120" y="2761488"/>
+            <a:ext cx="603504" cy="256032"/>
+          </a:xfrm>
+          <a:prstGeom prst="rect">
+            <a:avLst/>
+          </a:prstGeom>
+          <a:solidFill>
+            <a:srgbClr val="1B2A41"/>
+          </a:solidFill>
+          <a:ln w="12700">
+            <a:solidFill>
+              <a:srgbClr val="1B2A41"/>
+            </a:solidFill>
+            <a:prstDash val="solid"/>
+          </a:ln>
+        </p:spPr>
+      </p:sp>
+      <p:sp>
+        <p:nvSpPr>
+          <p:cNvPr id="17" name="Text 15"/>
+          <p:cNvSpPr txBox="1"/>
+          <p:nvPr/>
+        </p:nvSpPr>
+        <p:spPr>
+          <a:xfrm>
+            <a:off x="2779776" y="2724912"/>
+            <a:ext cx="457200" cy="329184"/>
+          </a:xfrm>
+          <a:prstGeom prst="rect">
+            <a:avLst/>
+          </a:prstGeom>
+          <a:noFill/>
+          <a:ln/>
+        </p:spPr>
+        <p:txBody>
+          <a:bodyPr wrap="square" lIns="0" tIns="0" rIns="0" bIns="0" rtlCol="0" anchor="ctr"/>
+          <a:lstStyle/>
+          <a:p>
+            <a:pPr indent="0" marL="0">
+              <a:buNone/>
+            </a:pPr>
+            <a:r>
+              <a:rPr lang="en-US" sz="1300" b="1" dirty="0">
+                <a:solidFill>
+                  <a:srgbClr val="1B2A41"/>
+                </a:solidFill>
+                <a:latin typeface="Calibri" pitchFamily="34" charset="0"/>
+                <a:ea typeface="Calibri" pitchFamily="34" charset="-122"/>
+                <a:cs typeface="Calibri" pitchFamily="34" charset="-120"/>
+              </a:rPr>
+              <a:t>3</a:t>
+            </a:r>
+            <a:endParaRPr lang="en-US" sz="1300" dirty="0"/>
+          </a:p>
+        </p:txBody>
+      </p:sp>
+      <p:sp>
+        <p:nvSpPr>
+          <p:cNvPr id="18" name="Text 16"/>
+          <p:cNvSpPr txBox="1"/>
+          <p:nvPr/>
+        </p:nvSpPr>
+        <p:spPr>
+          <a:xfrm>
+            <a:off x="457200" y="3145536"/>
+            <a:ext cx="1600200" cy="329184"/>
+          </a:xfrm>
+          <a:prstGeom prst="rect">
+            <a:avLst/>
+          </a:prstGeom>
+          <a:noFill/>
+          <a:ln/>
+        </p:spPr>
+        <p:txBody>
+          <a:bodyPr wrap="square" lIns="0" tIns="0" rIns="0" bIns="0" rtlCol="0" anchor="ctr"/>
+          <a:lstStyle/>
+          <a:p>
+            <a:pPr indent="0" marL="0">
+              <a:buNone/>
+            </a:pPr>
+            <a:r>
+              <a:rPr lang="en-US" sz="1300" dirty="0">
+                <a:solidFill>
+                  <a:srgbClr val="222222"/>
+                </a:solidFill>
+                <a:latin typeface="Calibri" pitchFamily="34" charset="0"/>
+                <a:ea typeface="Calibri" pitchFamily="34" charset="-122"/>
+                <a:cs typeface="Calibri" pitchFamily="34" charset="-120"/>
+              </a:rPr>
+              <a:t>加班費/準時下班</a:t>
+            </a:r>
+            <a:endParaRPr lang="en-US" sz="1300" dirty="0"/>
+          </a:p>
+        </p:txBody>
+      </p:sp>
+      <p:sp>
+        <p:nvSpPr>
+          <p:cNvPr id="19" name="Shape 17"/>
+          <p:cNvSpPr/>
+          <p:nvPr/>
+        </p:nvSpPr>
+        <p:spPr>
+          <a:xfrm>
+            <a:off x="2103120" y="3182112"/>
+            <a:ext cx="603504" cy="256032"/>
+          </a:xfrm>
+          <a:prstGeom prst="rect">
+            <a:avLst/>
+          </a:prstGeom>
+          <a:solidFill>
+            <a:srgbClr val="1B2A41"/>
+          </a:solidFill>
+          <a:ln w="12700">
+            <a:solidFill>
+              <a:srgbClr val="1B2A41"/>
+            </a:solidFill>
+            <a:prstDash val="solid"/>
+          </a:ln>
+        </p:spPr>
+      </p:sp>
+      <p:sp>
+        <p:nvSpPr>
+          <p:cNvPr id="20" name="Text 18"/>
+          <p:cNvSpPr txBox="1"/>
+          <p:nvPr/>
+        </p:nvSpPr>
+        <p:spPr>
+          <a:xfrm>
+            <a:off x="2779776" y="3145536"/>
+            <a:ext cx="457200" cy="329184"/>
+          </a:xfrm>
+          <a:prstGeom prst="rect">
+            <a:avLst/>
+          </a:prstGeom>
+          <a:noFill/>
+          <a:ln/>
+        </p:spPr>
+        <p:txBody>
+          <a:bodyPr wrap="square" lIns="0" tIns="0" rIns="0" bIns="0" rtlCol="0" anchor="ctr"/>
+          <a:lstStyle/>
+          <a:p>
+            <a:pPr indent="0" marL="0">
+              <a:buNone/>
+            </a:pPr>
+            <a:r>
+              <a:rPr lang="en-US" sz="1300" b="1" dirty="0">
+                <a:solidFill>
+                  <a:srgbClr val="1B2A41"/>
+                </a:solidFill>
+                <a:latin typeface="Calibri" pitchFamily="34" charset="0"/>
+                <a:ea typeface="Calibri" pitchFamily="34" charset="-122"/>
+                <a:cs typeface="Calibri" pitchFamily="34" charset="-120"/>
+              </a:rPr>
+              <a:t>3</a:t>
+            </a:r>
+            <a:endParaRPr lang="en-US" sz="1300" dirty="0"/>
+          </a:p>
+        </p:txBody>
+      </p:sp>
+      <p:sp>
+        <p:nvSpPr>
+          <p:cNvPr id="21" name="Text 19"/>
+          <p:cNvSpPr txBox="1"/>
+          <p:nvPr/>
+        </p:nvSpPr>
+        <p:spPr>
+          <a:xfrm>
+            <a:off x="457200" y="3566160"/>
+            <a:ext cx="1600200" cy="329184"/>
+          </a:xfrm>
+          <a:prstGeom prst="rect">
+            <a:avLst/>
+          </a:prstGeom>
+          <a:noFill/>
+          <a:ln/>
+        </p:spPr>
+        <p:txBody>
+          <a:bodyPr wrap="square" lIns="0" tIns="0" rIns="0" bIns="0" rtlCol="0" anchor="ctr"/>
+          <a:lstStyle/>
+          <a:p>
+            <a:pPr indent="0" marL="0">
+              <a:buNone/>
+            </a:pPr>
+            <a:r>
+              <a:rPr lang="en-US" sz="1300" dirty="0">
+                <a:solidFill>
+                  <a:srgbClr val="222222"/>
+                </a:solidFill>
+                <a:latin typeface="Calibri" pitchFamily="34" charset="0"/>
+                <a:ea typeface="Calibri" pitchFamily="34" charset="-122"/>
+                <a:cs typeface="Calibri" pitchFamily="34" charset="-120"/>
+              </a:rPr>
+              <a:t>停車位</a:t>
+            </a:r>
+            <a:endParaRPr lang="en-US" sz="1300" dirty="0"/>
+          </a:p>
+        </p:txBody>
+      </p:sp>
+      <p:sp>
+        <p:nvSpPr>
+          <p:cNvPr id="22" name="Shape 20"/>
+          <p:cNvSpPr/>
+          <p:nvPr/>
+        </p:nvSpPr>
+        <p:spPr>
+          <a:xfrm>
+            <a:off x="2103120" y="3602736"/>
+            <a:ext cx="402336" cy="256032"/>
+          </a:xfrm>
+          <a:prstGeom prst="rect">
+            <a:avLst/>
+          </a:prstGeom>
+          <a:solidFill>
+            <a:srgbClr val="1B2A41"/>
+          </a:solidFill>
+          <a:ln w="12700">
+            <a:solidFill>
+              <a:srgbClr val="1B2A41"/>
+            </a:solidFill>
+            <a:prstDash val="solid"/>
+          </a:ln>
+        </p:spPr>
+      </p:sp>
+      <p:sp>
+        <p:nvSpPr>
+          <p:cNvPr id="23" name="Text 21"/>
+          <p:cNvSpPr txBox="1"/>
+          <p:nvPr/>
+        </p:nvSpPr>
+        <p:spPr>
+          <a:xfrm>
+            <a:off x="2578608" y="3566160"/>
+            <a:ext cx="457200" cy="329184"/>
+          </a:xfrm>
+          <a:prstGeom prst="rect">
+            <a:avLst/>
+          </a:prstGeom>
+          <a:noFill/>
+          <a:ln/>
+        </p:spPr>
+        <p:txBody>
+          <a:bodyPr wrap="square" lIns="0" tIns="0" rIns="0" bIns="0" rtlCol="0" anchor="ctr"/>
+          <a:lstStyle/>
+          <a:p>
+            <a:pPr indent="0" marL="0">
+              <a:buNone/>
+            </a:pPr>
+            <a:r>
+              <a:rPr lang="en-US" sz="1300" b="1" dirty="0">
+                <a:solidFill>
+                  <a:srgbClr val="1B2A41"/>
+                </a:solidFill>
+                <a:latin typeface="Calibri" pitchFamily="34" charset="0"/>
+                <a:ea typeface="Calibri" pitchFamily="34" charset="-122"/>
+                <a:cs typeface="Calibri" pitchFamily="34" charset="-120"/>
+              </a:rPr>
+              <a:t>2</a:t>
+            </a:r>
+            <a:endParaRPr lang="en-US" sz="1300" dirty="0"/>
+          </a:p>
+        </p:txBody>
+      </p:sp>
+      <p:sp>
+        <p:nvSpPr>
+          <p:cNvPr id="24" name="Text 22"/>
+          <p:cNvSpPr txBox="1"/>
+          <p:nvPr/>
+        </p:nvSpPr>
+        <p:spPr>
+          <a:xfrm>
+            <a:off x="457200" y="3986784"/>
+            <a:ext cx="1600200" cy="329184"/>
+          </a:xfrm>
+          <a:prstGeom prst="rect">
+            <a:avLst/>
+          </a:prstGeom>
+          <a:noFill/>
+          <a:ln/>
+        </p:spPr>
+        <p:txBody>
+          <a:bodyPr wrap="square" lIns="0" tIns="0" rIns="0" bIns="0" rtlCol="0" anchor="ctr"/>
+          <a:lstStyle/>
+          <a:p>
+            <a:pPr indent="0" marL="0">
+              <a:buNone/>
+            </a:pPr>
+            <a:r>
+              <a:rPr lang="en-US" sz="1300" dirty="0">
+                <a:solidFill>
+                  <a:srgbClr val="222222"/>
+                </a:solidFill>
+                <a:latin typeface="Calibri" pitchFamily="34" charset="0"/>
+                <a:ea typeface="Calibri" pitchFamily="34" charset="-122"/>
+                <a:cs typeface="Calibri" pitchFamily="34" charset="-120"/>
+              </a:rPr>
+              <a:t>體檢</a:t>
+            </a:r>
+            <a:endParaRPr lang="en-US" sz="1300" dirty="0"/>
+          </a:p>
+        </p:txBody>
+      </p:sp>
+      <p:sp>
+        <p:nvSpPr>
+          <p:cNvPr id="25" name="Shape 23"/>
+          <p:cNvSpPr/>
+          <p:nvPr/>
+        </p:nvSpPr>
+        <p:spPr>
+          <a:xfrm>
+            <a:off x="2103120" y="4023360"/>
+            <a:ext cx="201168" cy="256032"/>
+          </a:xfrm>
+          <a:prstGeom prst="rect">
+            <a:avLst/>
+          </a:prstGeom>
+          <a:solidFill>
+            <a:srgbClr val="1B2A41"/>
+          </a:solidFill>
+          <a:ln w="12700">
+            <a:solidFill>
+              <a:srgbClr val="1B2A41"/>
+            </a:solidFill>
+            <a:prstDash val="solid"/>
+          </a:ln>
+        </p:spPr>
+      </p:sp>
+      <p:sp>
+        <p:nvSpPr>
+          <p:cNvPr id="26" name="Text 24"/>
+          <p:cNvSpPr txBox="1"/>
+          <p:nvPr/>
+        </p:nvSpPr>
+        <p:spPr>
+          <a:xfrm>
+            <a:off x="2377440" y="3986784"/>
+            <a:ext cx="457200" cy="329184"/>
+          </a:xfrm>
+          <a:prstGeom prst="rect">
+            <a:avLst/>
+          </a:prstGeom>
+          <a:noFill/>
+          <a:ln/>
+        </p:spPr>
+        <p:txBody>
+          <a:bodyPr wrap="square" lIns="0" tIns="0" rIns="0" bIns="0" rtlCol="0" anchor="ctr"/>
+          <a:lstStyle/>
+          <a:p>
+            <a:pPr indent="0" marL="0">
+              <a:buNone/>
+            </a:pPr>
+            <a:r>
+              <a:rPr lang="en-US" sz="1300" b="1" dirty="0">
+                <a:solidFill>
+                  <a:srgbClr val="1B2A41"/>
+                </a:solidFill>
+                <a:latin typeface="Calibri" pitchFamily="34" charset="0"/>
+                <a:ea typeface="Calibri" pitchFamily="34" charset="-122"/>
+                <a:cs typeface="Calibri" pitchFamily="34" charset="-120"/>
+              </a:rPr>
+              <a:t>1</a:t>
+            </a:r>
+            <a:endParaRPr lang="en-US" sz="1300" dirty="0"/>
+          </a:p>
+        </p:txBody>
+      </p:sp>
+      <p:sp>
+        <p:nvSpPr>
+          <p:cNvPr id="27" name="Shape 25"/>
+          <p:cNvSpPr/>
+          <p:nvPr/>
+        </p:nvSpPr>
+        <p:spPr>
+          <a:xfrm>
             <a:off x="5760720" y="1005840"/>
-            <a:ext cx="2926080" cy="1737360"/>
+            <a:ext cx="2926080" cy="3200400"/>
           </a:xfrm>
           <a:prstGeom prst="roundRect">
             <a:avLst>
-              <a:gd name="adj" fmla="val 4211"/>
+              <a:gd name="adj" fmla="val 2500"/>
             </a:avLst>
           </a:prstGeom>
           <a:solidFill>
@@ -6861,7 +7292,7 @@
       </p:sp>
       <p:sp>
         <p:nvSpPr>
-          <p:cNvPr id="8" name="Text 5"/>
+          <p:cNvPr id="28" name="Text 26"/>
           <p:cNvSpPr txBox="1"/>
           <p:nvPr/>
         </p:nvSpPr>
@@ -6892,7 +7323,7 @@
                 <a:ea typeface="Calibri" pitchFamily="34" charset="-122"/>
                 <a:cs typeface="Calibri" pitchFamily="34" charset="-120"/>
               </a:rPr>
-              <a:t>兩篇貼文互動合計</a:t>
+              <a:t>外部對照:1111 人力銀行</a:t>
             </a:r>
             <a:endParaRPr lang="en-US" sz="1600" dirty="0"/>
           </a:p>
@@ -6900,14 +7331,14 @@
       </p:sp>
       <p:sp>
         <p:nvSpPr>
-          <p:cNvPr id="9" name="Text 6"/>
+          <p:cNvPr id="29" name="Text 27"/>
           <p:cNvSpPr txBox="1"/>
           <p:nvPr/>
         </p:nvSpPr>
         <p:spPr>
           <a:xfrm>
             <a:off x="5943600" y="1536192"/>
-            <a:ext cx="2560320" cy="1051560"/>
+            <a:ext cx="2560320" cy="2514600"/>
           </a:xfrm>
           <a:prstGeom prst="rect">
             <a:avLst/>
@@ -6926,7 +7357,7 @@
               <a:buNone/>
             </a:pPr>
             <a:r>
-              <a:rPr lang="en-US" sz="1400" dirty="0">
+              <a:rPr lang="en-US" sz="1300" b="1" dirty="0">
                 <a:solidFill>
                   <a:srgbClr val="222222"/>
                 </a:solidFill>
@@ -6934,19 +7365,20 @@
                 <a:ea typeface="Calibri" pitchFamily="34" charset="-122"/>
                 <a:cs typeface="Calibri" pitchFamily="34" charset="-120"/>
               </a:rPr>
-              <a:t>愛心 224 ・ 留言 50</a:t>
-            </a:r>
-            <a:endParaRPr lang="en-US" sz="1400" dirty="0"/>
-          </a:p>
-          <a:p>
-            <a:pPr indent="0" marL="0">
+              <a:t>2025 新鮮人求職意向調查</a:t>
+            </a:r>
+            <a:endParaRPr lang="en-US" sz="1300" dirty="0"/>
+          </a:p>
+          <a:p>
+            <a:pPr marL="190500" indent="-190500">
               <a:spcAft>
                 <a:spcPts val="400"/>
               </a:spcAft>
-              <a:buNone/>
-            </a:pPr>
-            <a:r>
-              <a:rPr lang="en-US" sz="1400" dirty="0">
+              <a:buSzPct val="100000"/>
+              <a:buChar char="•"/>
+            </a:pPr>
+            <a:r>
+              <a:rPr lang="en-US" sz="1300" dirty="0">
                 <a:solidFill>
                   <a:srgbClr val="222222"/>
                 </a:solidFill>
@@ -6954,117 +7386,171 @@
                 <a:ea typeface="Calibri" pitchFamily="34" charset="-122"/>
                 <a:cs typeface="Calibri" pitchFamily="34" charset="-120"/>
               </a:rPr>
-              <a:t>收藏 842 ・ 分享 52</a:t>
-            </a:r>
-            <a:endParaRPr lang="en-US" sz="1400" dirty="0"/>
-          </a:p>
-        </p:txBody>
-      </p:sp>
-      <p:sp>
-        <p:nvSpPr>
-          <p:cNvPr id="10" name="Shape 7"/>
-          <p:cNvSpPr/>
-          <p:nvPr/>
-        </p:nvSpPr>
-        <p:spPr>
-          <a:xfrm>
-            <a:off x="5760720" y="2880360"/>
-            <a:ext cx="2926080" cy="1920240"/>
-          </a:xfrm>
-          <a:prstGeom prst="roundRect">
-            <a:avLst>
-              <a:gd name="adj" fmla="val 3810"/>
-            </a:avLst>
-          </a:prstGeom>
-          <a:solidFill>
-            <a:srgbClr val="F3F5F8"/>
-          </a:solidFill>
-          <a:ln w="12700">
-            <a:solidFill>
-              <a:srgbClr val="F3F5F8"/>
-            </a:solidFill>
-            <a:prstDash val="solid"/>
-          </a:ln>
-        </p:spPr>
-      </p:sp>
-      <p:sp>
-        <p:nvSpPr>
-          <p:cNvPr id="11" name="Text 8"/>
-          <p:cNvSpPr txBox="1"/>
-          <p:nvPr/>
-        </p:nvSpPr>
-        <p:spPr>
-          <a:xfrm>
-            <a:off x="5943600" y="2990088"/>
-            <a:ext cx="2560320" cy="365760"/>
-          </a:xfrm>
-          <a:prstGeom prst="rect">
-            <a:avLst/>
-          </a:prstGeom>
-          <a:noFill/>
-          <a:ln/>
-        </p:spPr>
-        <p:txBody>
-          <a:bodyPr wrap="square" lIns="0" tIns="0" rIns="0" bIns="0" rtlCol="0" anchor="ctr"/>
-          <a:lstStyle/>
-          <a:p>
-            <a:pPr indent="0" marL="0">
-              <a:buNone/>
-            </a:pPr>
-            <a:r>
-              <a:rPr lang="en-US" sz="1600" b="1" dirty="0">
-                <a:solidFill>
-                  <a:srgbClr val="1B2A41"/>
-                </a:solidFill>
-                <a:latin typeface="Calibri" pitchFamily="34" charset="0"/>
-                <a:ea typeface="Calibri" pitchFamily="34" charset="-122"/>
-                <a:cs typeface="Calibri" pitchFamily="34" charset="-120"/>
-              </a:rPr>
-              <a:t>資料侷限</a:t>
-            </a:r>
-            <a:endParaRPr lang="en-US" sz="1600" dirty="0"/>
-          </a:p>
-        </p:txBody>
-      </p:sp>
-      <p:sp>
-        <p:nvSpPr>
-          <p:cNvPr id="12" name="Text 9"/>
-          <p:cNvSpPr txBox="1"/>
-          <p:nvPr/>
-        </p:nvSpPr>
-        <p:spPr>
-          <a:xfrm>
-            <a:off x="5943600" y="3410712"/>
-            <a:ext cx="2560320" cy="1234440"/>
-          </a:xfrm>
-          <a:prstGeom prst="rect">
-            <a:avLst/>
-          </a:prstGeom>
-          <a:noFill/>
-          <a:ln/>
-        </p:spPr>
-        <p:txBody>
-          <a:bodyPr wrap="square" lIns="0" tIns="0" rIns="0" bIns="0" rtlCol="0" anchor="t"/>
-          <a:lstStyle/>
-          <a:p>
-            <a:pPr indent="0" marL="0">
+              <a:t>薪資符合行情 63.7%</a:t>
+            </a:r>
+            <a:endParaRPr lang="en-US" sz="1300" dirty="0"/>
+          </a:p>
+          <a:p>
+            <a:pPr marL="190500" indent="-190500">
               <a:spcAft>
                 <a:spcPts val="400"/>
               </a:spcAft>
+              <a:buSzPct val="100000"/>
+              <a:buChar char="•"/>
+            </a:pPr>
+            <a:r>
+              <a:rPr lang="en-US" sz="1300" dirty="0">
+                <a:solidFill>
+                  <a:srgbClr val="222222"/>
+                </a:solidFill>
+                <a:latin typeface="Calibri" pitchFamily="34" charset="0"/>
+                <a:ea typeface="Calibri" pitchFamily="34" charset="-122"/>
+                <a:cs typeface="Calibri" pitchFamily="34" charset="-120"/>
+              </a:rPr>
+              <a:t>不用常態加班 45.1%</a:t>
+            </a:r>
+            <a:endParaRPr lang="en-US" sz="1300" dirty="0"/>
+          </a:p>
+          <a:p>
+            <a:pPr marL="190500" indent="-190500">
+              <a:spcAft>
+                <a:spcPts val="400"/>
+              </a:spcAft>
+              <a:buSzPct val="100000"/>
+              <a:buChar char="•"/>
+            </a:pPr>
+            <a:r>
+              <a:rPr lang="en-US" sz="1300" dirty="0">
+                <a:solidFill>
+                  <a:srgbClr val="222222"/>
+                </a:solidFill>
+                <a:latin typeface="Calibri" pitchFamily="34" charset="0"/>
+                <a:ea typeface="Calibri" pitchFamily="34" charset="-122"/>
+                <a:cs typeface="Calibri" pitchFamily="34" charset="-120"/>
+              </a:rPr>
+              <a:t>公司福利好 34.6%</a:t>
+            </a:r>
+            <a:endParaRPr lang="en-US" sz="1300" dirty="0"/>
+          </a:p>
+          <a:p>
+            <a:pPr marL="190500" indent="-190500">
+              <a:spcAft>
+                <a:spcPts val="400"/>
+              </a:spcAft>
+              <a:buSzPct val="100000"/>
+              <a:buChar char="•"/>
+            </a:pPr>
+            <a:r>
+              <a:rPr lang="en-US" sz="1300" dirty="0">
+                <a:solidFill>
+                  <a:srgbClr val="222222"/>
+                </a:solidFill>
+                <a:latin typeface="Calibri" pitchFamily="34" charset="0"/>
+                <a:ea typeface="Calibri" pitchFamily="34" charset="-122"/>
+                <a:cs typeface="Calibri" pitchFamily="34" charset="-120"/>
+              </a:rPr>
+              <a:t>交通便利 32.2%</a:t>
+            </a:r>
+            <a:endParaRPr lang="en-US" sz="1300" dirty="0"/>
+          </a:p>
+          <a:p>
+            <a:pPr marL="190500" indent="-190500">
+              <a:spcAft>
+                <a:spcPts val="400"/>
+              </a:spcAft>
+              <a:buSzPct val="100000"/>
+              <a:buChar char="•"/>
+            </a:pPr>
+            <a:r>
+              <a:rPr lang="en-US" sz="1300" dirty="0">
+                <a:solidFill>
+                  <a:srgbClr val="222222"/>
+                </a:solidFill>
+                <a:latin typeface="Calibri" pitchFamily="34" charset="0"/>
+                <a:ea typeface="Calibri" pitchFamily="34" charset="-122"/>
+                <a:cs typeface="Calibri" pitchFamily="34" charset="-120"/>
+              </a:rPr>
+              <a:t>固定週休二日 30.6%</a:t>
+            </a:r>
+            <a:endParaRPr lang="en-US" sz="1300" dirty="0"/>
+          </a:p>
+        </p:txBody>
+      </p:sp>
+      <p:sp>
+        <p:nvSpPr>
+          <p:cNvPr id="30" name="Text 28"/>
+          <p:cNvSpPr txBox="1"/>
+          <p:nvPr/>
+        </p:nvSpPr>
+        <p:spPr>
+          <a:xfrm>
+            <a:off x="457200" y="4389120"/>
+            <a:ext cx="5120640" cy="685800"/>
+          </a:xfrm>
+          <a:prstGeom prst="rect">
+            <a:avLst/>
+          </a:prstGeom>
+          <a:noFill/>
+          <a:ln/>
+        </p:spPr>
+        <p:txBody>
+          <a:bodyPr wrap="square" lIns="0" tIns="0" rIns="0" bIns="0" rtlCol="0" anchor="ctr"/>
+          <a:lstStyle/>
+          <a:p>
+            <a:pPr indent="0" marL="0">
               <a:buNone/>
             </a:pPr>
             <a:r>
-              <a:rPr lang="en-US" sz="1400" dirty="0">
-                <a:solidFill>
-                  <a:srgbClr val="222222"/>
-                </a:solidFill>
-                <a:latin typeface="Calibri" pitchFamily="34" charset="0"/>
-                <a:ea typeface="Calibri" pitchFamily="34" charset="-122"/>
-                <a:cs typeface="Calibri" pitchFamily="34" charset="-120"/>
-              </a:rPr>
-              <a:t>僅 Dcard 兩篇貼文的可見留言,屬質性觀察,不代表全體畢業生</a:t>
-            </a:r>
-            <a:endParaRPr lang="en-US" sz="1400" dirty="0"/>
+              <a:rPr lang="en-US" sz="1100" dirty="0">
+                <a:solidFill>
+                  <a:srgbClr val="5B6575"/>
+                </a:solidFill>
+                <a:latin typeface="Calibri" pitchFamily="34" charset="0"/>
+                <a:ea typeface="Calibri" pitchFamily="34" charset="-122"/>
+                <a:cs typeface="Calibri" pitchFamily="34" charset="-120"/>
+              </a:rPr>
+              <a:t>統計方式:案例 1 共 35 則留言,可見 20 則,其中 17 則談福利;一則可提及多項。案例 2 可見 11 則,其中 4 則談零食/賀卡。兩篇貼文互動合計:愛心 224、留言 50、收藏 842、分享 52。</a:t>
+            </a:r>
+            <a:endParaRPr lang="en-US" sz="1100" dirty="0"/>
+          </a:p>
+        </p:txBody>
+      </p:sp>
+      <p:sp>
+        <p:nvSpPr>
+          <p:cNvPr id="31" name="Text 29"/>
+          <p:cNvSpPr txBox="1"/>
+          <p:nvPr/>
+        </p:nvSpPr>
+        <p:spPr>
+          <a:xfrm>
+            <a:off x="5760720" y="4297680"/>
+            <a:ext cx="2926080" cy="731520"/>
+          </a:xfrm>
+          <a:prstGeom prst="rect">
+            <a:avLst/>
+          </a:prstGeom>
+          <a:noFill/>
+          <a:ln/>
+        </p:spPr>
+        <p:txBody>
+          <a:bodyPr wrap="square" lIns="0" tIns="0" rIns="0" bIns="0" rtlCol="0" anchor="ctr"/>
+          <a:lstStyle/>
+          <a:p>
+            <a:pPr indent="0" marL="0">
+              <a:buNone/>
+            </a:pPr>
+            <a:r>
+              <a:rPr lang="en-US" sz="1100" dirty="0">
+                <a:solidFill>
+                  <a:srgbClr val="5B6575"/>
+                </a:solidFill>
+                <a:latin typeface="Calibri" pitchFamily="34" charset="0"/>
+                <a:ea typeface="Calibri" pitchFamily="34" charset="-122"/>
+                <a:cs typeface="Calibri" pitchFamily="34" charset="-120"/>
+              </a:rPr>
+              <a:t>資料來源:1111 人力銀行(產經新聞網報導);Dcard 為可見留言之質性觀察,不代表全體畢業生。</a:t>
+            </a:r>
+            <a:endParaRPr lang="en-US" sz="1100" dirty="0"/>
           </a:p>
         </p:txBody>
       </p:sp>
@@ -7213,17 +7699,17 @@
           </p:nvPr>
         </p:nvGraphicFramePr>
         <p:xfrm>
-          <a:off x="457200" y="1005840"/>
-          <a:ext cx="5394960" cy="914400"/>
+          <a:off x="457200" y="1051560"/>
+          <a:ext cx="8229600" cy="914400"/>
         </p:xfrm>
         <a:graphic>
           <a:graphicData uri="http://schemas.openxmlformats.org/drawingml/2006/table">
             <a:tbl>
               <a:tblPr/>
               <a:tblGrid>
-                <a:gridCol w="1280160"/>
-                <a:gridCol w="502920"/>
-                <a:gridCol w="3611880"/>
+                <a:gridCol w="1920240"/>
+                <a:gridCol w="731520"/>
+                <a:gridCol w="5577840"/>
               </a:tblGrid>
               <a:tr h="365760">
                 <a:tc>
@@ -7235,7 +7721,7 @@
                         <a:buNone/>
                       </a:pPr>
                       <a:r>
-                        <a:rPr lang="en-US" sz="1300" b="1" dirty="0">
+                        <a:rPr lang="en-US" sz="1400" b="1" dirty="0">
                           <a:solidFill>
                             <a:srgbClr val="FFFFFF"/>
                           </a:solidFill>
@@ -7245,7 +7731,7 @@
                         </a:rPr>
                         <a:t>Dcard 最在意</a:t>
                       </a:r>
-                      <a:endParaRPr lang="en-US" sz="1300" dirty="0">
+                      <a:endParaRPr lang="en-US" sz="1400" dirty="0">
                         <a:latin typeface="Calibri" charset="0"/>
                         <a:ea typeface="Calibri" charset="0"/>
                         <a:cs typeface="Calibri" charset="0"/>
@@ -7303,7 +7789,7 @@
                         <a:buNone/>
                       </a:pPr>
                       <a:r>
-                        <a:rPr lang="en-US" sz="1300" b="1" dirty="0">
+                        <a:rPr lang="en-US" sz="1400" b="1" dirty="0">
                           <a:solidFill>
                             <a:srgbClr val="FFFFFF"/>
                           </a:solidFill>
@@ -7313,7 +7799,7 @@
                         </a:rPr>
                         <a:t>則數</a:t>
                       </a:r>
-                      <a:endParaRPr lang="en-US" sz="1300" dirty="0">
+                      <a:endParaRPr lang="en-US" sz="1400" dirty="0">
                         <a:latin typeface="Calibri" charset="0"/>
                         <a:ea typeface="Calibri" charset="0"/>
                         <a:cs typeface="Calibri" charset="0"/>
@@ -7371,7 +7857,7 @@
                         <a:buNone/>
                       </a:pPr>
                       <a:r>
-                        <a:rPr lang="en-US" sz="1300" b="1" dirty="0">
+                        <a:rPr lang="en-US" sz="1400" b="1" dirty="0">
                           <a:solidFill>
                             <a:srgbClr val="FFFFFF"/>
                           </a:solidFill>
@@ -7381,7 +7867,7 @@
                         </a:rPr>
                         <a:t>中華汽車(104 公司頁)</a:t>
                       </a:r>
-                      <a:endParaRPr lang="en-US" sz="1300" dirty="0">
+                      <a:endParaRPr lang="en-US" sz="1400" dirty="0">
                         <a:latin typeface="Calibri" charset="0"/>
                         <a:ea typeface="Calibri" charset="0"/>
                         <a:cs typeface="Calibri" charset="0"/>
@@ -7431,7 +7917,7 @@
                   </a:tcPr>
                 </a:tc>
               </a:tr>
-              <a:tr h="640080">
+              <a:tr h="548640">
                 <a:tc>
                   <a:txBody>
                     <a:bodyPr/>
@@ -7441,7 +7927,7 @@
                         <a:buNone/>
                       </a:pPr>
                       <a:r>
-                        <a:rPr lang="en-US" sz="1200" b="1" dirty="0">
+                        <a:rPr lang="en-US" sz="1300" b="1" dirty="0">
                           <a:solidFill>
                             <a:srgbClr val="222222"/>
                           </a:solidFill>
@@ -7451,7 +7937,7 @@
                         </a:rPr>
                         <a:t>薪資/獎金/年終</a:t>
                       </a:r>
-                      <a:endParaRPr lang="en-US" sz="1200" dirty="0">
+                      <a:endParaRPr lang="en-US" sz="1300" dirty="0">
                         <a:latin typeface="Calibri" charset="0"/>
                         <a:ea typeface="Calibri" charset="0"/>
                         <a:cs typeface="Calibri" charset="0"/>
@@ -7509,7 +7995,7 @@
                         <a:buNone/>
                       </a:pPr>
                       <a:r>
-                        <a:rPr lang="en-US" sz="1200" dirty="0">
+                        <a:rPr lang="en-US" sz="1300" dirty="0">
                           <a:solidFill>
                             <a:srgbClr val="222222"/>
                           </a:solidFill>
@@ -7519,7 +8005,7 @@
                         </a:rPr>
                         <a:t>14</a:t>
                       </a:r>
-                      <a:endParaRPr lang="en-US" sz="1200" dirty="0">
+                      <a:endParaRPr lang="en-US" sz="1300" dirty="0">
                         <a:latin typeface="Calibri" charset="0"/>
                         <a:ea typeface="Calibri" charset="0"/>
                         <a:cs typeface="Calibri" charset="0"/>
@@ -7577,7 +8063,7 @@
                         <a:buNone/>
                       </a:pPr>
                       <a:r>
-                        <a:rPr lang="en-US" sz="1200" dirty="0">
+                        <a:rPr lang="en-US" sz="1300" dirty="0">
                           <a:solidFill>
                             <a:srgbClr val="222222"/>
                           </a:solidFill>
@@ -7587,7 +8073,7 @@
                         </a:rPr>
                         <a:t>年終獎金(含中秋、端午),依營運與考績加發獎金及紅利,三節/生日禮券</a:t>
                       </a:r>
-                      <a:endParaRPr lang="en-US" sz="1200" dirty="0">
+                      <a:endParaRPr lang="en-US" sz="1300" dirty="0">
                         <a:latin typeface="Calibri" charset="0"/>
                         <a:ea typeface="Calibri" charset="0"/>
                         <a:cs typeface="Calibri" charset="0"/>
@@ -7637,7 +8123,7 @@
                   </a:tcPr>
                 </a:tc>
               </a:tr>
-              <a:tr h="594360">
+              <a:tr h="548640">
                 <a:tc>
                   <a:txBody>
                     <a:bodyPr/>
@@ -7647,7 +8133,7 @@
                         <a:buNone/>
                       </a:pPr>
                       <a:r>
-                        <a:rPr lang="en-US" sz="1200" b="1" dirty="0">
+                        <a:rPr lang="en-US" sz="1300" b="1" dirty="0">
                           <a:solidFill>
                             <a:srgbClr val="222222"/>
                           </a:solidFill>
@@ -7657,7 +8143,7 @@
                         </a:rPr>
                         <a:t>餐飲/設備</a:t>
                       </a:r>
-                      <a:endParaRPr lang="en-US" sz="1200" dirty="0">
+                      <a:endParaRPr lang="en-US" sz="1300" dirty="0">
                         <a:latin typeface="Calibri" charset="0"/>
                         <a:ea typeface="Calibri" charset="0"/>
                         <a:cs typeface="Calibri" charset="0"/>
@@ -7715,7 +8201,7 @@
                         <a:buNone/>
                       </a:pPr>
                       <a:r>
-                        <a:rPr lang="en-US" sz="1200" dirty="0">
+                        <a:rPr lang="en-US" sz="1300" dirty="0">
                           <a:solidFill>
                             <a:srgbClr val="222222"/>
                           </a:solidFill>
@@ -7725,7 +8211,7 @@
                         </a:rPr>
                         <a:t>5</a:t>
                       </a:r>
-                      <a:endParaRPr lang="en-US" sz="1200" dirty="0">
+                      <a:endParaRPr lang="en-US" sz="1300" dirty="0">
                         <a:latin typeface="Calibri" charset="0"/>
                         <a:ea typeface="Calibri" charset="0"/>
                         <a:cs typeface="Calibri" charset="0"/>
@@ -7783,7 +8269,7 @@
                         <a:buNone/>
                       </a:pPr>
                       <a:r>
-                        <a:rPr lang="en-US" sz="1200" dirty="0">
+                        <a:rPr lang="en-US" sz="1300" dirty="0">
                           <a:solidFill>
                             <a:srgbClr val="222222"/>
                           </a:solidFill>
@@ -7793,7 +8279,7 @@
                         </a:rPr>
                         <a:t>多樣化同仁餐廳(自助餐、麵食、套餐、Cafe'),健身房、球場</a:t>
                       </a:r>
-                      <a:endParaRPr lang="en-US" sz="1200" dirty="0">
+                      <a:endParaRPr lang="en-US" sz="1300" dirty="0">
                         <a:latin typeface="Calibri" charset="0"/>
                         <a:ea typeface="Calibri" charset="0"/>
                         <a:cs typeface="Calibri" charset="0"/>
@@ -7853,7 +8339,7 @@
                         <a:buNone/>
                       </a:pPr>
                       <a:r>
-                        <a:rPr lang="en-US" sz="1200" b="1" dirty="0">
+                        <a:rPr lang="en-US" sz="1300" b="1" dirty="0">
                           <a:solidFill>
                             <a:srgbClr val="222222"/>
                           </a:solidFill>
@@ -7863,7 +8349,7 @@
                         </a:rPr>
                         <a:t>彈性/遠端</a:t>
                       </a:r>
-                      <a:endParaRPr lang="en-US" sz="1200" dirty="0">
+                      <a:endParaRPr lang="en-US" sz="1300" dirty="0">
                         <a:latin typeface="Calibri" charset="0"/>
                         <a:ea typeface="Calibri" charset="0"/>
                         <a:cs typeface="Calibri" charset="0"/>
@@ -7921,7 +8407,7 @@
                         <a:buNone/>
                       </a:pPr>
                       <a:r>
-                        <a:rPr lang="en-US" sz="1200" dirty="0">
+                        <a:rPr lang="en-US" sz="1300" dirty="0">
                           <a:solidFill>
                             <a:srgbClr val="222222"/>
                           </a:solidFill>
@@ -7931,7 +8417,7 @@
                         </a:rPr>
                         <a:t>3</a:t>
                       </a:r>
-                      <a:endParaRPr lang="en-US" sz="1200" dirty="0">
+                      <a:endParaRPr lang="en-US" sz="1300" dirty="0">
                         <a:latin typeface="Calibri" charset="0"/>
                         <a:ea typeface="Calibri" charset="0"/>
                         <a:cs typeface="Calibri" charset="0"/>
@@ -7989,7 +8475,7 @@
                         <a:buNone/>
                       </a:pPr>
                       <a:r>
-                        <a:rPr lang="en-US" sz="1200" dirty="0">
+                        <a:rPr lang="en-US" sz="1300" dirty="0">
                           <a:solidFill>
                             <a:srgbClr val="222222"/>
                           </a:solidFill>
@@ -7999,7 +8485,7 @@
                         </a:rPr>
                         <a:t>彈性上班制度(遠端未見說明)</a:t>
                       </a:r>
-                      <a:endParaRPr lang="en-US" sz="1200" dirty="0">
+                      <a:endParaRPr lang="en-US" sz="1300" dirty="0">
                         <a:latin typeface="Calibri" charset="0"/>
                         <a:ea typeface="Calibri" charset="0"/>
                         <a:cs typeface="Calibri" charset="0"/>
@@ -8049,7 +8535,7 @@
                   </a:tcPr>
                 </a:tc>
               </a:tr>
-              <a:tr h="594360">
+              <a:tr h="548640">
                 <a:tc>
                   <a:txBody>
                     <a:bodyPr/>
@@ -8059,7 +8545,7 @@
                         <a:buNone/>
                       </a:pPr>
                       <a:r>
-                        <a:rPr lang="en-US" sz="1200" b="1" dirty="0">
+                        <a:rPr lang="en-US" sz="1300" b="1" dirty="0">
                           <a:solidFill>
                             <a:srgbClr val="222222"/>
                           </a:solidFill>
@@ -8069,7 +8555,7 @@
                         </a:rPr>
                         <a:t>休假</a:t>
                       </a:r>
-                      <a:endParaRPr lang="en-US" sz="1200" dirty="0">
+                      <a:endParaRPr lang="en-US" sz="1300" dirty="0">
                         <a:latin typeface="Calibri" charset="0"/>
                         <a:ea typeface="Calibri" charset="0"/>
                         <a:cs typeface="Calibri" charset="0"/>
@@ -8127,7 +8613,7 @@
                         <a:buNone/>
                       </a:pPr>
                       <a:r>
-                        <a:rPr lang="en-US" sz="1200" dirty="0">
+                        <a:rPr lang="en-US" sz="1300" dirty="0">
                           <a:solidFill>
                             <a:srgbClr val="222222"/>
                           </a:solidFill>
@@ -8137,7 +8623,7 @@
                         </a:rPr>
                         <a:t>3</a:t>
                       </a:r>
-                      <a:endParaRPr lang="en-US" sz="1200" dirty="0">
+                      <a:endParaRPr lang="en-US" sz="1300" dirty="0">
                         <a:latin typeface="Calibri" charset="0"/>
                         <a:ea typeface="Calibri" charset="0"/>
                         <a:cs typeface="Calibri" charset="0"/>
@@ -8195,7 +8681,7 @@
                         <a:buNone/>
                       </a:pPr>
                       <a:r>
-                        <a:rPr lang="en-US" sz="1200" dirty="0">
+                        <a:rPr lang="en-US" sz="1300" dirty="0">
                           <a:solidFill>
                             <a:srgbClr val="222222"/>
                           </a:solidFill>
@@ -8205,7 +8691,7 @@
                         </a:rPr>
                         <a:t>週休二日,小寒假、小暑假各約 1 週,優於法令的旅遊假</a:t>
                       </a:r>
-                      <a:endParaRPr lang="en-US" sz="1200" dirty="0">
+                      <a:endParaRPr lang="en-US" sz="1300" dirty="0">
                         <a:latin typeface="Calibri" charset="0"/>
                         <a:ea typeface="Calibri" charset="0"/>
                         <a:cs typeface="Calibri" charset="0"/>
@@ -8265,7 +8751,7 @@
                         <a:buNone/>
                       </a:pPr>
                       <a:r>
-                        <a:rPr lang="en-US" sz="1200" b="1" dirty="0">
+                        <a:rPr lang="en-US" sz="1300" b="1" dirty="0">
                           <a:solidFill>
                             <a:srgbClr val="222222"/>
                           </a:solidFill>
@@ -8275,7 +8761,7 @@
                         </a:rPr>
                         <a:t>體檢</a:t>
                       </a:r>
-                      <a:endParaRPr lang="en-US" sz="1200" dirty="0">
+                      <a:endParaRPr lang="en-US" sz="1300" dirty="0">
                         <a:latin typeface="Calibri" charset="0"/>
                         <a:ea typeface="Calibri" charset="0"/>
                         <a:cs typeface="Calibri" charset="0"/>
@@ -8333,7 +8819,7 @@
                         <a:buNone/>
                       </a:pPr>
                       <a:r>
-                        <a:rPr lang="en-US" sz="1200" dirty="0">
+                        <a:rPr lang="en-US" sz="1300" dirty="0">
                           <a:solidFill>
                             <a:srgbClr val="222222"/>
                           </a:solidFill>
@@ -8343,7 +8829,7 @@
                         </a:rPr>
                         <a:t>1</a:t>
                       </a:r>
-                      <a:endParaRPr lang="en-US" sz="1200" dirty="0">
+                      <a:endParaRPr lang="en-US" sz="1300" dirty="0">
                         <a:latin typeface="Calibri" charset="0"/>
                         <a:ea typeface="Calibri" charset="0"/>
                         <a:cs typeface="Calibri" charset="0"/>
@@ -8401,7 +8887,7 @@
                         <a:buNone/>
                       </a:pPr>
                       <a:r>
-                        <a:rPr lang="en-US" sz="1200" dirty="0">
+                        <a:rPr lang="en-US" sz="1300" dirty="0">
                           <a:solidFill>
                             <a:srgbClr val="222222"/>
                           </a:solidFill>
@@ -8411,7 +8897,7 @@
                         </a:rPr>
                         <a:t>醫師駐廠看診、定期健康檢查</a:t>
                       </a:r>
-                      <a:endParaRPr lang="en-US" sz="1200" dirty="0">
+                      <a:endParaRPr lang="en-US" sz="1300" dirty="0">
                         <a:latin typeface="Calibri" charset="0"/>
                         <a:ea typeface="Calibri" charset="0"/>
                         <a:cs typeface="Calibri" charset="0"/>
@@ -8471,7 +8957,7 @@
                         <a:buNone/>
                       </a:pPr>
                       <a:r>
-                        <a:rPr lang="en-US" sz="1200" b="1" dirty="0">
+                        <a:rPr lang="en-US" sz="1300" b="1" dirty="0">
                           <a:solidFill>
                             <a:srgbClr val="222222"/>
                           </a:solidFill>
@@ -8481,7 +8967,7 @@
                         </a:rPr>
                         <a:t>加班費</a:t>
                       </a:r>
-                      <a:endParaRPr lang="en-US" sz="1200" dirty="0">
+                      <a:endParaRPr lang="en-US" sz="1300" dirty="0">
                         <a:latin typeface="Calibri" charset="0"/>
                         <a:ea typeface="Calibri" charset="0"/>
                         <a:cs typeface="Calibri" charset="0"/>
@@ -8539,7 +9025,7 @@
                         <a:buNone/>
                       </a:pPr>
                       <a:r>
-                        <a:rPr lang="en-US" sz="1200" dirty="0">
+                        <a:rPr lang="en-US" sz="1300" dirty="0">
                           <a:solidFill>
                             <a:srgbClr val="222222"/>
                           </a:solidFill>
@@ -8549,7 +9035,7 @@
                         </a:rPr>
                         <a:t>3</a:t>
                       </a:r>
-                      <a:endParaRPr lang="en-US" sz="1200" dirty="0">
+                      <a:endParaRPr lang="en-US" sz="1300" dirty="0">
                         <a:latin typeface="Calibri" charset="0"/>
                         <a:ea typeface="Calibri" charset="0"/>
                         <a:cs typeface="Calibri" charset="0"/>
@@ -8607,7 +9093,7 @@
                         <a:buNone/>
                       </a:pPr>
                       <a:r>
-                        <a:rPr lang="en-US" sz="1200" dirty="0">
+                        <a:rPr lang="en-US" sz="1300" dirty="0">
                           <a:solidFill>
                             <a:srgbClr val="222222"/>
                           </a:solidFill>
@@ -8617,7 +9103,7 @@
                         </a:rPr>
                         <a:t>公司頁未載明,需向人資確認</a:t>
                       </a:r>
-                      <a:endParaRPr lang="en-US" sz="1200" dirty="0">
+                      <a:endParaRPr lang="en-US" sz="1300" dirty="0">
                         <a:latin typeface="Calibri" charset="0"/>
                         <a:ea typeface="Calibri" charset="0"/>
                         <a:cs typeface="Calibri" charset="0"/>
@@ -8671,39 +9157,15 @@
           </a:graphicData>
         </a:graphic>
       </p:graphicFrame>
-      <p:pic>
-        <p:nvPicPr>
-          <p:cNvPr id="6" name="Image 0" descr="img/cmc.jpg">    </p:cNvPr>
-          <p:cNvPicPr>
-            <a:picLocks noChangeAspect="1"/>
-          </p:cNvPicPr>
-          <p:nvPr/>
-        </p:nvPicPr>
-        <p:blipFill>
-          <a:blip r:embed="rId1"/>
-          <a:stretch>
-            <a:fillRect/>
-          </a:stretch>
-        </p:blipFill>
-        <p:spPr>
-          <a:xfrm>
-            <a:off x="6126480" y="1005840"/>
-            <a:ext cx="2286000" cy="3529584"/>
-          </a:xfrm>
-          <a:prstGeom prst="rect">
-            <a:avLst/>
-          </a:prstGeom>
-        </p:spPr>
-      </p:pic>
-      <p:sp>
-        <p:nvSpPr>
-          <p:cNvPr id="7" name="Text 3"/>
+      <p:sp>
+        <p:nvSpPr>
+          <p:cNvPr id="6" name="Text 3"/>
           <p:cNvSpPr txBox="1"/>
           <p:nvPr/>
         </p:nvSpPr>
         <p:spPr>
           <a:xfrm>
-            <a:off x="457200" y="4663440"/>
+            <a:off x="457200" y="4754880"/>
             <a:ext cx="8229600" cy="274320"/>
           </a:xfrm>
           <a:prstGeom prst="rect">

</xml_diff>

<commit_message>
Use plain rectangles and add PDF preview of deck
Co-Authored-By: Claude Sonnet 5.5 <noreply@anthropic.com>
Claude-Session: https://claude.ai/code/session_01YWYmCoF2kfC3GxD29xN2Db
</commit_message>
<xml_diff>
--- a/deliverables/CMC_10月_AB任務簡報.pptx
+++ b/deliverables/CMC_10月_AB任務簡報.pptx
@@ -2125,7 +2125,7 @@
             <a:off x="457200" y="1051560"/>
             <a:ext cx="4023360" cy="3749040"/>
           </a:xfrm>
-          <a:prstGeom prst="roundRect">
+          <a:prstGeom prst="rect">
             <a:avLst>
               <a:gd name="adj" fmla="val 1951"/>
             </a:avLst>
@@ -2297,7 +2297,7 @@
             <a:off x="4663440" y="1051560"/>
             <a:ext cx="4023360" cy="3749040"/>
           </a:xfrm>
-          <a:prstGeom prst="roundRect">
+          <a:prstGeom prst="rect">
             <a:avLst>
               <a:gd name="adj" fmla="val 1951"/>
             </a:avLst>
@@ -2519,7 +2519,7 @@
             <a:off x="457200" y="1051560"/>
             <a:ext cx="4023360" cy="3749040"/>
           </a:xfrm>
-          <a:prstGeom prst="roundRect">
+          <a:prstGeom prst="rect">
             <a:avLst>
               <a:gd name="adj" fmla="val 1951"/>
             </a:avLst>
@@ -2627,7 +2627,7 @@
             <a:off x="4663440" y="1051560"/>
             <a:ext cx="4023360" cy="3749040"/>
           </a:xfrm>
-          <a:prstGeom prst="roundRect">
+          <a:prstGeom prst="rect">
             <a:avLst>
               <a:gd name="adj" fmla="val 1951"/>
             </a:avLst>
@@ -2806,7 +2806,7 @@
             <a:off x="457200" y="1051560"/>
             <a:ext cx="4023360" cy="2194560"/>
           </a:xfrm>
-          <a:prstGeom prst="roundRect">
+          <a:prstGeom prst="rect">
             <a:avLst>
               <a:gd name="adj" fmla="val 3333"/>
             </a:avLst>
@@ -2957,7 +2957,7 @@
             <a:off x="4663440" y="1051560"/>
             <a:ext cx="4023360" cy="2194560"/>
           </a:xfrm>
-          <a:prstGeom prst="roundRect">
+          <a:prstGeom prst="rect">
             <a:avLst>
               <a:gd name="adj" fmla="val 3333"/>
             </a:avLst>
@@ -3316,7 +3316,7 @@
             <a:off x="457200" y="1097280"/>
             <a:ext cx="2103120" cy="548640"/>
           </a:xfrm>
-          <a:prstGeom prst="roundRect">
+          <a:prstGeom prst="rect">
             <a:avLst>
               <a:gd name="adj" fmla="val 10000"/>
             </a:avLst>
@@ -3382,7 +3382,7 @@
             <a:off x="2697480" y="1097280"/>
             <a:ext cx="5989320" cy="548640"/>
           </a:xfrm>
-          <a:prstGeom prst="roundRect">
+          <a:prstGeom prst="rect">
             <a:avLst>
               <a:gd name="adj" fmla="val 10000"/>
             </a:avLst>
@@ -3448,7 +3448,7 @@
             <a:off x="457200" y="1783080"/>
             <a:ext cx="2103120" cy="548640"/>
           </a:xfrm>
-          <a:prstGeom prst="roundRect">
+          <a:prstGeom prst="rect">
             <a:avLst>
               <a:gd name="adj" fmla="val 10000"/>
             </a:avLst>
@@ -3514,7 +3514,7 @@
             <a:off x="2697480" y="1783080"/>
             <a:ext cx="5989320" cy="548640"/>
           </a:xfrm>
-          <a:prstGeom prst="roundRect">
+          <a:prstGeom prst="rect">
             <a:avLst>
               <a:gd name="adj" fmla="val 10000"/>
             </a:avLst>
@@ -3580,7 +3580,7 @@
             <a:off x="457200" y="2468880"/>
             <a:ext cx="2103120" cy="548640"/>
           </a:xfrm>
-          <a:prstGeom prst="roundRect">
+          <a:prstGeom prst="rect">
             <a:avLst>
               <a:gd name="adj" fmla="val 10000"/>
             </a:avLst>
@@ -3646,7 +3646,7 @@
             <a:off x="2697480" y="2468880"/>
             <a:ext cx="5989320" cy="548640"/>
           </a:xfrm>
-          <a:prstGeom prst="roundRect">
+          <a:prstGeom prst="rect">
             <a:avLst>
               <a:gd name="adj" fmla="val 10000"/>
             </a:avLst>
@@ -3712,7 +3712,7 @@
             <a:off x="457200" y="3154680"/>
             <a:ext cx="2103120" cy="548640"/>
           </a:xfrm>
-          <a:prstGeom prst="roundRect">
+          <a:prstGeom prst="rect">
             <a:avLst>
               <a:gd name="adj" fmla="val 10000"/>
             </a:avLst>
@@ -3778,7 +3778,7 @@
             <a:off x="2697480" y="3154680"/>
             <a:ext cx="5989320" cy="548640"/>
           </a:xfrm>
-          <a:prstGeom prst="roundRect">
+          <a:prstGeom prst="rect">
             <a:avLst>
               <a:gd name="adj" fmla="val 10000"/>
             </a:avLst>
@@ -3844,7 +3844,7 @@
             <a:off x="457200" y="3840480"/>
             <a:ext cx="2103120" cy="548640"/>
           </a:xfrm>
-          <a:prstGeom prst="roundRect">
+          <a:prstGeom prst="rect">
             <a:avLst>
               <a:gd name="adj" fmla="val 10000"/>
             </a:avLst>
@@ -3910,7 +3910,7 @@
             <a:off x="2697480" y="3840480"/>
             <a:ext cx="5989320" cy="548640"/>
           </a:xfrm>
-          <a:prstGeom prst="roundRect">
+          <a:prstGeom prst="rect">
             <a:avLst>
               <a:gd name="adj" fmla="val 10000"/>
             </a:avLst>
@@ -4169,7 +4169,7 @@
             <a:off x="3840480" y="1051560"/>
             <a:ext cx="4846320" cy="1600200"/>
           </a:xfrm>
-          <a:prstGeom prst="roundRect">
+          <a:prstGeom prst="rect">
             <a:avLst>
               <a:gd name="adj" fmla="val 4571"/>
             </a:avLst>
@@ -4299,7 +4299,7 @@
             <a:off x="3840480" y="2788920"/>
             <a:ext cx="4846320" cy="2011680"/>
           </a:xfrm>
-          <a:prstGeom prst="roundRect">
+          <a:prstGeom prst="rect">
             <a:avLst>
               <a:gd name="adj" fmla="val 3636"/>
             </a:avLst>
@@ -4580,7 +4580,7 @@
             <a:off x="457200" y="1051560"/>
             <a:ext cx="1783080" cy="1417320"/>
           </a:xfrm>
-          <a:prstGeom prst="roundRect">
+          <a:prstGeom prst="rect">
             <a:avLst>
               <a:gd name="adj" fmla="val 5161"/>
             </a:avLst>
@@ -4685,7 +4685,7 @@
             <a:off x="2377440" y="1051560"/>
             <a:ext cx="1783080" cy="1417320"/>
           </a:xfrm>
-          <a:prstGeom prst="roundRect">
+          <a:prstGeom prst="rect">
             <a:avLst>
               <a:gd name="adj" fmla="val 5161"/>
             </a:avLst>
@@ -4790,7 +4790,7 @@
             <a:off x="4297680" y="1051560"/>
             <a:ext cx="1783080" cy="1417320"/>
           </a:xfrm>
-          <a:prstGeom prst="roundRect">
+          <a:prstGeom prst="rect">
             <a:avLst>
               <a:gd name="adj" fmla="val 5161"/>
             </a:avLst>
@@ -4895,7 +4895,7 @@
             <a:off x="457200" y="2651760"/>
             <a:ext cx="1783080" cy="1417320"/>
           </a:xfrm>
-          <a:prstGeom prst="roundRect">
+          <a:prstGeom prst="rect">
             <a:avLst>
               <a:gd name="adj" fmla="val 5161"/>
             </a:avLst>
@@ -5000,7 +5000,7 @@
             <a:off x="2377440" y="2651760"/>
             <a:ext cx="1783080" cy="1417320"/>
           </a:xfrm>
-          <a:prstGeom prst="roundRect">
+          <a:prstGeom prst="rect">
             <a:avLst>
               <a:gd name="adj" fmla="val 5161"/>
             </a:avLst>
@@ -5105,7 +5105,7 @@
             <a:off x="4297680" y="2651760"/>
             <a:ext cx="1783080" cy="1417320"/>
           </a:xfrm>
-          <a:prstGeom prst="roundRect">
+          <a:prstGeom prst="rect">
             <a:avLst>
               <a:gd name="adj" fmla="val 5161"/>
             </a:avLst>
@@ -5403,7 +5403,7 @@
             <a:off x="457200" y="1051560"/>
             <a:ext cx="4023360" cy="1645920"/>
           </a:xfrm>
-          <a:prstGeom prst="roundRect">
+          <a:prstGeom prst="rect">
             <a:avLst>
               <a:gd name="adj" fmla="val 4444"/>
             </a:avLst>
@@ -5531,7 +5531,7 @@
             <a:off x="4663440" y="1051560"/>
             <a:ext cx="4023360" cy="1645920"/>
           </a:xfrm>
-          <a:prstGeom prst="roundRect">
+          <a:prstGeom prst="rect">
             <a:avLst>
               <a:gd name="adj" fmla="val 4444"/>
             </a:avLst>
@@ -5682,7 +5682,7 @@
             <a:off x="457200" y="2880360"/>
             <a:ext cx="8229600" cy="1920240"/>
           </a:xfrm>
-          <a:prstGeom prst="roundRect">
+          <a:prstGeom prst="rect">
             <a:avLst>
               <a:gd name="adj" fmla="val 3810"/>
             </a:avLst>
@@ -7274,7 +7274,7 @@
             <a:off x="5760720" y="1005840"/>
             <a:ext cx="2926080" cy="3200400"/>
           </a:xfrm>
-          <a:prstGeom prst="roundRect">
+          <a:prstGeom prst="rect">
             <a:avLst>
               <a:gd name="adj" fmla="val 2500"/>
             </a:avLst>

</xml_diff>

<commit_message>
Add polished reflections to deck
Co-Authored-By: Claude Sonnet 5.5 <noreply@anthropic.com>
Claude-Session: https://claude.ai/code/session_01YWYmCoF2kfC3GxD29xN2Db
</commit_message>
<xml_diff>
--- a/deliverables/CMC_10月_AB任務簡報.pptx
+++ b/deliverables/CMC_10月_AB任務簡報.pptx
@@ -2602,15 +2602,35 @@
               <a:buNone/>
             </a:pPr>
             <a:r>
-              <a:rPr lang="en-US" sz="1400" b="1" dirty="0">
-                <a:solidFill>
-                  <a:srgbClr val="C8102E"/>
-                </a:solidFill>
-                <a:latin typeface="Calibri" pitchFamily="34" charset="0"/>
-                <a:ea typeface="Calibri" pitchFamily="34" charset="-122"/>
-                <a:cs typeface="Calibri" pitchFamily="34" charset="-120"/>
-              </a:rPr>
-              <a:t>【待補】</a:t>
+              <a:rPr lang="en-US" sz="1400" dirty="0">
+                <a:solidFill>
+                  <a:srgbClr val="222222"/>
+                </a:solidFill>
+                <a:latin typeface="Calibri" pitchFamily="34" charset="0"/>
+                <a:ea typeface="Calibri" pitchFamily="34" charset="-122"/>
+                <a:cs typeface="Calibri" pitchFamily="34" charset="-120"/>
+              </a:rPr>
+              <a:t>一開始是被「車輛設計數位研習營」這個名稱和想像中的內容吸引,希望透過這支影片讓更多同學知道,原來中華汽車有這樣的活動。</a:t>
+            </a:r>
+            <a:endParaRPr lang="en-US" sz="1400" dirty="0"/>
+          </a:p>
+          <a:p>
+            <a:pPr indent="0" marL="0">
+              <a:spcAft>
+                <a:spcPts val="400"/>
+              </a:spcAft>
+              <a:buNone/>
+            </a:pPr>
+            <a:r>
+              <a:rPr lang="en-US" sz="1400" dirty="0">
+                <a:solidFill>
+                  <a:srgbClr val="222222"/>
+                </a:solidFill>
+                <a:latin typeface="Calibri" pitchFamily="34" charset="0"/>
+                <a:ea typeface="Calibri" pitchFamily="34" charset="-122"/>
+                <a:cs typeface="Calibri" pitchFamily="34" charset="-120"/>
+              </a:rPr>
+              <a:t>實際體驗與拍攝後,我發現活動裡有許多專業術語與設計關鍵概念。期待未來中華汽車能辦一場更偏實作的設計營,不限設計科系,讓對設計、汽車或工業設計較陌生的同學也能快速融入,進一步認識中華汽車。</a:t>
             </a:r>
             <a:endParaRPr lang="en-US" sz="1400" dirty="0"/>
           </a:p>
@@ -2710,15 +2730,35 @@
               <a:buNone/>
             </a:pPr>
             <a:r>
-              <a:rPr lang="en-US" sz="1400" b="1" dirty="0">
-                <a:solidFill>
-                  <a:srgbClr val="C8102E"/>
-                </a:solidFill>
-                <a:latin typeface="Calibri" pitchFamily="34" charset="0"/>
-                <a:ea typeface="Calibri" pitchFamily="34" charset="-122"/>
-                <a:cs typeface="Calibri" pitchFamily="34" charset="-120"/>
-              </a:rPr>
-              <a:t>【待補】</a:t>
+              <a:rPr lang="en-US" sz="1400" dirty="0">
+                <a:solidFill>
+                  <a:srgbClr val="222222"/>
+                </a:solidFill>
+                <a:latin typeface="Calibri" pitchFamily="34" charset="0"/>
+                <a:ea typeface="Calibri" pitchFamily="34" charset="-122"/>
+                <a:cs typeface="Calibri" pitchFamily="34" charset="-120"/>
+              </a:rPr>
+              <a:t>B 任務是從自己也關心的福利出發。觀察兩篇 Dcard 貼文後發現,薪資、獎金與年終仍是最多人在意的項目。</a:t>
+            </a:r>
+            <a:endParaRPr lang="en-US" sz="1400" dirty="0"/>
+          </a:p>
+          <a:p>
+            <a:pPr indent="0" marL="0">
+              <a:spcAft>
+                <a:spcPts val="400"/>
+              </a:spcAft>
+              <a:buNone/>
+            </a:pPr>
+            <a:r>
+              <a:rPr lang="en-US" sz="1400" dirty="0">
+                <a:solidFill>
+                  <a:srgbClr val="222222"/>
+                </a:solidFill>
+                <a:latin typeface="Calibri" pitchFamily="34" charset="0"/>
+                <a:ea typeface="Calibri" pitchFamily="34" charset="-122"/>
+                <a:cs typeface="Calibri" pitchFamily="34" charset="-120"/>
+              </a:rPr>
+              <a:t>我再用對照表檢視中華汽車已有的福利與資源,並結合實際數據與人力銀行的職場調查,整理出適合中華汽車的建議。整體成果與我原本的想像相當接近,過程中也吸收了不少新知。</a:t>
             </a:r>
             <a:endParaRPr lang="en-US" sz="1400" dirty="0"/>
           </a:p>

</xml_diff>

<commit_message>
Simplify deck wording to a more casual tone
Co-Authored-By: Claude Sonnet 5.5 <noreply@anthropic.com>
Claude-Session: https://claude.ai/code/session_01YWYmCoF2kfC3GxD29xN2Db
</commit_message>
<xml_diff>
--- a/deliverables/CMC_10月_AB任務簡報.pptx
+++ b/deliverables/CMC_10月_AB任務簡報.pptx
@@ -2217,7 +2217,7 @@
                 <a:ea typeface="Calibri" pitchFamily="34" charset="-122"/>
                 <a:cs typeface="Calibri" pitchFamily="34" charset="-120"/>
               </a:rPr>
-              <a:t>新鮮人談福利,第一關仍是「錢」:17 則中 14 則提到薪資、獎金或年終</a:t>
+              <a:t>大家聊福利,最在意的還是「錢」:17 則裡有 14 則提到薪水、獎金或年終</a:t>
             </a:r>
             <a:endParaRPr lang="en-US" sz="1300" dirty="0"/>
           </a:p>
@@ -2238,7 +2238,7 @@
                 <a:ea typeface="Calibri" pitchFamily="34" charset="-122"/>
                 <a:cs typeface="Calibri" pitchFamily="34" charset="-120"/>
               </a:rPr>
-              <a:t>其次是日常體驗:餐飲零食、彈性遠端、優於勞基法的休假</a:t>
+              <a:t>再來是日常的舒服感:吃的、零食、彈性上班、比法律規定多的假</a:t>
             </a:r>
             <a:endParaRPr lang="en-US" sz="1300" dirty="0"/>
           </a:p>
@@ -2259,7 +2259,7 @@
                 <a:ea typeface="Calibri" pitchFamily="34" charset="-122"/>
                 <a:cs typeface="Calibri" pitchFamily="34" charset="-120"/>
               </a:rPr>
-              <a:t>小確幸互動不高,卻最容易引發羨慕與分享</a:t>
+              <a:t>小確幸的互動不多,但很容易讓人羨慕</a:t>
             </a:r>
             <a:endParaRPr lang="en-US" sz="1300" dirty="0"/>
           </a:p>
@@ -2280,7 +2280,7 @@
                 <a:ea typeface="Calibri" pitchFamily="34" charset="-122"/>
                 <a:cs typeface="Calibri" pitchFamily="34" charset="-120"/>
               </a:rPr>
-              <a:t>與 1111 調查一致:薪資居首(63.7%),不常態加班(45.1%)次之</a:t>
+              <a:t>1111 的調查也一樣:薪水排第一(63.7%),不用常常加班排第二(45.1%)</a:t>
             </a:r>
             <a:endParaRPr lang="en-US" sz="1300" dirty="0"/>
           </a:p>
@@ -2389,7 +2389,7 @@
                 <a:ea typeface="Calibri" pitchFamily="34" charset="-122"/>
                 <a:cs typeface="Calibri" pitchFamily="34" charset="-120"/>
               </a:rPr>
-              <a:t>薪資與年終是新鮮人最在意的項目,中華汽車已有制度,招募溝通宜優先說清楚</a:t>
+              <a:t>薪水和年終最多人在意,中華汽車本來就有,招募時可以先講清楚</a:t>
             </a:r>
             <a:endParaRPr lang="en-US" sz="1300" dirty="0"/>
           </a:p>
@@ -2410,7 +2410,7 @@
                 <a:ea typeface="Calibri" pitchFamily="34" charset="-122"/>
                 <a:cs typeface="Calibri" pitchFamily="34" charset="-120"/>
               </a:rPr>
-              <a:t>彈性上班、寒暑假、餐廳等福利做成真實員工故事,放到校園與社群</a:t>
+              <a:t>把彈性上班、寒暑假、餐廳這些福利,變成真實員工的小故事,放在校園和社群</a:t>
             </a:r>
             <a:endParaRPr lang="en-US" sz="1300" dirty="0"/>
           </a:p>
@@ -2431,7 +2431,7 @@
                 <a:ea typeface="Calibri" pitchFamily="34" charset="-122"/>
                 <a:cs typeface="Calibri" pitchFamily="34" charset="-120"/>
               </a:rPr>
-              <a:t>研習營等活動可加入福利 Q&amp;A</a:t>
+              <a:t>辦活動時可以加一段「福利問答」</a:t>
             </a:r>
             <a:endParaRPr lang="en-US" sz="1300" dirty="0"/>
           </a:p>
@@ -3131,7 +3131,7 @@
                 <a:ea typeface="Calibri" pitchFamily="34" charset="-122"/>
                 <a:cs typeface="Calibri" pitchFamily="34" charset="-120"/>
               </a:rPr>
-              <a:t>形式:觀察 + 分析 + 數據</a:t>
+              <a:t>形式:看 Dcard 討論 + 整理數據</a:t>
             </a:r>
             <a:endParaRPr lang="en-US" sz="1400" dirty="0"/>
           </a:p>
@@ -4322,7 +4322,7 @@
                 <a:ea typeface="Calibri" pitchFamily="34" charset="-122"/>
                 <a:cs typeface="Calibri" pitchFamily="34" charset="-120"/>
               </a:rPr>
-              <a:t>第一人稱視角,拉近校園與車輛產業</a:t>
+              <a:t>用自己的角度拍,讓同學覺得離車廠沒那麼遠</a:t>
             </a:r>
             <a:endParaRPr lang="en-US" sz="1400" dirty="0"/>
           </a:p>
@@ -4431,7 +4431,7 @@
                 <a:ea typeface="Calibri" pitchFamily="34" charset="-122"/>
                 <a:cs typeface="Calibri" pitchFamily="34" charset="-120"/>
               </a:rPr>
-              <a:t>研習營體驗:AI 內裝設計、CMF、VR、油土模型、四足機器人</a:t>
+              <a:t>當天體驗:AI 設計車內裝、顏色材質展示、VR、油土模型、四足機器人</a:t>
             </a:r>
             <a:endParaRPr lang="en-US" sz="1400" dirty="0"/>
           </a:p>
@@ -4452,7 +4452,7 @@
                 <a:ea typeface="Calibri" pitchFamily="34" charset="-122"/>
                 <a:cs typeface="Calibri" pitchFamily="34" charset="-120"/>
               </a:rPr>
-              <a:t>影片記錄 + 貼文文案,結尾提問「你最想體驗哪一關?」</a:t>
+              <a:t>拍成影片,貼文最後問大家「你最想體驗哪一關?」</a:t>
             </a:r>
             <a:endParaRPr lang="en-US" sz="1400" dirty="0"/>
           </a:p>
@@ -5272,7 +5272,7 @@
                 <a:ea typeface="Calibri" pitchFamily="34" charset="-122"/>
                 <a:cs typeface="Calibri" pitchFamily="34" charset="-120"/>
               </a:rPr>
-              <a:t>互動數 = 按讚 34 + 留言 1 + 分享 1(轉發、儲存皆 0)。平均觀看 3 秒,新增追蹤 0。資料來源:IG Reel 後台洞察。</a:t>
+              <a:t>互動數 = 按讚 34 + 留言 1 + 分享 1。平均每人看 3 秒,沒有新增追蹤。數字來自 IG 後台。</a:t>
             </a:r>
             <a:endParaRPr lang="en-US" sz="1200" dirty="0"/>
           </a:p>
@@ -5705,7 +5705,7 @@
                 <a:ea typeface="Calibri" pitchFamily="34" charset="-122"/>
                 <a:cs typeface="Calibri" pitchFamily="34" charset="-120"/>
               </a:rPr>
-              <a:t>可見留言 31 則納入統計</a:t>
+              <a:t>看得到的 31 則留言都有算</a:t>
             </a:r>
             <a:endParaRPr lang="en-US" sz="1400" dirty="0"/>
           </a:p>
@@ -5814,7 +5814,7 @@
                 <a:ea typeface="Calibri" pitchFamily="34" charset="-122"/>
                 <a:cs typeface="Calibri" pitchFamily="34" charset="-120"/>
               </a:rPr>
-              <a:t>選出與福利、新鮮人職場最相關的兩篇貼文,記錄愛心、留言、收藏、分享數</a:t>
+              <a:t>挑兩篇最多人聊福利、新鮮人工作的貼文,記下愛心、留言、收藏、分享數</a:t>
             </a:r>
             <a:endParaRPr lang="en-US" sz="1400" dirty="0"/>
           </a:p>
@@ -5835,7 +5835,7 @@
                 <a:ea typeface="Calibri" pitchFamily="34" charset="-122"/>
                 <a:cs typeface="Calibri" pitchFamily="34" charset="-120"/>
               </a:rPr>
-              <a:t>逐則閱讀可見留言,依福利類別統計提及次數(一則可提及多項)</a:t>
+              <a:t>把看得到的留言一則一則讀,算每種福利被提到幾次(一則可能提到好幾種)</a:t>
             </a:r>
             <a:endParaRPr lang="en-US" sz="1400" dirty="0"/>
           </a:p>
@@ -5856,7 +5856,7 @@
                 <a:ea typeface="Calibri" pitchFamily="34" charset="-122"/>
                 <a:cs typeface="Calibri" pitchFamily="34" charset="-120"/>
               </a:rPr>
-              <a:t>對照 104 公開的中華汽車福利,找出新鮮人需求與企業現況的落差</a:t>
+              <a:t>再跟 104 上寫的中華汽車福利比一比,看新鮮人想要的公司有沒有</a:t>
             </a:r>
             <a:endParaRPr lang="en-US" sz="1400" dirty="0"/>
           </a:p>
@@ -6165,7 +6165,7 @@
                 <a:ea typeface="Calibri" pitchFamily="34" charset="-122"/>
                 <a:cs typeface="Calibri" pitchFamily="34" charset="-120"/>
               </a:rPr>
-              <a:t>新鮮人請教哪些福利是必問、必備</a:t>
+              <a:t>剛拿到錄取的新鮮人問:哪些福利一定要問?</a:t>
             </a:r>
             <a:endParaRPr lang="en-US" sz="1300" dirty="0"/>
           </a:p>
@@ -6186,7 +6186,7 @@
                 <a:ea typeface="Calibri" pitchFamily="34" charset="-122"/>
                 <a:cs typeface="Calibri" pitchFamily="34" charset="-120"/>
               </a:rPr>
-              <a:t>最高讚留言(246 讚):入職前先確認薪資結構、休假、三節年終、加班費</a:t>
+              <a:t>最多人按讚的留言(246 讚):報到前先問清楚薪水怎麼算、假期、三節年終、加班費</a:t>
             </a:r>
             <a:endParaRPr lang="en-US" sz="1300" dirty="0"/>
           </a:p>
@@ -6386,7 +6386,7 @@
                 <a:ea typeface="Calibri" pitchFamily="34" charset="-122"/>
                 <a:cs typeface="Calibri" pitchFamily="34" charset="-120"/>
               </a:rPr>
-              <a:t>原 PO 最愛:放風日、Work From Anywhere、午休 1.5 小時、生日月福利</a:t>
+              <a:t>發文的人最愛:每月放風日、可以在任何地方上班、午休 1.5 小時、生日月福利</a:t>
             </a:r>
             <a:endParaRPr lang="en-US" sz="1300" dirty="0"/>
           </a:p>
@@ -6407,7 +6407,7 @@
                 <a:ea typeface="Calibri" pitchFamily="34" charset="-122"/>
                 <a:cs typeface="Calibri" pitchFamily="34" charset="-120"/>
               </a:rPr>
-              <a:t>留言多羨慕零食、賀卡、蛋糕等小確幸</a:t>
+              <a:t>留言很多人羨慕有零食、賀卡、蛋糕這些小確幸</a:t>
             </a:r>
             <a:endParaRPr lang="en-US" sz="1300" dirty="0"/>
           </a:p>
@@ -6576,7 +6576,7 @@
                 <a:ea typeface="Calibri" pitchFamily="34" charset="-122"/>
                 <a:cs typeface="Calibri" pitchFamily="34" charset="-120"/>
               </a:rPr>
-              <a:t>Dcard 案例 1 留言提及的福利(則,n=17)</a:t>
+              <a:t>Dcard 案例 1 留言裡,大家提到的福利(17 則留言)</a:t>
             </a:r>
             <a:endParaRPr lang="en-US" sz="1400" dirty="0"/>
           </a:p>
@@ -7363,7 +7363,7 @@
                 <a:ea typeface="Calibri" pitchFamily="34" charset="-122"/>
                 <a:cs typeface="Calibri" pitchFamily="34" charset="-120"/>
               </a:rPr>
-              <a:t>外部對照:1111 人力銀行</a:t>
+              <a:t>另一份調查:1111 人力銀行</a:t>
             </a:r>
             <a:endParaRPr lang="en-US" sz="1600" dirty="0"/>
           </a:p>
@@ -7405,7 +7405,7 @@
                 <a:ea typeface="Calibri" pitchFamily="34" charset="-122"/>
                 <a:cs typeface="Calibri" pitchFamily="34" charset="-120"/>
               </a:rPr>
-              <a:t>2025 新鮮人求職意向調查</a:t>
+              <a:t>2025 新鮮人找工作調查</a:t>
             </a:r>
             <a:endParaRPr lang="en-US" sz="1300" dirty="0"/>
           </a:p>
@@ -7426,7 +7426,7 @@
                 <a:ea typeface="Calibri" pitchFamily="34" charset="-122"/>
                 <a:cs typeface="Calibri" pitchFamily="34" charset="-120"/>
               </a:rPr>
-              <a:t>薪資符合行情 63.7%</a:t>
+              <a:t>薪水符合行情 63.7%</a:t>
             </a:r>
             <a:endParaRPr lang="en-US" sz="1300" dirty="0"/>
           </a:p>
@@ -7549,7 +7549,7 @@
                 <a:ea typeface="Calibri" pitchFamily="34" charset="-122"/>
                 <a:cs typeface="Calibri" pitchFamily="34" charset="-120"/>
               </a:rPr>
-              <a:t>統計方式:案例 1 共 35 則留言,可見 20 則,其中 17 則談福利;一則可提及多項。案例 2 可見 11 則,其中 4 則談零食/賀卡。兩篇貼文互動合計:愛心 224、留言 50、收藏 842、分享 52。</a:t>
+              <a:t>怎麼算的:案例 1 有 35 則留言,我看得到 20 則,其中 17 則在聊福利。案例 2 看得到 11 則,有 4 則在聊零食、賀卡。兩篇加起來:愛心 224、留言 50、收藏 842、分享 52。</a:t>
             </a:r>
             <a:endParaRPr lang="en-US" sz="1100" dirty="0"/>
           </a:p>
@@ -7588,7 +7588,7 @@
                 <a:ea typeface="Calibri" pitchFamily="34" charset="-122"/>
                 <a:cs typeface="Calibri" pitchFamily="34" charset="-120"/>
               </a:rPr>
-              <a:t>資料來源:1111 人力銀行(產經新聞網報導);Dcard 為可見留言之質性觀察,不代表全體畢業生。</a:t>
+              <a:t>資料來源:1111 人力銀行(產經新聞網報導)。Dcard 只看了兩篇貼文的留言,不代表所有畢業生。</a:t>
             </a:r>
             <a:endParaRPr lang="en-US" sz="1100" dirty="0"/>
           </a:p>

</xml_diff>